<commit_message>
Fix Thai font fallback in the deck and add the PDF export
- Set the complex-script typeface so Thai renders in Tahoma like the Latin
  text instead of PowerPoint's fallback font.
- Crop the three importance charts on slide 8 to the top features so the
  labels are readable.
- Hanging indent on bullet paragraphs; rebalanced slide 5.
- scripts/export_pdf.py exports the deck to PDF via installed PowerPoint.

Co-Authored-By: Claude Opus 5 <noreply@anthropic.com>
</commit_message>
<xml_diff>
--- a/slides/Hotel-Booking-Cancellation-Prediction.pptx
+++ b/slides/Hotel-Booking-Cancellation-Prediction.pptx
@@ -4724,6 +4724,8 @@
                   <a:srgbClr val="E0A458"/>
                 </a:solidFill>
                 <a:latin typeface="Tahoma"/>
+                <a:ea typeface="Tahoma"/>
+                <a:cs typeface="Tahoma"/>
               </a:rPr>
               <a:t>โครงงานรายวิชา Machine Learning</a:t>
             </a:r>
@@ -4766,6 +4768,8 @@
                   <a:srgbClr val="FFFFFF"/>
                 </a:solidFill>
                 <a:latin typeface="Tahoma"/>
+                <a:ea typeface="Tahoma"/>
+                <a:cs typeface="Tahoma"/>
               </a:rPr>
               <a:t>Hotel Booking
 Cancellation Prediction</a:t>
@@ -4809,6 +4813,8 @@
                   <a:srgbClr val="C7D2DE"/>
                 </a:solidFill>
                 <a:latin typeface="Tahoma"/>
+                <a:ea typeface="Tahoma"/>
+                <a:cs typeface="Tahoma"/>
               </a:rPr>
               <a:t>ทำนายความเสี่ยงที่การจองโรงแรมจะถูกยกเลิก ด้วยข้อมูลการจองจริง 119,208 รายการ</a:t>
             </a:r>
@@ -4851,6 +4857,8 @@
                   <a:srgbClr val="E4EAF1"/>
                 </a:solidFill>
                 <a:latin typeface="Tahoma"/>
+                <a:ea typeface="Tahoma"/>
+                <a:cs typeface="Tahoma"/>
               </a:rPr>
               <a:t>นายชัยพร ศรีพราย  66114540168</a:t>
             </a:r>
@@ -4870,6 +4878,8 @@
                   <a:srgbClr val="E4EAF1"/>
                 </a:solidFill>
                 <a:latin typeface="Tahoma"/>
+                <a:ea typeface="Tahoma"/>
+                <a:cs typeface="Tahoma"/>
               </a:rPr>
               <a:t>นางสาวกวิณชฎา มีศรี  67114540015</a:t>
             </a:r>
@@ -4889,6 +4899,8 @@
                   <a:srgbClr val="E4EAF1"/>
                 </a:solidFill>
                 <a:latin typeface="Tahoma"/>
+                <a:ea typeface="Tahoma"/>
+                <a:cs typeface="Tahoma"/>
               </a:rPr>
               <a:t>นายธนากร ไชยรัตน์  67114540244</a:t>
             </a:r>
@@ -4931,6 +4943,8 @@
                   <a:srgbClr val="E4EAF1"/>
                 </a:solidFill>
                 <a:latin typeface="Tahoma"/>
+                <a:ea typeface="Tahoma"/>
+                <a:cs typeface="Tahoma"/>
               </a:rPr>
               <a:t>นายรัชชานนท์ รื่นจิตต์  67114540446</a:t>
             </a:r>
@@ -4950,6 +4964,8 @@
                   <a:srgbClr val="E4EAF1"/>
                 </a:solidFill>
                 <a:latin typeface="Tahoma"/>
+                <a:ea typeface="Tahoma"/>
+                <a:cs typeface="Tahoma"/>
               </a:rPr>
               <a:t>นายราชภัฏ บุญรอด  67114540455</a:t>
             </a:r>
@@ -5038,6 +5054,8 @@
                   <a:srgbClr val="E0A458"/>
                 </a:solidFill>
                 <a:latin typeface="Tahoma"/>
+                <a:ea typeface="Tahoma"/>
+                <a:cs typeface="Tahoma"/>
               </a:rPr>
               <a:t>18</a:t>
             </a:r>
@@ -5080,6 +5098,8 @@
                   <a:srgbClr val="6B7A8C"/>
                 </a:solidFill>
                 <a:latin typeface="Tahoma"/>
+                <a:ea typeface="Tahoma"/>
+                <a:cs typeface="Tahoma"/>
               </a:rPr>
               <a:t>features ที่ใช้เทรน</a:t>
             </a:r>
@@ -5168,6 +5188,8 @@
                   <a:srgbClr val="E0A458"/>
                 </a:solidFill>
                 <a:latin typeface="Tahoma"/>
+                <a:ea typeface="Tahoma"/>
+                <a:cs typeface="Tahoma"/>
               </a:rPr>
               <a:t>0.847</a:t>
             </a:r>
@@ -5210,6 +5232,8 @@
                   <a:srgbClr val="6B7A8C"/>
                 </a:solidFill>
                 <a:latin typeface="Tahoma"/>
+                <a:ea typeface="Tahoma"/>
+                <a:cs typeface="Tahoma"/>
               </a:rPr>
               <a:t>F1-score บนชุดทดสอบ</a:t>
             </a:r>
@@ -5325,6 +5349,8 @@
                   <a:srgbClr val="0F2038"/>
                 </a:solidFill>
                 <a:latin typeface="Tahoma"/>
+                <a:ea typeface="Tahoma"/>
+                <a:cs typeface="Tahoma"/>
               </a:rPr>
               <a:t>10</a:t>
             </a:r>
@@ -5367,6 +5393,8 @@
                   <a:srgbClr val="E0A458"/>
                 </a:solidFill>
                 <a:latin typeface="Tahoma"/>
+                <a:ea typeface="Tahoma"/>
+                <a:cs typeface="Tahoma"/>
               </a:rPr>
               <a:t>MODEL DEVELOPMENT</a:t>
             </a:r>
@@ -5409,6 +5437,8 @@
                   <a:srgbClr val="0F2038"/>
                 </a:solidFill>
                 <a:latin typeface="Tahoma"/>
+                <a:ea typeface="Tahoma"/>
+                <a:cs typeface="Tahoma"/>
               </a:rPr>
               <a:t>Random Forest นำตั้งแต่ก่อน Tuning (F1 = 0.842)</a:t>
             </a:r>
@@ -5519,6 +5549,8 @@
                   <a:srgbClr val="FFFFFF"/>
                 </a:solidFill>
                 <a:latin typeface="Tahoma"/>
+                <a:ea typeface="Tahoma"/>
+                <a:cs typeface="Tahoma"/>
               </a:rPr>
               <a:t>โมเดล (ค่า default)</a:t>
             </a:r>
@@ -5561,6 +5593,8 @@
                   <a:srgbClr val="FFFFFF"/>
                 </a:solidFill>
                 <a:latin typeface="Tahoma"/>
+                <a:ea typeface="Tahoma"/>
+                <a:cs typeface="Tahoma"/>
               </a:rPr>
               <a:t>F1 (CV)</a:t>
             </a:r>
@@ -5603,6 +5637,8 @@
                   <a:srgbClr val="FFFFFF"/>
                 </a:solidFill>
                 <a:latin typeface="Tahoma"/>
+                <a:ea typeface="Tahoma"/>
+                <a:cs typeface="Tahoma"/>
               </a:rPr>
               <a:t>ช่องว่าง Train–CV</a:t>
             </a:r>
@@ -5645,6 +5681,8 @@
                   <a:srgbClr val="1F2C3D"/>
                 </a:solidFill>
                 <a:latin typeface="Tahoma"/>
+                <a:ea typeface="Tahoma"/>
+                <a:cs typeface="Tahoma"/>
               </a:rPr>
               <a:t>Dummy (baseline)</a:t>
             </a:r>
@@ -5687,6 +5725,8 @@
                   <a:srgbClr val="1F2C3D"/>
                 </a:solidFill>
                 <a:latin typeface="Tahoma"/>
+                <a:ea typeface="Tahoma"/>
+                <a:cs typeface="Tahoma"/>
               </a:rPr>
               <a:t>0.000</a:t>
             </a:r>
@@ -5729,6 +5769,8 @@
                   <a:srgbClr val="1F2C3D"/>
                 </a:solidFill>
                 <a:latin typeface="Tahoma"/>
+                <a:ea typeface="Tahoma"/>
+                <a:cs typeface="Tahoma"/>
               </a:rPr>
               <a:t>0.000</a:t>
             </a:r>
@@ -5815,6 +5857,8 @@
                   <a:srgbClr val="1F2C3D"/>
                 </a:solidFill>
                 <a:latin typeface="Tahoma"/>
+                <a:ea typeface="Tahoma"/>
+                <a:cs typeface="Tahoma"/>
               </a:rPr>
               <a:t>Logistic Regression</a:t>
             </a:r>
@@ -5857,6 +5901,8 @@
                   <a:srgbClr val="1F2C3D"/>
                 </a:solidFill>
                 <a:latin typeface="Tahoma"/>
+                <a:ea typeface="Tahoma"/>
+                <a:cs typeface="Tahoma"/>
               </a:rPr>
               <a:t>0.763</a:t>
             </a:r>
@@ -5899,6 +5945,8 @@
                   <a:srgbClr val="1F2C3D"/>
                 </a:solidFill>
                 <a:latin typeface="Tahoma"/>
+                <a:ea typeface="Tahoma"/>
+                <a:cs typeface="Tahoma"/>
               </a:rPr>
               <a:t>0.001</a:t>
             </a:r>
@@ -5941,6 +5989,8 @@
                   <a:srgbClr val="1F2C3D"/>
                 </a:solidFill>
                 <a:latin typeface="Tahoma"/>
+                <a:ea typeface="Tahoma"/>
+                <a:cs typeface="Tahoma"/>
               </a:rPr>
               <a:t>Decision Tree</a:t>
             </a:r>
@@ -5983,6 +6033,8 @@
                   <a:srgbClr val="1F2C3D"/>
                 </a:solidFill>
                 <a:latin typeface="Tahoma"/>
+                <a:ea typeface="Tahoma"/>
+                <a:cs typeface="Tahoma"/>
               </a:rPr>
               <a:t>0.791</a:t>
             </a:r>
@@ -6025,6 +6077,8 @@
                   <a:srgbClr val="0F2038"/>
                 </a:solidFill>
                 <a:latin typeface="Tahoma"/>
+                <a:ea typeface="Tahoma"/>
+                <a:cs typeface="Tahoma"/>
               </a:rPr>
               <a:t>0.203</a:t>
             </a:r>
@@ -6111,6 +6165,8 @@
                   <a:srgbClr val="0F2038"/>
                 </a:solidFill>
                 <a:latin typeface="Tahoma"/>
+                <a:ea typeface="Tahoma"/>
+                <a:cs typeface="Tahoma"/>
               </a:rPr>
               <a:t>Random Forest</a:t>
             </a:r>
@@ -6153,6 +6209,8 @@
                   <a:srgbClr val="0F2038"/>
                 </a:solidFill>
                 <a:latin typeface="Tahoma"/>
+                <a:ea typeface="Tahoma"/>
+                <a:cs typeface="Tahoma"/>
               </a:rPr>
               <a:t>0.842</a:t>
             </a:r>
@@ -6195,6 +6253,8 @@
                   <a:srgbClr val="1F2C3D"/>
                 </a:solidFill>
                 <a:latin typeface="Tahoma"/>
+                <a:ea typeface="Tahoma"/>
+                <a:cs typeface="Tahoma"/>
               </a:rPr>
               <a:t>0.152</a:t>
             </a:r>
@@ -6237,6 +6297,8 @@
                   <a:srgbClr val="1F2C3D"/>
                 </a:solidFill>
                 <a:latin typeface="Tahoma"/>
+                <a:ea typeface="Tahoma"/>
+                <a:cs typeface="Tahoma"/>
               </a:rPr>
               <a:t>HistGradientBoosting</a:t>
             </a:r>
@@ -6279,6 +6341,8 @@
                   <a:srgbClr val="1F2C3D"/>
                 </a:solidFill>
                 <a:latin typeface="Tahoma"/>
+                <a:ea typeface="Tahoma"/>
+                <a:cs typeface="Tahoma"/>
               </a:rPr>
               <a:t>0.811</a:t>
             </a:r>
@@ -6321,6 +6385,8 @@
                   <a:srgbClr val="1F2C3D"/>
                 </a:solidFill>
                 <a:latin typeface="Tahoma"/>
+                <a:ea typeface="Tahoma"/>
+                <a:cs typeface="Tahoma"/>
               </a:rPr>
               <a:t>0.011</a:t>
             </a:r>
@@ -6409,6 +6475,8 @@
                   <a:srgbClr val="B33A3A"/>
                 </a:solidFill>
                 <a:latin typeface="Tahoma"/>
+                <a:ea typeface="Tahoma"/>
+                <a:cs typeface="Tahoma"/>
               </a:rPr>
               <a:t>Decision Tree overfit ชัดเจน </a:t>
             </a:r>
@@ -6418,6 +6486,8 @@
                   <a:srgbClr val="0F2038"/>
                 </a:solidFill>
                 <a:latin typeface="Tahoma"/>
+                <a:ea typeface="Tahoma"/>
+                <a:cs typeface="Tahoma"/>
               </a:rPr>
               <a:t>— ช่องว่าง train–CV ถึง 0.203</a:t>
             </a:r>
@@ -6437,6 +6507,8 @@
                   <a:srgbClr val="1F2C3D"/>
                 </a:solidFill>
                 <a:latin typeface="Tahoma"/>
+                <a:ea typeface="Tahoma"/>
+                <a:cs typeface="Tahoma"/>
               </a:rPr>
               <a:t>Random Forest แก้ปัญหานี้ด้วยการรวมหลายต้นเข้าด้วยกัน</a:t>
             </a:r>
@@ -6479,6 +6551,8 @@
                   <a:srgbClr val="6B7A8C"/>
                 </a:solidFill>
                 <a:latin typeface="Tahoma"/>
+                <a:ea typeface="Tahoma"/>
+                <a:cs typeface="Tahoma"/>
               </a:rPr>
               <a:t>ทุกโมเดลใช้ Stratified 5-Fold Cross-Validation บน train set เดียวกัน และใช้ Pipeline ชุดเดียวกัน</a:t>
             </a:r>
@@ -6594,6 +6668,8 @@
                   <a:srgbClr val="0F2038"/>
                 </a:solidFill>
                 <a:latin typeface="Tahoma"/>
+                <a:ea typeface="Tahoma"/>
+                <a:cs typeface="Tahoma"/>
               </a:rPr>
               <a:t>11</a:t>
             </a:r>
@@ -6636,6 +6712,8 @@
                   <a:srgbClr val="E0A458"/>
                 </a:solidFill>
                 <a:latin typeface="Tahoma"/>
+                <a:ea typeface="Tahoma"/>
+                <a:cs typeface="Tahoma"/>
               </a:rPr>
               <a:t>METRICS</a:t>
             </a:r>
@@ -6678,6 +6756,8 @@
                   <a:srgbClr val="0F2038"/>
                 </a:solidFill>
                 <a:latin typeface="Tahoma"/>
+                <a:ea typeface="Tahoma"/>
+                <a:cs typeface="Tahoma"/>
               </a:rPr>
               <a:t>Accuracy หลอกตา — Dummy ได้ 62.9% แต่ F1 = 0</a:t>
             </a:r>
@@ -6766,6 +6846,8 @@
                   <a:srgbClr val="B33A3A"/>
                 </a:solidFill>
                 <a:latin typeface="Tahoma"/>
+                <a:ea typeface="Tahoma"/>
+                <a:cs typeface="Tahoma"/>
               </a:rPr>
               <a:t>False Negative</a:t>
             </a:r>
@@ -6785,6 +6867,8 @@
                   <a:srgbClr val="1F2C3D"/>
                 </a:solidFill>
                 <a:latin typeface="Tahoma"/>
+                <a:ea typeface="Tahoma"/>
+                <a:cs typeface="Tahoma"/>
               </a:rPr>
               <a:t>ทำนายว่าไม่ยกเลิก → แต่ยกเลิกจริง</a:t>
             </a:r>
@@ -6804,6 +6888,8 @@
                   <a:srgbClr val="0F2038"/>
                 </a:solidFill>
                 <a:latin typeface="Tahoma"/>
+                <a:ea typeface="Tahoma"/>
+                <a:cs typeface="Tahoma"/>
               </a:rPr>
               <a:t>ห้องว่าง ขายต่อไม่ทัน = รายได้หาย</a:t>
             </a:r>
@@ -6892,6 +6978,8 @@
                   <a:srgbClr val="B33A3A"/>
                 </a:solidFill>
                 <a:latin typeface="Tahoma"/>
+                <a:ea typeface="Tahoma"/>
+                <a:cs typeface="Tahoma"/>
               </a:rPr>
               <a:t>False Positive</a:t>
             </a:r>
@@ -6911,6 +6999,8 @@
                   <a:srgbClr val="1F2C3D"/>
                 </a:solidFill>
                 <a:latin typeface="Tahoma"/>
+                <a:ea typeface="Tahoma"/>
+                <a:cs typeface="Tahoma"/>
               </a:rPr>
               <a:t>ทำนายว่ายกเลิก → แต่ลูกค้ามาจริง</a:t>
             </a:r>
@@ -6930,6 +7020,8 @@
                   <a:srgbClr val="0F2038"/>
                 </a:solidFill>
                 <a:latin typeface="Tahoma"/>
+                <a:ea typeface="Tahoma"/>
+                <a:cs typeface="Tahoma"/>
               </a:rPr>
               <a:t>ถ้าเผื่อ Overbooking ไว้ = ห้องไม่พอ เสียชื่อเสียง</a:t>
             </a:r>
@@ -6972,6 +7064,8 @@
                   <a:srgbClr val="0F2038"/>
                 </a:solidFill>
                 <a:latin typeface="Tahoma"/>
+                <a:ea typeface="Tahoma"/>
+                <a:cs typeface="Tahoma"/>
               </a:rPr>
               <a:t>ทั้งสองแบบมีต้นทุนสูงพอกัน จึงเลือก F1-score เป็นตัวชี้วัดหลัก</a:t>
             </a:r>
@@ -7060,6 +7154,8 @@
                   <a:srgbClr val="E0A458"/>
                 </a:solidFill>
                 <a:latin typeface="Tahoma"/>
+                <a:ea typeface="Tahoma"/>
+                <a:cs typeface="Tahoma"/>
               </a:rPr>
               <a:t>F1-score</a:t>
             </a:r>
@@ -7102,6 +7198,8 @@
                   <a:srgbClr val="6B7A8C"/>
                 </a:solidFill>
                 <a:latin typeface="Tahoma"/>
+                <a:ea typeface="Tahoma"/>
+                <a:cs typeface="Tahoma"/>
               </a:rPr>
               <a:t>ตัวชี้วัดหลัก — สมดุล Precision กับ Recall</a:t>
             </a:r>
@@ -7190,6 +7288,8 @@
                   <a:srgbClr val="0F2038"/>
                 </a:solidFill>
                 <a:latin typeface="Tahoma"/>
+                <a:ea typeface="Tahoma"/>
+                <a:cs typeface="Tahoma"/>
               </a:rPr>
               <a:t>ROC-AUC</a:t>
             </a:r>
@@ -7232,6 +7332,8 @@
                   <a:srgbClr val="6B7A8C"/>
                 </a:solidFill>
                 <a:latin typeface="Tahoma"/>
+                <a:ea typeface="Tahoma"/>
+                <a:cs typeface="Tahoma"/>
               </a:rPr>
               <a:t>ความสามารถแยกคลาสโดยไม่ขึ้นกับ threshold</a:t>
             </a:r>
@@ -7320,6 +7422,8 @@
                   <a:srgbClr val="0F2038"/>
                 </a:solidFill>
                 <a:latin typeface="Tahoma"/>
+                <a:ea typeface="Tahoma"/>
+                <a:cs typeface="Tahoma"/>
               </a:rPr>
               <a:t>PR-AUC</a:t>
             </a:r>
@@ -7362,6 +7466,8 @@
                   <a:srgbClr val="6B7A8C"/>
                 </a:solidFill>
                 <a:latin typeface="Tahoma"/>
+                <a:ea typeface="Tahoma"/>
+                <a:cs typeface="Tahoma"/>
               </a:rPr>
               <a:t>เหมาะกับข้อมูลไม่สมดุลมากกว่า ROC-AUC</a:t>
             </a:r>
@@ -7450,6 +7556,8 @@
                   <a:srgbClr val="0F2038"/>
                 </a:solidFill>
                 <a:latin typeface="Tahoma"/>
+                <a:ea typeface="Tahoma"/>
+                <a:cs typeface="Tahoma"/>
               </a:rPr>
               <a:t>Confusion
 Matrix</a:t>
@@ -7493,6 +7601,8 @@
                   <a:srgbClr val="6B7A8C"/>
                 </a:solidFill>
                 <a:latin typeface="Tahoma"/>
+                <a:ea typeface="Tahoma"/>
+                <a:cs typeface="Tahoma"/>
               </a:rPr>
               <a:t>เห็นจำนวน error แต่ละแบบจริง</a:t>
             </a:r>
@@ -7535,6 +7645,8 @@
                   <a:srgbClr val="6B7A8C"/>
                 </a:solidFill>
                 <a:latin typeface="Tahoma"/>
+                <a:ea typeface="Tahoma"/>
+                <a:cs typeface="Tahoma"/>
               </a:rPr>
               <a:t>Baseline: Dummy Classifier ทายคลาสที่พบบ่อยที่สุดเสมอ ได้ Accuracy 62.9% แต่ F1 = 0 คือจับคนที่จะยกเลิกไม่ได้เลยแม้แต่รายเดียว</a:t>
             </a:r>
@@ -7650,6 +7762,8 @@
                   <a:srgbClr val="0F2038"/>
                 </a:solidFill>
                 <a:latin typeface="Tahoma"/>
+                <a:ea typeface="Tahoma"/>
+                <a:cs typeface="Tahoma"/>
               </a:rPr>
               <a:t>12</a:t>
             </a:r>
@@ -7692,6 +7806,8 @@
                   <a:srgbClr val="E0A458"/>
                 </a:solidFill>
                 <a:latin typeface="Tahoma"/>
+                <a:ea typeface="Tahoma"/>
+                <a:cs typeface="Tahoma"/>
               </a:rPr>
               <a:t>HYPERPARAMETER TUNING</a:t>
             </a:r>
@@ -7734,6 +7850,8 @@
                   <a:srgbClr val="0F2038"/>
                 </a:solidFill>
                 <a:latin typeface="Tahoma"/>
+                <a:ea typeface="Tahoma"/>
+                <a:cs typeface="Tahoma"/>
               </a:rPr>
               <a:t>Tuning ช่วยลด Overfitting มากกว่าจะเพิ่มคะแนน</a:t>
             </a:r>
@@ -7820,6 +7938,8 @@
                   <a:srgbClr val="FFFFFF"/>
                 </a:solidFill>
                 <a:latin typeface="Tahoma"/>
+                <a:ea typeface="Tahoma"/>
+                <a:cs typeface="Tahoma"/>
               </a:rPr>
               <a:t>โมเดล</a:t>
             </a:r>
@@ -7862,6 +7982,8 @@
                   <a:srgbClr val="FFFFFF"/>
                 </a:solidFill>
                 <a:latin typeface="Tahoma"/>
+                <a:ea typeface="Tahoma"/>
+                <a:cs typeface="Tahoma"/>
               </a:rPr>
               <a:t>F1 ก่อน</a:t>
             </a:r>
@@ -7904,6 +8026,8 @@
                   <a:srgbClr val="FFFFFF"/>
                 </a:solidFill>
                 <a:latin typeface="Tahoma"/>
+                <a:ea typeface="Tahoma"/>
+                <a:cs typeface="Tahoma"/>
               </a:rPr>
               <a:t>F1 หลัง</a:t>
             </a:r>
@@ -7946,6 +8070,8 @@
                   <a:srgbClr val="FFFFFF"/>
                 </a:solidFill>
                 <a:latin typeface="Tahoma"/>
+                <a:ea typeface="Tahoma"/>
+                <a:cs typeface="Tahoma"/>
               </a:rPr>
               <a:t>ช่องว่าง Train–CV</a:t>
             </a:r>
@@ -7988,6 +8114,8 @@
                   <a:srgbClr val="1F2C3D"/>
                 </a:solidFill>
                 <a:latin typeface="Tahoma"/>
+                <a:ea typeface="Tahoma"/>
+                <a:cs typeface="Tahoma"/>
               </a:rPr>
               <a:t>Logistic Regression</a:t>
             </a:r>
@@ -8030,6 +8158,8 @@
                   <a:srgbClr val="1F2C3D"/>
                 </a:solidFill>
                 <a:latin typeface="Tahoma"/>
+                <a:ea typeface="Tahoma"/>
+                <a:cs typeface="Tahoma"/>
               </a:rPr>
               <a:t>0.7629</a:t>
             </a:r>
@@ -8072,6 +8202,8 @@
                   <a:srgbClr val="0F2038"/>
                 </a:solidFill>
                 <a:latin typeface="Tahoma"/>
+                <a:ea typeface="Tahoma"/>
+                <a:cs typeface="Tahoma"/>
               </a:rPr>
               <a:t>0.7784</a:t>
             </a:r>
@@ -8114,6 +8246,8 @@
                   <a:srgbClr val="1F2C3D"/>
                 </a:solidFill>
                 <a:latin typeface="Tahoma"/>
+                <a:ea typeface="Tahoma"/>
+                <a:cs typeface="Tahoma"/>
               </a:rPr>
               <a:t>0.001 → 0.002</a:t>
             </a:r>
@@ -8200,6 +8334,8 @@
                   <a:srgbClr val="0F2038"/>
                 </a:solidFill>
                 <a:latin typeface="Tahoma"/>
+                <a:ea typeface="Tahoma"/>
+                <a:cs typeface="Tahoma"/>
               </a:rPr>
               <a:t>Random Forest</a:t>
             </a:r>
@@ -8242,6 +8378,8 @@
                   <a:srgbClr val="1F2C3D"/>
                 </a:solidFill>
                 <a:latin typeface="Tahoma"/>
+                <a:ea typeface="Tahoma"/>
+                <a:cs typeface="Tahoma"/>
               </a:rPr>
               <a:t>0.8422</a:t>
             </a:r>
@@ -8284,6 +8422,8 @@
                   <a:srgbClr val="1F2C3D"/>
                 </a:solidFill>
                 <a:latin typeface="Tahoma"/>
+                <a:ea typeface="Tahoma"/>
+                <a:cs typeface="Tahoma"/>
               </a:rPr>
               <a:t>0.8419</a:t>
             </a:r>
@@ -8326,6 +8466,8 @@
                   <a:srgbClr val="0F2038"/>
                 </a:solidFill>
                 <a:latin typeface="Tahoma"/>
+                <a:ea typeface="Tahoma"/>
+                <a:cs typeface="Tahoma"/>
               </a:rPr>
               <a:t>0.152 → 0.122</a:t>
             </a:r>
@@ -8368,6 +8510,8 @@
                   <a:srgbClr val="1F2C3D"/>
                 </a:solidFill>
                 <a:latin typeface="Tahoma"/>
+                <a:ea typeface="Tahoma"/>
+                <a:cs typeface="Tahoma"/>
               </a:rPr>
               <a:t>HistGradientBoosting</a:t>
             </a:r>
@@ -8410,6 +8554,8 @@
                   <a:srgbClr val="1F2C3D"/>
                 </a:solidFill>
                 <a:latin typeface="Tahoma"/>
+                <a:ea typeface="Tahoma"/>
+                <a:cs typeface="Tahoma"/>
               </a:rPr>
               <a:t>0.8112</a:t>
             </a:r>
@@ -8452,6 +8598,8 @@
                   <a:srgbClr val="0F2038"/>
                 </a:solidFill>
                 <a:latin typeface="Tahoma"/>
+                <a:ea typeface="Tahoma"/>
+                <a:cs typeface="Tahoma"/>
               </a:rPr>
               <a:t>0.8344</a:t>
             </a:r>
@@ -8494,6 +8642,8 @@
                   <a:srgbClr val="1F2C3D"/>
                 </a:solidFill>
                 <a:latin typeface="Tahoma"/>
+                <a:ea typeface="Tahoma"/>
+                <a:cs typeface="Tahoma"/>
               </a:rPr>
               <a:t>0.011 → 0.062</a:t>
             </a:r>
@@ -8582,6 +8732,8 @@
                   <a:srgbClr val="0F2038"/>
                 </a:solidFill>
                 <a:latin typeface="Tahoma"/>
+                <a:ea typeface="Tahoma"/>
+                <a:cs typeface="Tahoma"/>
               </a:rPr>
               <a:t>F1 ของ Random Forest แทบไม่ขึ้นเลย </a:t>
             </a:r>
@@ -8591,6 +8743,8 @@
                   <a:srgbClr val="1F2C3D"/>
                 </a:solidFill>
                 <a:latin typeface="Tahoma"/>
+                <a:ea typeface="Tahoma"/>
+                <a:cs typeface="Tahoma"/>
               </a:rPr>
               <a:t>แต่ช่องว่าง train–CV แคบลงจาก 0.152 เหลือ 0.122</a:t>
             </a:r>
@@ -8610,6 +8764,8 @@
                   <a:srgbClr val="0F2038"/>
                 </a:solidFill>
                 <a:latin typeface="Tahoma"/>
+                <a:ea typeface="Tahoma"/>
+                <a:cs typeface="Tahoma"/>
               </a:rPr>
               <a:t>→ โมเดลจำข้อมูลน้อยลงและมีเสถียรภาพมากขึ้น จึงถือว่า tuning ได้ผล</a:t>
             </a:r>
@@ -8652,6 +8808,8 @@
                   <a:srgbClr val="0F2038"/>
                 </a:solidFill>
                 <a:latin typeface="Tahoma"/>
+                <a:ea typeface="Tahoma"/>
+                <a:cs typeface="Tahoma"/>
               </a:rPr>
               <a:t>ค่าที่เลือกใช้: </a:t>
             </a:r>
@@ -8671,6 +8829,8 @@
                   <a:srgbClr val="6B7A8C"/>
                 </a:solidFill>
                 <a:latin typeface="Tahoma"/>
+                <a:ea typeface="Tahoma"/>
+                <a:cs typeface="Tahoma"/>
               </a:rPr>
               <a:t>n_estimators=300 · max_depth=30 · min_samples_leaf=2 · max_features=log2 · class_weight=balanced_subsample</a:t>
             </a:r>
@@ -8737,6 +8897,8 @@
                   <a:srgbClr val="6B7A8C"/>
                 </a:solidFill>
                 <a:latin typeface="Tahoma"/>
+                <a:ea typeface="Tahoma"/>
+                <a:cs typeface="Tahoma"/>
               </a:rPr>
               <a:t>Validation Curve: เส้น train พุ่งขึ้นแต่ validation นิ่ง = สัญญาณ overfitting ใช้เลือกค่า max_depth</a:t>
             </a:r>
@@ -8852,6 +9014,8 @@
                   <a:srgbClr val="0F2038"/>
                 </a:solidFill>
                 <a:latin typeface="Tahoma"/>
+                <a:ea typeface="Tahoma"/>
+                <a:cs typeface="Tahoma"/>
               </a:rPr>
               <a:t>13</a:t>
             </a:r>
@@ -8894,6 +9058,8 @@
                   <a:srgbClr val="E0A458"/>
                 </a:solidFill>
                 <a:latin typeface="Tahoma"/>
+                <a:ea typeface="Tahoma"/>
+                <a:cs typeface="Tahoma"/>
               </a:rPr>
               <a:t>ผลบนชุดทดสอบ</a:t>
             </a:r>
@@ -8936,6 +9102,8 @@
                   <a:srgbClr val="0F2038"/>
                 </a:solidFill>
                 <a:latin typeface="Tahoma"/>
+                <a:ea typeface="Tahoma"/>
+                <a:cs typeface="Tahoma"/>
               </a:rPr>
               <a:t>ปรับ threshold เป็น 0.46 เพิ่ม Recall ได้ 2.6 จุด</a:t>
             </a:r>
@@ -9048,6 +9216,8 @@
                   <a:srgbClr val="E0A458"/>
                 </a:solidFill>
                 <a:latin typeface="Tahoma"/>
+                <a:ea typeface="Tahoma"/>
+                <a:cs typeface="Tahoma"/>
               </a:rPr>
               <a:t>0.8469</a:t>
             </a:r>
@@ -9090,6 +9260,8 @@
                   <a:srgbClr val="6B7A8C"/>
                 </a:solidFill>
                 <a:latin typeface="Tahoma"/>
+                <a:ea typeface="Tahoma"/>
+                <a:cs typeface="Tahoma"/>
               </a:rPr>
               <a:t>F1-score</a:t>
             </a:r>
@@ -9178,6 +9350,8 @@
                   <a:srgbClr val="0F2038"/>
                 </a:solidFill>
                 <a:latin typeface="Tahoma"/>
+                <a:ea typeface="Tahoma"/>
+                <a:cs typeface="Tahoma"/>
               </a:rPr>
               <a:t>0.8351</a:t>
             </a:r>
@@ -9220,6 +9394,8 @@
                   <a:srgbClr val="6B7A8C"/>
                 </a:solidFill>
                 <a:latin typeface="Tahoma"/>
+                <a:ea typeface="Tahoma"/>
+                <a:cs typeface="Tahoma"/>
               </a:rPr>
               <a:t>Precision</a:t>
             </a:r>
@@ -9308,6 +9484,8 @@
                   <a:srgbClr val="0F2038"/>
                 </a:solidFill>
                 <a:latin typeface="Tahoma"/>
+                <a:ea typeface="Tahoma"/>
+                <a:cs typeface="Tahoma"/>
               </a:rPr>
               <a:t>0.8590</a:t>
             </a:r>
@@ -9350,6 +9528,8 @@
                   <a:srgbClr val="6B7A8C"/>
                 </a:solidFill>
                 <a:latin typeface="Tahoma"/>
+                <a:ea typeface="Tahoma"/>
+                <a:cs typeface="Tahoma"/>
               </a:rPr>
               <a:t>Recall</a:t>
             </a:r>
@@ -9438,6 +9618,8 @@
                   <a:srgbClr val="0F2038"/>
                 </a:solidFill>
                 <a:latin typeface="Tahoma"/>
+                <a:ea typeface="Tahoma"/>
+                <a:cs typeface="Tahoma"/>
               </a:rPr>
               <a:t>0.9567</a:t>
             </a:r>
@@ -9480,6 +9662,8 @@
                   <a:srgbClr val="6B7A8C"/>
                 </a:solidFill>
                 <a:latin typeface="Tahoma"/>
+                <a:ea typeface="Tahoma"/>
+                <a:cs typeface="Tahoma"/>
               </a:rPr>
               <a:t>ROC-AUC</a:t>
             </a:r>
@@ -9568,6 +9752,8 @@
                   <a:srgbClr val="0F2038"/>
                 </a:solidFill>
                 <a:latin typeface="Tahoma"/>
+                <a:ea typeface="Tahoma"/>
+                <a:cs typeface="Tahoma"/>
               </a:rPr>
               <a:t>0.9367</a:t>
             </a:r>
@@ -9610,6 +9796,8 @@
                   <a:srgbClr val="6B7A8C"/>
                 </a:solidFill>
                 <a:latin typeface="Tahoma"/>
+                <a:ea typeface="Tahoma"/>
+                <a:cs typeface="Tahoma"/>
               </a:rPr>
               <a:t>PR-AUC</a:t>
             </a:r>
@@ -9698,6 +9886,8 @@
                   <a:srgbClr val="0F2038"/>
                 </a:solidFill>
                 <a:latin typeface="Tahoma"/>
+                <a:ea typeface="Tahoma"/>
+                <a:cs typeface="Tahoma"/>
               </a:rPr>
               <a:t>0.8849</a:t>
             </a:r>
@@ -9740,6 +9930,8 @@
                   <a:srgbClr val="6B7A8C"/>
                 </a:solidFill>
                 <a:latin typeface="Tahoma"/>
+                <a:ea typeface="Tahoma"/>
+                <a:cs typeface="Tahoma"/>
               </a:rPr>
               <a:t>Accuracy</a:t>
             </a:r>
@@ -9828,6 +10020,8 @@
                   <a:srgbClr val="FFFFFF"/>
                 </a:solidFill>
                 <a:latin typeface="Tahoma"/>
+                <a:ea typeface="Tahoma"/>
+                <a:cs typeface="Tahoma"/>
               </a:rPr>
               <a:t>Test set 23,842 แถว ถูกใช้เพียงครั้งเดียวตอนท้าย</a:t>
             </a:r>
@@ -9847,6 +10041,8 @@
                   <a:srgbClr val="C7D2DE"/>
                 </a:solidFill>
                 <a:latin typeface="Tahoma"/>
+                <a:ea typeface="Tahoma"/>
+                <a:cs typeface="Tahoma"/>
               </a:rPr>
               <a:t>การเลือก feature · เลือกโมเดล · tuning · หา threshold ทั้งหมดใช้ Cross-Validation บน train เท่านั้น</a:t>
             </a:r>
@@ -9962,6 +10158,8 @@
                   <a:srgbClr val="0F2038"/>
                 </a:solidFill>
                 <a:latin typeface="Tahoma"/>
+                <a:ea typeface="Tahoma"/>
+                <a:cs typeface="Tahoma"/>
               </a:rPr>
               <a:t>14</a:t>
             </a:r>
@@ -10004,6 +10202,8 @@
                   <a:srgbClr val="E0A458"/>
                 </a:solidFill>
                 <a:latin typeface="Tahoma"/>
+                <a:ea typeface="Tahoma"/>
+                <a:cs typeface="Tahoma"/>
               </a:rPr>
               <a:t>จุดค้นพบสำคัญ</a:t>
             </a:r>
@@ -10046,6 +10246,8 @@
                   <a:srgbClr val="0F2038"/>
                 </a:solidFill>
                 <a:latin typeface="Tahoma"/>
+                <a:ea typeface="Tahoma"/>
+                <a:cs typeface="Tahoma"/>
               </a:rPr>
               <a:t>ถ้าทดสอบแบบทำนายอนาคตจริง F1 ตกจาก 0.847 เหลือ 0.725</a:t>
             </a:r>
@@ -10132,6 +10334,8 @@
                   <a:srgbClr val="FFFFFF"/>
                 </a:solidFill>
                 <a:latin typeface="Tahoma"/>
+                <a:ea typeface="Tahoma"/>
+                <a:cs typeface="Tahoma"/>
               </a:rPr>
               <a:t>วิธีแบ่งข้อมูล (threshold 0.46)</a:t>
             </a:r>
@@ -10174,6 +10378,8 @@
                   <a:srgbClr val="FFFFFF"/>
                 </a:solidFill>
                 <a:latin typeface="Tahoma"/>
+                <a:ea typeface="Tahoma"/>
+                <a:cs typeface="Tahoma"/>
               </a:rPr>
               <a:t>F1</a:t>
             </a:r>
@@ -10216,6 +10422,8 @@
                   <a:srgbClr val="FFFFFF"/>
                 </a:solidFill>
                 <a:latin typeface="Tahoma"/>
+                <a:ea typeface="Tahoma"/>
+                <a:cs typeface="Tahoma"/>
               </a:rPr>
               <a:t>Precision</a:t>
             </a:r>
@@ -10258,6 +10466,8 @@
                   <a:srgbClr val="FFFFFF"/>
                 </a:solidFill>
                 <a:latin typeface="Tahoma"/>
+                <a:ea typeface="Tahoma"/>
+                <a:cs typeface="Tahoma"/>
               </a:rPr>
               <a:t>Recall</a:t>
             </a:r>
@@ -10300,6 +10510,8 @@
                   <a:srgbClr val="0F2038"/>
                 </a:solidFill>
                 <a:latin typeface="Tahoma"/>
+                <a:ea typeface="Tahoma"/>
+                <a:cs typeface="Tahoma"/>
               </a:rPr>
               <a:t>Random split</a:t>
             </a:r>
@@ -10342,6 +10554,8 @@
                   <a:srgbClr val="0F2038"/>
                 </a:solidFill>
                 <a:latin typeface="Tahoma"/>
+                <a:ea typeface="Tahoma"/>
+                <a:cs typeface="Tahoma"/>
               </a:rPr>
               <a:t>0.8469</a:t>
             </a:r>
@@ -10384,6 +10598,8 @@
                   <a:srgbClr val="1F2C3D"/>
                 </a:solidFill>
                 <a:latin typeface="Tahoma"/>
+                <a:ea typeface="Tahoma"/>
+                <a:cs typeface="Tahoma"/>
               </a:rPr>
               <a:t>0.8351</a:t>
             </a:r>
@@ -10426,6 +10642,8 @@
                   <a:srgbClr val="1F2C3D"/>
                 </a:solidFill>
                 <a:latin typeface="Tahoma"/>
+                <a:ea typeface="Tahoma"/>
+                <a:cs typeface="Tahoma"/>
               </a:rPr>
               <a:t>0.8590</a:t>
             </a:r>
@@ -10512,6 +10730,8 @@
                   <a:srgbClr val="0F2038"/>
                 </a:solidFill>
                 <a:latin typeface="Tahoma"/>
+                <a:ea typeface="Tahoma"/>
+                <a:cs typeface="Tahoma"/>
               </a:rPr>
               <a:t>Time-based split</a:t>
             </a:r>
@@ -10554,6 +10774,8 @@
                   <a:srgbClr val="0F2038"/>
                 </a:solidFill>
                 <a:latin typeface="Tahoma"/>
+                <a:ea typeface="Tahoma"/>
+                <a:cs typeface="Tahoma"/>
               </a:rPr>
               <a:t>0.7249</a:t>
             </a:r>
@@ -10596,6 +10818,8 @@
                   <a:srgbClr val="1F2C3D"/>
                 </a:solidFill>
                 <a:latin typeface="Tahoma"/>
+                <a:ea typeface="Tahoma"/>
+                <a:cs typeface="Tahoma"/>
               </a:rPr>
               <a:t>0.7996</a:t>
             </a:r>
@@ -10638,6 +10862,8 @@
                   <a:srgbClr val="1F2C3D"/>
                 </a:solidFill>
                 <a:latin typeface="Tahoma"/>
+                <a:ea typeface="Tahoma"/>
+                <a:cs typeface="Tahoma"/>
               </a:rPr>
               <a:t>0.6630</a:t>
             </a:r>
@@ -10726,6 +10952,8 @@
                   <a:srgbClr val="B33A3A"/>
                 </a:solidFill>
                 <a:latin typeface="Tahoma"/>
+                <a:ea typeface="Tahoma"/>
+                <a:cs typeface="Tahoma"/>
               </a:rPr>
               <a:t>สาเหตุ: </a:t>
             </a:r>
@@ -10735,6 +10963,8 @@
                   <a:srgbClr val="0F2038"/>
                 </a:solidFill>
                 <a:latin typeface="Tahoma"/>
+                <a:ea typeface="Tahoma"/>
+                <a:cs typeface="Tahoma"/>
               </a:rPr>
               <a:t>ชุด test ที่แบ่งตามเวลามีอัตรายกเลิก 40.99% ขณะที่ train มี 36.09%</a:t>
             </a:r>
@@ -10754,6 +10984,8 @@
                   <a:srgbClr val="1F2C3D"/>
                 </a:solidFill>
                 <a:latin typeface="Tahoma"/>
+                <a:ea typeface="Tahoma"/>
+                <a:cs typeface="Tahoma"/>
               </a:rPr>
               <a:t>พฤติกรรมลูกค้าเปลี่ยนไปตามเวลาจริง (distribution shift)</a:t>
             </a:r>
@@ -10842,6 +11074,8 @@
                   <a:srgbClr val="B33A3A"/>
                 </a:solidFill>
                 <a:latin typeface="Tahoma"/>
+                <a:ea typeface="Tahoma"/>
+                <a:cs typeface="Tahoma"/>
               </a:rPr>
               <a:t>−0.122</a:t>
             </a:r>
@@ -10884,6 +11118,8 @@
                   <a:srgbClr val="6B7A8C"/>
                 </a:solidFill>
                 <a:latin typeface="Tahoma"/>
+                <a:ea typeface="Tahoma"/>
+                <a:cs typeface="Tahoma"/>
               </a:rPr>
               <a:t>F1 ที่หายไปเมื่อทดสอบตามเวลา</a:t>
             </a:r>
@@ -10926,6 +11162,8 @@
                   <a:srgbClr val="0F2038"/>
                 </a:solidFill>
                 <a:latin typeface="Tahoma"/>
+                <a:ea typeface="Tahoma"/>
+                <a:cs typeface="Tahoma"/>
               </a:rPr>
               <a:t>“การสุ่มแบ่งข้อมูลประเมินโมเดลสูงเกินจริง เราจึงรายงานตัวเลขทั้งสองแบบ”</a:t>
             </a:r>
@@ -10945,6 +11183,8 @@
                   <a:srgbClr val="6B7A8C"/>
                 </a:solidFill>
                 <a:latin typeface="Tahoma"/>
+                <a:ea typeface="Tahoma"/>
+                <a:cs typeface="Tahoma"/>
               </a:rPr>
               <a:t>ในการใช้งานจริง โมเดลต้องทำนายอนาคตจากข้อมูลอดีต จึงควร retrain เป็นระยะ</a:t>
             </a:r>
@@ -11060,6 +11300,8 @@
                   <a:srgbClr val="0F2038"/>
                 </a:solidFill>
                 <a:latin typeface="Tahoma"/>
+                <a:ea typeface="Tahoma"/>
+                <a:cs typeface="Tahoma"/>
               </a:rPr>
               <a:t>15</a:t>
             </a:r>
@@ -11102,6 +11344,8 @@
                   <a:srgbClr val="E0A458"/>
                 </a:solidFill>
                 <a:latin typeface="Tahoma"/>
+                <a:ea typeface="Tahoma"/>
+                <a:cs typeface="Tahoma"/>
               </a:rPr>
               <a:t>DEPLOYMENT</a:t>
             </a:r>
@@ -11144,6 +11388,8 @@
                   <a:srgbClr val="0F2038"/>
                 </a:solidFill>
                 <a:latin typeface="Tahoma"/>
+                <a:ea typeface="Tahoma"/>
+                <a:cs typeface="Tahoma"/>
               </a:rPr>
               <a:t>กรอกข้อมูลการจอง → ได้ความเสี่ยงทันที</a:t>
             </a:r>
@@ -11186,6 +11432,8 @@
                   <a:srgbClr val="6B7A8C"/>
                 </a:solidFill>
                 <a:latin typeface="Tahoma"/>
+                <a:ea typeface="Tahoma"/>
+                <a:cs typeface="Tahoma"/>
               </a:rPr>
               <a:t>เว็บแอป Streamlit — ผู้ใช้กรอกรายละเอียดการจอง ระบบคำนวณ 18 features แล้วแสดงความน่าจะเป็นที่จะยกเลิก</a:t>
             </a:r>
@@ -11274,6 +11522,8 @@
                   <a:srgbClr val="B33A3A"/>
                 </a:solidFill>
                 <a:latin typeface="Tahoma"/>
+                <a:ea typeface="Tahoma"/>
+                <a:cs typeface="Tahoma"/>
               </a:rPr>
               <a:t>99.8%</a:t>
             </a:r>
@@ -11316,6 +11566,8 @@
                   <a:srgbClr val="B33A3A"/>
                 </a:solidFill>
                 <a:latin typeface="Tahoma"/>
+                <a:ea typeface="Tahoma"/>
+                <a:cs typeface="Tahoma"/>
               </a:rPr>
               <a:t>เสี่ยงสูง</a:t>
             </a:r>
@@ -11358,6 +11610,8 @@
                   <a:srgbClr val="6B7A8C"/>
                 </a:solidFill>
                 <a:latin typeface="Tahoma"/>
+                <a:ea typeface="Tahoma"/>
+                <a:cs typeface="Tahoma"/>
               </a:rPr>
               <a:t>จองล่วงหน้า 300 วัน
 Non Refund + Groups</a:t>
@@ -11447,6 +11701,8 @@
                   <a:srgbClr val="E0A458"/>
                 </a:solidFill>
                 <a:latin typeface="Tahoma"/>
+                <a:ea typeface="Tahoma"/>
+                <a:cs typeface="Tahoma"/>
               </a:rPr>
               <a:t>25.9%</a:t>
             </a:r>
@@ -11489,6 +11745,8 @@
                   <a:srgbClr val="E0A458"/>
                 </a:solidFill>
                 <a:latin typeface="Tahoma"/>
+                <a:ea typeface="Tahoma"/>
+                <a:cs typeface="Tahoma"/>
               </a:rPr>
               <a:t>เสี่ยงปานกลาง</a:t>
             </a:r>
@@ -11531,6 +11789,8 @@
                   <a:srgbClr val="6B7A8C"/>
                 </a:solidFill>
                 <a:latin typeface="Tahoma"/>
+                <a:ea typeface="Tahoma"/>
+                <a:cs typeface="Tahoma"/>
               </a:rPr>
               <a:t>จองล่วงหน้า 60 วัน
 Online TA</a:t>
@@ -11620,6 +11880,8 @@
                   <a:srgbClr val="1E7A5E"/>
                 </a:solidFill>
                 <a:latin typeface="Tahoma"/>
+                <a:ea typeface="Tahoma"/>
+                <a:cs typeface="Tahoma"/>
               </a:rPr>
               <a:t>1.0%</a:t>
             </a:r>
@@ -11662,6 +11924,8 @@
                   <a:srgbClr val="1E7A5E"/>
                 </a:solidFill>
                 <a:latin typeface="Tahoma"/>
+                <a:ea typeface="Tahoma"/>
+                <a:cs typeface="Tahoma"/>
               </a:rPr>
               <a:t>เสี่ยงต่ำ</a:t>
             </a:r>
@@ -11704,6 +11968,8 @@
                   <a:srgbClr val="6B7A8C"/>
                 </a:solidFill>
                 <a:latin typeface="Tahoma"/>
+                <a:ea typeface="Tahoma"/>
+                <a:cs typeface="Tahoma"/>
               </a:rPr>
               <a:t>จองล่วงหน้า 5 วัน
 Direct + ลูกค้าเก่า</a:t>
@@ -11793,6 +12059,8 @@
                   <a:srgbClr val="E0A458"/>
                 </a:solidFill>
                 <a:latin typeface="Tahoma"/>
+                <a:ea typeface="Tahoma"/>
+                <a:cs typeface="Tahoma"/>
               </a:rPr>
               <a:t>ข้อจำกัดของระบบ</a:t>
             </a:r>
@@ -11812,6 +12080,8 @@
                   <a:srgbClr val="C7D2DE"/>
                 </a:solidFill>
                 <a:latin typeface="Tahoma"/>
+                <a:ea typeface="Tahoma"/>
+                <a:cs typeface="Tahoma"/>
               </a:rPr>
               <a:t>โมเดลบนเว็บใช้ HistGradientBoosting ขนาด 0.8 MB (F1 0.8334) แทน Random Forest 356.8 MB เพราะข้อจำกัดด้านหน่วยความจำของบริการฟรี · ผลทำนายอิงข้อมูลโปรตุเกสปี 2015–2017</a:t>
             </a:r>
@@ -11927,6 +12197,8 @@
                   <a:srgbClr val="0F2038"/>
                 </a:solidFill>
                 <a:latin typeface="Tahoma"/>
+                <a:ea typeface="Tahoma"/>
+                <a:cs typeface="Tahoma"/>
               </a:rPr>
               <a:t>16</a:t>
             </a:r>
@@ -11969,6 +12241,8 @@
                   <a:srgbClr val="E0A458"/>
                 </a:solidFill>
                 <a:latin typeface="Tahoma"/>
+                <a:ea typeface="Tahoma"/>
+                <a:cs typeface="Tahoma"/>
               </a:rPr>
               <a:t>CONCLUSION</a:t>
             </a:r>
@@ -12011,6 +12285,8 @@
                   <a:srgbClr val="0F2038"/>
                 </a:solidFill>
                 <a:latin typeface="Tahoma"/>
+                <a:ea typeface="Tahoma"/>
+                <a:cs typeface="Tahoma"/>
               </a:rPr>
               <a:t>สรุปผล ข้อจำกัด และงานต่อไป</a:t>
             </a:r>
@@ -12099,6 +12375,8 @@
                   <a:srgbClr val="1E7A5E"/>
                 </a:solidFill>
                 <a:latin typeface="Tahoma"/>
+                <a:ea typeface="Tahoma"/>
+                <a:cs typeface="Tahoma"/>
               </a:rPr>
               <a:t>ตอบโจทย์หรือไม่</a:t>
             </a:r>
@@ -12127,7 +12405,7 @@
           </a:bodyPr>
           <a:lstStyle/>
           <a:p>
-            <a:pPr algn="l">
+            <a:pPr algn="l" marL="201168" indent="-201168">
               <a:lnSpc>
                 <a:spcPct val="125000"/>
               </a:lnSpc>
@@ -12141,6 +12419,8 @@
                   <a:srgbClr val="E0A458"/>
                 </a:solidFill>
                 <a:latin typeface="Tahoma"/>
+                <a:ea typeface="Tahoma"/>
+                <a:cs typeface="Tahoma"/>
               </a:rPr>
               <a:t>•  </a:t>
             </a:r>
@@ -12150,12 +12430,14 @@
                   <a:srgbClr val="1F2C3D"/>
                 </a:solidFill>
                 <a:latin typeface="Tahoma"/>
+                <a:ea typeface="Tahoma"/>
+                <a:cs typeface="Tahoma"/>
               </a:rPr>
               <a:t>ทำนายได้ F1 0.8469 บนชุดทดสอบ</a:t>
             </a:r>
           </a:p>
           <a:p>
-            <a:pPr algn="l">
+            <a:pPr algn="l" marL="201168" indent="-201168">
               <a:lnSpc>
                 <a:spcPct val="125000"/>
               </a:lnSpc>
@@ -12169,6 +12451,8 @@
                   <a:srgbClr val="E0A458"/>
                 </a:solidFill>
                 <a:latin typeface="Tahoma"/>
+                <a:ea typeface="Tahoma"/>
+                <a:cs typeface="Tahoma"/>
               </a:rPr>
               <a:t>•  </a:t>
             </a:r>
@@ -12178,12 +12462,14 @@
                   <a:srgbClr val="1F2C3D"/>
                 </a:solidFill>
                 <a:latin typeface="Tahoma"/>
+                <a:ea typeface="Tahoma"/>
+                <a:cs typeface="Tahoma"/>
               </a:rPr>
               <a:t>สูงกว่า baseline (F1 = 0) อย่างชัดเจน</a:t>
             </a:r>
           </a:p>
           <a:p>
-            <a:pPr algn="l">
+            <a:pPr algn="l" marL="201168" indent="-201168">
               <a:lnSpc>
                 <a:spcPct val="125000"/>
               </a:lnSpc>
@@ -12197,6 +12483,8 @@
                   <a:srgbClr val="E0A458"/>
                 </a:solidFill>
                 <a:latin typeface="Tahoma"/>
+                <a:ea typeface="Tahoma"/>
+                <a:cs typeface="Tahoma"/>
               </a:rPr>
               <a:t>•  </a:t>
             </a:r>
@@ -12206,6 +12494,8 @@
                   <a:srgbClr val="1F2C3D"/>
                 </a:solidFill>
                 <a:latin typeface="Tahoma"/>
+                <a:ea typeface="Tahoma"/>
+                <a:cs typeface="Tahoma"/>
               </a:rPr>
               <a:t>ระบุปัจจัยเสี่ยงหลักได้: มัดจำ · เอเจนต์ · ระยะจองล่วงหน้า</a:t>
             </a:r>
@@ -12294,6 +12584,8 @@
                   <a:srgbClr val="B33A3A"/>
                 </a:solidFill>
                 <a:latin typeface="Tahoma"/>
+                <a:ea typeface="Tahoma"/>
+                <a:cs typeface="Tahoma"/>
               </a:rPr>
               <a:t>ข้อจำกัด</a:t>
             </a:r>
@@ -12322,7 +12614,7 @@
           </a:bodyPr>
           <a:lstStyle/>
           <a:p>
-            <a:pPr algn="l">
+            <a:pPr algn="l" marL="201168" indent="-201168">
               <a:lnSpc>
                 <a:spcPct val="125000"/>
               </a:lnSpc>
@@ -12336,6 +12628,8 @@
                   <a:srgbClr val="E0A458"/>
                 </a:solidFill>
                 <a:latin typeface="Tahoma"/>
+                <a:ea typeface="Tahoma"/>
+                <a:cs typeface="Tahoma"/>
               </a:rPr>
               <a:t>•  </a:t>
             </a:r>
@@ -12345,12 +12639,14 @@
                   <a:srgbClr val="1F2C3D"/>
                 </a:solidFill>
                 <a:latin typeface="Tahoma"/>
+                <a:ea typeface="Tahoma"/>
+                <a:cs typeface="Tahoma"/>
               </a:rPr>
               <a:t>ข้อมูลจากโปรตุเกส ปี 2015–2017 เท่านั้น</a:t>
             </a:r>
           </a:p>
           <a:p>
-            <a:pPr algn="l">
+            <a:pPr algn="l" marL="201168" indent="-201168">
               <a:lnSpc>
                 <a:spcPct val="125000"/>
               </a:lnSpc>
@@ -12364,6 +12660,8 @@
                   <a:srgbClr val="E0A458"/>
                 </a:solidFill>
                 <a:latin typeface="Tahoma"/>
+                <a:ea typeface="Tahoma"/>
+                <a:cs typeface="Tahoma"/>
               </a:rPr>
               <a:t>•  </a:t>
             </a:r>
@@ -12373,12 +12671,14 @@
                   <a:srgbClr val="1F2C3D"/>
                 </a:solidFill>
                 <a:latin typeface="Tahoma"/>
+                <a:ea typeface="Tahoma"/>
+                <a:cs typeface="Tahoma"/>
               </a:rPr>
               <a:t>ทดสอบตามเวลาได้ F1 ~0.72 ต่ำกว่าผลสุ่มแบ่ง</a:t>
             </a:r>
           </a:p>
           <a:p>
-            <a:pPr algn="l">
+            <a:pPr algn="l" marL="201168" indent="-201168">
               <a:lnSpc>
                 <a:spcPct val="125000"/>
               </a:lnSpc>
@@ -12392,6 +12692,8 @@
                   <a:srgbClr val="E0A458"/>
                 </a:solidFill>
                 <a:latin typeface="Tahoma"/>
+                <a:ea typeface="Tahoma"/>
+                <a:cs typeface="Tahoma"/>
               </a:rPr>
               <a:t>•  </a:t>
             </a:r>
@@ -12401,6 +12703,8 @@
                   <a:srgbClr val="1F2C3D"/>
                 </a:solidFill>
                 <a:latin typeface="Tahoma"/>
+                <a:ea typeface="Tahoma"/>
+                <a:cs typeface="Tahoma"/>
               </a:rPr>
               <a:t>มีแถวซ้ำ 31,994 แถวที่เลือกไม่ลบ</a:t>
             </a:r>
@@ -12489,6 +12793,8 @@
                   <a:srgbClr val="0F2038"/>
                 </a:solidFill>
                 <a:latin typeface="Tahoma"/>
+                <a:ea typeface="Tahoma"/>
+                <a:cs typeface="Tahoma"/>
               </a:rPr>
               <a:t>งานต่อไป</a:t>
             </a:r>
@@ -12517,7 +12823,7 @@
           </a:bodyPr>
           <a:lstStyle/>
           <a:p>
-            <a:pPr algn="l">
+            <a:pPr algn="l" marL="201168" indent="-201168">
               <a:lnSpc>
                 <a:spcPct val="125000"/>
               </a:lnSpc>
@@ -12531,6 +12837,8 @@
                   <a:srgbClr val="E0A458"/>
                 </a:solidFill>
                 <a:latin typeface="Tahoma"/>
+                <a:ea typeface="Tahoma"/>
+                <a:cs typeface="Tahoma"/>
               </a:rPr>
               <a:t>•  </a:t>
             </a:r>
@@ -12540,12 +12848,14 @@
                   <a:srgbClr val="1F2C3D"/>
                 </a:solidFill>
                 <a:latin typeface="Tahoma"/>
+                <a:ea typeface="Tahoma"/>
+                <a:cs typeface="Tahoma"/>
               </a:rPr>
               <a:t>ใช้ time-based validation ตอน tuning</a:t>
             </a:r>
           </a:p>
           <a:p>
-            <a:pPr algn="l">
+            <a:pPr algn="l" marL="201168" indent="-201168">
               <a:lnSpc>
                 <a:spcPct val="125000"/>
               </a:lnSpc>
@@ -12559,6 +12869,8 @@
                   <a:srgbClr val="E0A458"/>
                 </a:solidFill>
                 <a:latin typeface="Tahoma"/>
+                <a:ea typeface="Tahoma"/>
+                <a:cs typeface="Tahoma"/>
               </a:rPr>
               <a:t>•  </a:t>
             </a:r>
@@ -12568,12 +12880,14 @@
                   <a:srgbClr val="1F2C3D"/>
                 </a:solidFill>
                 <a:latin typeface="Tahoma"/>
+                <a:ea typeface="Tahoma"/>
+                <a:cs typeface="Tahoma"/>
               </a:rPr>
               <a:t>ตั้ง threshold ตามต้นทุนธุรกิจจริง</a:t>
             </a:r>
           </a:p>
           <a:p>
-            <a:pPr algn="l">
+            <a:pPr algn="l" marL="201168" indent="-201168">
               <a:lnSpc>
                 <a:spcPct val="125000"/>
               </a:lnSpc>
@@ -12587,6 +12901,8 @@
                   <a:srgbClr val="E0A458"/>
                 </a:solidFill>
                 <a:latin typeface="Tahoma"/>
+                <a:ea typeface="Tahoma"/>
+                <a:cs typeface="Tahoma"/>
               </a:rPr>
               <a:t>•  </a:t>
             </a:r>
@@ -12596,6 +12912,8 @@
                   <a:srgbClr val="1F2C3D"/>
                 </a:solidFill>
                 <a:latin typeface="Tahoma"/>
+                <a:ea typeface="Tahoma"/>
+                <a:cs typeface="Tahoma"/>
               </a:rPr>
               <a:t>เพิ่ม SHAP อธิบายผลเป็นรายรายการ</a:t>
             </a:r>
@@ -12684,6 +13002,8 @@
                   <a:srgbClr val="E0A458"/>
                 </a:solidFill>
                 <a:latin typeface="Tahoma"/>
+                <a:ea typeface="Tahoma"/>
+                <a:cs typeface="Tahoma"/>
               </a:rPr>
               <a:t>สิ่งที่ได้เรียนรู้</a:t>
             </a:r>
@@ -12703,6 +13023,8 @@
                   <a:srgbClr val="C7D2DE"/>
                 </a:solidFill>
                 <a:latin typeface="Tahoma"/>
+                <a:ea typeface="Tahoma"/>
+                <a:cs typeface="Tahoma"/>
               </a:rPr>
               <a:t>ระวัง Data Leakage ตั้งแต่ก่อนแบ่งข้อมูล · เลือก metric ให้ตรงกับต้นทุนของปัญหา · ใช้ Pipeline ป้องกันข้อมูลรั่วระหว่าง Cross-Validation · ตัวเลขที่ดูดีเกินจริงมักมาจากวิธีประเมินที่ไม่ตรงกับการใช้งานจริง</a:t>
             </a:r>
@@ -12807,6 +13129,8 @@
                   <a:srgbClr val="FFFFFF"/>
                 </a:solidFill>
                 <a:latin typeface="Tahoma"/>
+                <a:ea typeface="Tahoma"/>
+                <a:cs typeface="Tahoma"/>
               </a:rPr>
               <a:t>ขอบคุณครับ / ค่ะ</a:t>
             </a:r>
@@ -12849,6 +13173,8 @@
                   <a:srgbClr val="E0A458"/>
                 </a:solidFill>
                 <a:latin typeface="Tahoma"/>
+                <a:ea typeface="Tahoma"/>
+                <a:cs typeface="Tahoma"/>
               </a:rPr>
               <a:t>Q &amp; A</a:t>
             </a:r>
@@ -12891,6 +13217,8 @@
                   <a:srgbClr val="FFFFFF"/>
                 </a:solidFill>
                 <a:latin typeface="Tahoma"/>
+                <a:ea typeface="Tahoma"/>
+                <a:cs typeface="Tahoma"/>
               </a:rPr>
               <a:t>โค้ดทั้งหมด (Colab / GitHub)</a:t>
             </a:r>
@@ -12910,6 +13238,8 @@
                   <a:srgbClr val="C7D2DE"/>
                 </a:solidFill>
                 <a:latin typeface="Tahoma"/>
+                <a:ea typeface="Tahoma"/>
+                <a:cs typeface="Tahoma"/>
               </a:rPr>
               <a:t>github.com/Hake2549/ML</a:t>
             </a:r>
@@ -12998,6 +13328,8 @@
                   <a:srgbClr val="E0A458"/>
                 </a:solidFill>
                 <a:latin typeface="Tahoma"/>
+                <a:ea typeface="Tahoma"/>
+                <a:cs typeface="Tahoma"/>
               </a:rPr>
               <a:t>สไลด์สำรอง (เปิดเมื่อถูกถาม)</a:t>
             </a:r>
@@ -13026,7 +13358,7 @@
           </a:bodyPr>
           <a:lstStyle/>
           <a:p>
-            <a:pPr algn="l">
+            <a:pPr algn="l" marL="201168" indent="-201168">
               <a:lnSpc>
                 <a:spcPct val="125000"/>
               </a:lnSpc>
@@ -13040,6 +13372,8 @@
                   <a:srgbClr val="E0A458"/>
                 </a:solidFill>
                 <a:latin typeface="Tahoma"/>
+                <a:ea typeface="Tahoma"/>
+                <a:cs typeface="Tahoma"/>
               </a:rPr>
               <a:t>•  </a:t>
             </a:r>
@@ -13049,6 +13383,8 @@
                   <a:srgbClr val="FFFFFF"/>
                 </a:solidFill>
                 <a:latin typeface="Tahoma"/>
+                <a:ea typeface="Tahoma"/>
+                <a:cs typeface="Tahoma"/>
               </a:rPr>
               <a:t>RF Importance ก่อน–หลัง tune</a:t>
             </a:r>
@@ -13058,12 +13394,14 @@
                   <a:srgbClr val="C7D2DE"/>
                 </a:solidFill>
                 <a:latin typeface="Tahoma"/>
+                <a:ea typeface="Tahoma"/>
+                <a:cs typeface="Tahoma"/>
               </a:rPr>
               <a:t> (Spearman 0.985)</a:t>
             </a:r>
           </a:p>
           <a:p>
-            <a:pPr algn="l">
+            <a:pPr algn="l" marL="201168" indent="-201168">
               <a:lnSpc>
                 <a:spcPct val="125000"/>
               </a:lnSpc>
@@ -13077,6 +13415,8 @@
                   <a:srgbClr val="E0A458"/>
                 </a:solidFill>
                 <a:latin typeface="Tahoma"/>
+                <a:ea typeface="Tahoma"/>
+                <a:cs typeface="Tahoma"/>
               </a:rPr>
               <a:t>•  </a:t>
             </a:r>
@@ -13086,12 +13426,14 @@
                   <a:srgbClr val="FFFFFF"/>
                 </a:solidFill>
                 <a:latin typeface="Tahoma"/>
+                <a:ea typeface="Tahoma"/>
+                <a:cs typeface="Tahoma"/>
               </a:rPr>
               <a:t>Learning Curve</a:t>
             </a:r>
           </a:p>
           <a:p>
-            <a:pPr algn="l">
+            <a:pPr algn="l" marL="201168" indent="-201168">
               <a:lnSpc>
                 <a:spcPct val="125000"/>
               </a:lnSpc>
@@ -13105,6 +13447,8 @@
                   <a:srgbClr val="E0A458"/>
                 </a:solidFill>
                 <a:latin typeface="Tahoma"/>
+                <a:ea typeface="Tahoma"/>
+                <a:cs typeface="Tahoma"/>
               </a:rPr>
               <a:t>•  </a:t>
             </a:r>
@@ -13114,12 +13458,14 @@
                   <a:srgbClr val="FFFFFF"/>
                 </a:solidFill>
                 <a:latin typeface="Tahoma"/>
+                <a:ea typeface="Tahoma"/>
+                <a:cs typeface="Tahoma"/>
               </a:rPr>
               <a:t>Error Analysis แยกตามกลุ่ม</a:t>
             </a:r>
           </a:p>
           <a:p>
-            <a:pPr algn="l">
+            <a:pPr algn="l" marL="201168" indent="-201168">
               <a:lnSpc>
                 <a:spcPct val="125000"/>
               </a:lnSpc>
@@ -13133,6 +13479,8 @@
                   <a:srgbClr val="E0A458"/>
                 </a:solidFill>
                 <a:latin typeface="Tahoma"/>
+                <a:ea typeface="Tahoma"/>
+                <a:cs typeface="Tahoma"/>
               </a:rPr>
               <a:t>•  </a:t>
             </a:r>
@@ -13142,12 +13490,14 @@
                   <a:srgbClr val="FFFFFF"/>
                 </a:solidFill>
                 <a:latin typeface="Tahoma"/>
+                <a:ea typeface="Tahoma"/>
+                <a:cs typeface="Tahoma"/>
               </a:rPr>
               <a:t>ช่วงค่า Hyperparameter ที่ค้นหา</a:t>
             </a:r>
           </a:p>
           <a:p>
-            <a:pPr algn="l">
+            <a:pPr algn="l" marL="201168" indent="-201168">
               <a:lnSpc>
                 <a:spcPct val="125000"/>
               </a:lnSpc>
@@ -13161,6 +13511,8 @@
                   <a:srgbClr val="E0A458"/>
                 </a:solidFill>
                 <a:latin typeface="Tahoma"/>
+                <a:ea typeface="Tahoma"/>
+                <a:cs typeface="Tahoma"/>
               </a:rPr>
               <a:t>•  </a:t>
             </a:r>
@@ -13170,6 +13522,8 @@
                   <a:srgbClr val="FFFFFF"/>
                 </a:solidFill>
                 <a:latin typeface="Tahoma"/>
+                <a:ea typeface="Tahoma"/>
+                <a:cs typeface="Tahoma"/>
               </a:rPr>
               <a:t>Correlation Heatmap</a:t>
             </a:r>
@@ -13285,6 +13639,8 @@
                   <a:srgbClr val="0F2038"/>
                 </a:solidFill>
                 <a:latin typeface="Tahoma"/>
+                <a:ea typeface="Tahoma"/>
+                <a:cs typeface="Tahoma"/>
               </a:rPr>
               <a:t>2</a:t>
             </a:r>
@@ -13327,6 +13683,8 @@
                   <a:srgbClr val="E0A458"/>
                 </a:solidFill>
                 <a:latin typeface="Tahoma"/>
+                <a:ea typeface="Tahoma"/>
+                <a:cs typeface="Tahoma"/>
               </a:rPr>
               <a:t>PROBLEM</a:t>
             </a:r>
@@ -13369,6 +13727,8 @@
                   <a:srgbClr val="0F2038"/>
                 </a:solidFill>
                 <a:latin typeface="Tahoma"/>
+                <a:ea typeface="Tahoma"/>
+                <a:cs typeface="Tahoma"/>
               </a:rPr>
               <a:t>ยกเลิก 37% คือรายได้ที่หายและพยากรณ์ห้องที่ผิดพลาด</a:t>
             </a:r>
@@ -13397,7 +13757,7 @@
           </a:bodyPr>
           <a:lstStyle/>
           <a:p>
-            <a:pPr algn="l">
+            <a:pPr algn="l" marL="201168" indent="-201168">
               <a:lnSpc>
                 <a:spcPct val="125000"/>
               </a:lnSpc>
@@ -13411,6 +13771,8 @@
                   <a:srgbClr val="E0A458"/>
                 </a:solidFill>
                 <a:latin typeface="Tahoma"/>
+                <a:ea typeface="Tahoma"/>
+                <a:cs typeface="Tahoma"/>
               </a:rPr>
               <a:t>•  </a:t>
             </a:r>
@@ -13420,12 +13782,14 @@
                   <a:srgbClr val="1F2C3D"/>
                 </a:solidFill>
                 <a:latin typeface="Tahoma"/>
+                <a:ea typeface="Tahoma"/>
+                <a:cs typeface="Tahoma"/>
               </a:rPr>
               <a:t>ยกเลิกกระชั้นชิด → ขายห้องต่อไม่ทัน → รายได้หายทันที</a:t>
             </a:r>
           </a:p>
           <a:p>
-            <a:pPr algn="l">
+            <a:pPr algn="l" marL="201168" indent="-201168">
               <a:lnSpc>
                 <a:spcPct val="125000"/>
               </a:lnSpc>
@@ -13439,6 +13803,8 @@
                   <a:srgbClr val="E0A458"/>
                 </a:solidFill>
                 <a:latin typeface="Tahoma"/>
+                <a:ea typeface="Tahoma"/>
+                <a:cs typeface="Tahoma"/>
               </a:rPr>
               <a:t>•  </a:t>
             </a:r>
@@ -13448,12 +13814,14 @@
                   <a:srgbClr val="1F2C3D"/>
                 </a:solidFill>
                 <a:latin typeface="Tahoma"/>
+                <a:ea typeface="Tahoma"/>
+                <a:cs typeface="Tahoma"/>
               </a:rPr>
               <a:t>โรงแรมต้องทำ Overbooking ชดเชย ซึ่งถ้าประเมินผิดจะเสียทั้งเงินและชื่อเสียง</a:t>
             </a:r>
           </a:p>
           <a:p>
-            <a:pPr algn="l">
+            <a:pPr algn="l" marL="201168" indent="-201168">
               <a:lnSpc>
                 <a:spcPct val="125000"/>
               </a:lnSpc>
@@ -13467,6 +13835,8 @@
                   <a:srgbClr val="E0A458"/>
                 </a:solidFill>
                 <a:latin typeface="Tahoma"/>
+                <a:ea typeface="Tahoma"/>
+                <a:cs typeface="Tahoma"/>
               </a:rPr>
               <a:t>•  </a:t>
             </a:r>
@@ -13476,6 +13846,8 @@
                   <a:srgbClr val="0F2038"/>
                 </a:solidFill>
                 <a:latin typeface="Tahoma"/>
+                <a:ea typeface="Tahoma"/>
+                <a:cs typeface="Tahoma"/>
               </a:rPr>
               <a:t>Input = </a:t>
             </a:r>
@@ -13485,6 +13857,8 @@
                   <a:srgbClr val="1F2C3D"/>
                 </a:solidFill>
                 <a:latin typeface="Tahoma"/>
+                <a:ea typeface="Tahoma"/>
+                <a:cs typeface="Tahoma"/>
               </a:rPr>
               <a:t>ข้อมูลการจอง ณ วันที่จอง  →  </a:t>
             </a:r>
@@ -13494,6 +13868,8 @@
                   <a:srgbClr val="0F2038"/>
                 </a:solidFill>
                 <a:latin typeface="Tahoma"/>
+                <a:ea typeface="Tahoma"/>
+                <a:cs typeface="Tahoma"/>
               </a:rPr>
               <a:t>Output = </a:t>
             </a:r>
@@ -13503,12 +13879,14 @@
                   <a:srgbClr val="1F2C3D"/>
                 </a:solidFill>
                 <a:latin typeface="Tahoma"/>
+                <a:ea typeface="Tahoma"/>
+                <a:cs typeface="Tahoma"/>
               </a:rPr>
               <a:t>ยกเลิก (1) / ไม่ยกเลิก (0)</a:t>
             </a:r>
           </a:p>
           <a:p>
-            <a:pPr algn="l">
+            <a:pPr algn="l" marL="201168" indent="-201168">
               <a:lnSpc>
                 <a:spcPct val="125000"/>
               </a:lnSpc>
@@ -13522,6 +13900,8 @@
                   <a:srgbClr val="E0A458"/>
                 </a:solidFill>
                 <a:latin typeface="Tahoma"/>
+                <a:ea typeface="Tahoma"/>
+                <a:cs typeface="Tahoma"/>
               </a:rPr>
               <a:t>•  </a:t>
             </a:r>
@@ -13531,6 +13911,8 @@
                   <a:srgbClr val="1F2C3D"/>
                 </a:solidFill>
                 <a:latin typeface="Tahoma"/>
+                <a:ea typeface="Tahoma"/>
+                <a:cs typeface="Tahoma"/>
               </a:rPr>
               <a:t>ขอบเขต: โรงแรม 2 แห่งในโปรตุเกส ก.ค. 2015 – ส.ค. 2017</a:t>
             </a:r>
@@ -13619,6 +14001,8 @@
                   <a:srgbClr val="E0A458"/>
                 </a:solidFill>
                 <a:latin typeface="Tahoma"/>
+                <a:ea typeface="Tahoma"/>
+                <a:cs typeface="Tahoma"/>
               </a:rPr>
               <a:t>37%</a:t>
             </a:r>
@@ -13661,6 +14045,8 @@
                   <a:srgbClr val="FFFFFF"/>
                 </a:solidFill>
                 <a:latin typeface="Tahoma"/>
+                <a:ea typeface="Tahoma"/>
+                <a:cs typeface="Tahoma"/>
               </a:rPr>
               <a:t>ของการจองทั้งหมดถูกยกเลิก
 (44,224 จาก 119,390 รายการ)</a:t>
@@ -13704,6 +14090,8 @@
                   <a:srgbClr val="6B7A8C"/>
                 </a:solidFill>
                 <a:latin typeface="Tahoma"/>
+                <a:ea typeface="Tahoma"/>
+                <a:cs typeface="Tahoma"/>
               </a:rPr>
               <a:t>ปัญหานี้เป็น Binary Classification ที่มีมูลค่าทางธุรกิจวัดได้จริง</a:t>
             </a:r>
@@ -13819,6 +14207,8 @@
                   <a:srgbClr val="0F2038"/>
                 </a:solidFill>
                 <a:latin typeface="Tahoma"/>
+                <a:ea typeface="Tahoma"/>
+                <a:cs typeface="Tahoma"/>
               </a:rPr>
               <a:t>3</a:t>
             </a:r>
@@ -13861,6 +14251,8 @@
                   <a:srgbClr val="E0A458"/>
                 </a:solidFill>
                 <a:latin typeface="Tahoma"/>
+                <a:ea typeface="Tahoma"/>
+                <a:cs typeface="Tahoma"/>
               </a:rPr>
               <a:t>DATA UNDERSTANDING</a:t>
             </a:r>
@@ -13903,6 +14295,8 @@
                   <a:srgbClr val="0F2038"/>
                 </a:solidFill>
                 <a:latin typeface="Tahoma"/>
+                <a:ea typeface="Tahoma"/>
+                <a:cs typeface="Tahoma"/>
               </a:rPr>
               <a:t>ทายว่า "ไม่ยกเลิก" ทุกรายการ ก็ได้ Accuracy 62.9% แล้ว</a:t>
             </a:r>
@@ -13955,7 +14349,7 @@
           </a:bodyPr>
           <a:lstStyle/>
           <a:p>
-            <a:pPr algn="l">
+            <a:pPr algn="l" marL="201168" indent="-201168">
               <a:lnSpc>
                 <a:spcPct val="125000"/>
               </a:lnSpc>
@@ -13969,6 +14363,8 @@
                   <a:srgbClr val="E0A458"/>
                 </a:solidFill>
                 <a:latin typeface="Tahoma"/>
+                <a:ea typeface="Tahoma"/>
+                <a:cs typeface="Tahoma"/>
               </a:rPr>
               <a:t>•  </a:t>
             </a:r>
@@ -13978,12 +14374,14 @@
                   <a:srgbClr val="1F2C3D"/>
                 </a:solidFill>
                 <a:latin typeface="Tahoma"/>
+                <a:ea typeface="Tahoma"/>
+                <a:cs typeface="Tahoma"/>
               </a:rPr>
               <a:t>ข้อมูลดิบ 119,390 แถว × 32 คอลัมน์</a:t>
             </a:r>
           </a:p>
           <a:p>
-            <a:pPr algn="l">
+            <a:pPr algn="l" marL="201168" indent="-201168">
               <a:lnSpc>
                 <a:spcPct val="125000"/>
               </a:lnSpc>
@@ -13997,6 +14395,8 @@
                   <a:srgbClr val="E0A458"/>
                 </a:solidFill>
                 <a:latin typeface="Tahoma"/>
+                <a:ea typeface="Tahoma"/>
+                <a:cs typeface="Tahoma"/>
               </a:rPr>
               <a:t>•  </a:t>
             </a:r>
@@ -14006,12 +14406,14 @@
                   <a:srgbClr val="1F2C3D"/>
                 </a:solidFill>
                 <a:latin typeface="Tahoma"/>
+                <a:ea typeface="Tahoma"/>
+                <a:cs typeface="Tahoma"/>
               </a:rPr>
               <a:t>ยกเลิก 44,224 รายการ : ไม่ยกเลิก 75,166 รายการ</a:t>
             </a:r>
           </a:p>
           <a:p>
-            <a:pPr algn="l">
+            <a:pPr algn="l" marL="201168" indent="-201168">
               <a:lnSpc>
                 <a:spcPct val="125000"/>
               </a:lnSpc>
@@ -14025,6 +14427,8 @@
                   <a:srgbClr val="E0A458"/>
                 </a:solidFill>
                 <a:latin typeface="Tahoma"/>
+                <a:ea typeface="Tahoma"/>
+                <a:cs typeface="Tahoma"/>
               </a:rPr>
               <a:t>•  </a:t>
             </a:r>
@@ -14034,6 +14438,8 @@
                   <a:srgbClr val="1F2C3D"/>
                 </a:solidFill>
                 <a:latin typeface="Tahoma"/>
+                <a:ea typeface="Tahoma"/>
+                <a:cs typeface="Tahoma"/>
               </a:rPr>
               <a:t>สัดส่วนคลาสไม่สมดุล 37 : 63</a:t>
             </a:r>
@@ -14122,6 +14528,8 @@
                   <a:srgbClr val="E0A458"/>
                 </a:solidFill>
                 <a:latin typeface="Tahoma"/>
+                <a:ea typeface="Tahoma"/>
+                <a:cs typeface="Tahoma"/>
               </a:rPr>
               <a:t>ประโยคสำคัญ: </a:t>
             </a:r>
@@ -14141,6 +14549,8 @@
                   <a:srgbClr val="0F2038"/>
                 </a:solidFill>
                 <a:latin typeface="Tahoma"/>
+                <a:ea typeface="Tahoma"/>
+                <a:cs typeface="Tahoma"/>
               </a:rPr>
               <a:t>“นี่คือเหตุผลที่เราไม่ใช้ Accuracy เป็นตัวชี้วัดหลัก </a:t>
             </a:r>
@@ -14150,6 +14560,8 @@
                   <a:srgbClr val="0F2038"/>
                 </a:solidFill>
                 <a:latin typeface="Tahoma"/>
+                <a:ea typeface="Tahoma"/>
+                <a:cs typeface="Tahoma"/>
               </a:rPr>
               <a:t>เพราะโมเดลที่ไม่ได้เรียนรู้อะไรเลยก็ทำคะแนนนี้ได้”</a:t>
             </a:r>
@@ -14265,6 +14677,8 @@
                   <a:srgbClr val="0F2038"/>
                 </a:solidFill>
                 <a:latin typeface="Tahoma"/>
+                <a:ea typeface="Tahoma"/>
+                <a:cs typeface="Tahoma"/>
               </a:rPr>
               <a:t>4</a:t>
             </a:r>
@@ -14307,6 +14721,8 @@
                   <a:srgbClr val="E0A458"/>
                 </a:solidFill>
                 <a:latin typeface="Tahoma"/>
+                <a:ea typeface="Tahoma"/>
+                <a:cs typeface="Tahoma"/>
               </a:rPr>
               <a:t>EDA</a:t>
             </a:r>
@@ -14349,6 +14765,8 @@
                   <a:srgbClr val="0F2038"/>
                 </a:solidFill>
                 <a:latin typeface="Tahoma"/>
+                <a:ea typeface="Tahoma"/>
+                <a:cs typeface="Tahoma"/>
               </a:rPr>
               <a:t>ประเภทมัดจำและช่องทางการจองต่างกันอย่างชัดเจน</a:t>
             </a:r>
@@ -14401,7 +14819,7 @@
           </a:bodyPr>
           <a:lstStyle/>
           <a:p>
-            <a:pPr algn="l">
+            <a:pPr algn="l" marL="201168" indent="-201168">
               <a:lnSpc>
                 <a:spcPct val="125000"/>
               </a:lnSpc>
@@ -14415,6 +14833,8 @@
                   <a:srgbClr val="E0A458"/>
                 </a:solidFill>
                 <a:latin typeface="Tahoma"/>
+                <a:ea typeface="Tahoma"/>
+                <a:cs typeface="Tahoma"/>
               </a:rPr>
               <a:t>•  </a:t>
             </a:r>
@@ -14424,6 +14844,8 @@
                   <a:srgbClr val="0F2038"/>
                 </a:solidFill>
                 <a:latin typeface="Tahoma"/>
+                <a:ea typeface="Tahoma"/>
+                <a:cs typeface="Tahoma"/>
               </a:rPr>
               <a:t>Non Refund </a:t>
             </a:r>
@@ -14433,12 +14855,14 @@
                   <a:srgbClr val="1F2C3D"/>
                 </a:solidFill>
                 <a:latin typeface="Tahoma"/>
+                <a:ea typeface="Tahoma"/>
+                <a:cs typeface="Tahoma"/>
               </a:rPr>
               <a:t>ยกเลิกเกือบ 100% ทั้งที่จ่ายเงินไปแล้ว</a:t>
             </a:r>
           </a:p>
           <a:p>
-            <a:pPr algn="l">
+            <a:pPr algn="l" marL="201168" indent="-201168">
               <a:lnSpc>
                 <a:spcPct val="125000"/>
               </a:lnSpc>
@@ -14452,6 +14876,8 @@
                   <a:srgbClr val="E0A458"/>
                 </a:solidFill>
                 <a:latin typeface="Tahoma"/>
+                <a:ea typeface="Tahoma"/>
+                <a:cs typeface="Tahoma"/>
               </a:rPr>
               <a:t>•  </a:t>
             </a:r>
@@ -14461,6 +14887,8 @@
                   <a:srgbClr val="0F2038"/>
                 </a:solidFill>
                 <a:latin typeface="Tahoma"/>
+                <a:ea typeface="Tahoma"/>
+                <a:cs typeface="Tahoma"/>
               </a:rPr>
               <a:t>Groups </a:t>
             </a:r>
@@ -14470,12 +14898,14 @@
                   <a:srgbClr val="1F2C3D"/>
                 </a:solidFill>
                 <a:latin typeface="Tahoma"/>
+                <a:ea typeface="Tahoma"/>
+                <a:cs typeface="Tahoma"/>
               </a:rPr>
               <a:t>ยกเลิกสูงกว่าการจองแบบอื่นชัดเจน</a:t>
             </a:r>
           </a:p>
           <a:p>
-            <a:pPr algn="l">
+            <a:pPr algn="l" marL="201168" indent="-201168">
               <a:lnSpc>
                 <a:spcPct val="125000"/>
               </a:lnSpc>
@@ -14489,6 +14919,8 @@
                   <a:srgbClr val="E0A458"/>
                 </a:solidFill>
                 <a:latin typeface="Tahoma"/>
+                <a:ea typeface="Tahoma"/>
+                <a:cs typeface="Tahoma"/>
               </a:rPr>
               <a:t>•  </a:t>
             </a:r>
@@ -14498,6 +14930,8 @@
                   <a:srgbClr val="1F2C3D"/>
                 </a:solidFill>
                 <a:latin typeface="Tahoma"/>
+                <a:ea typeface="Tahoma"/>
+                <a:cs typeface="Tahoma"/>
               </a:rPr>
               <a:t>เส้นประแดง = อัตรายกเลิกเฉลี่ยทั้งชุดข้อมูล</a:t>
             </a:r>
@@ -14540,6 +14974,8 @@
                   <a:srgbClr val="6B7A8C"/>
                 </a:solidFill>
                 <a:latin typeface="Tahoma"/>
+                <a:ea typeface="Tahoma"/>
+                <a:cs typeface="Tahoma"/>
               </a:rPr>
               <a:t>ทุกกราฟคำนวณจากข้อมูลจริงทั้ง 119,390 แถว</a:t>
             </a:r>
@@ -14655,6 +15091,8 @@
                   <a:srgbClr val="0F2038"/>
                 </a:solidFill>
                 <a:latin typeface="Tahoma"/>
+                <a:ea typeface="Tahoma"/>
+                <a:cs typeface="Tahoma"/>
               </a:rPr>
               <a:t>5</a:t>
             </a:r>
@@ -14697,6 +15135,8 @@
                   <a:srgbClr val="E0A458"/>
                 </a:solidFill>
                 <a:latin typeface="Tahoma"/>
+                <a:ea typeface="Tahoma"/>
+                <a:cs typeface="Tahoma"/>
               </a:rPr>
               <a:t>DATA PREPARATION</a:t>
             </a:r>
@@ -14739,6 +15179,8 @@
                   <a:srgbClr val="0F2038"/>
                 </a:solidFill>
                 <a:latin typeface="Tahoma"/>
+                <a:ea typeface="Tahoma"/>
+                <a:cs typeface="Tahoma"/>
               </a:rPr>
               <a:t>ทำความสะอาดข้อมูลโดยเสียข้อมูลเพียง 0.15%</a:t>
             </a:r>
@@ -14754,7 +15196,7 @@
         <p:spPr>
           <a:xfrm>
             <a:off x="548640" y="1554480"/>
-            <a:ext cx="7315200" cy="384048"/>
+            <a:ext cx="7315200" cy="566928"/>
           </a:xfrm>
           <a:prstGeom prst="rect">
             <a:avLst/>
@@ -14798,7 +15240,7 @@
         <p:spPr>
           <a:xfrm>
             <a:off x="658368" y="1627632"/>
-            <a:ext cx="2889504" cy="292608"/>
+            <a:ext cx="2889504" cy="475488"/>
           </a:xfrm>
           <a:prstGeom prst="rect">
             <a:avLst/>
@@ -14825,6 +15267,8 @@
                   <a:srgbClr val="FFFFFF"/>
                 </a:solidFill>
                 <a:latin typeface="Tahoma"/>
+                <a:ea typeface="Tahoma"/>
+                <a:cs typeface="Tahoma"/>
               </a:rPr>
               <a:t>ปัญหาที่พบ</a:t>
             </a:r>
@@ -14840,7 +15284,7 @@
         <p:spPr>
           <a:xfrm>
             <a:off x="3767328" y="1627632"/>
-            <a:ext cx="2706624" cy="292608"/>
+            <a:ext cx="2706624" cy="475488"/>
           </a:xfrm>
           <a:prstGeom prst="rect">
             <a:avLst/>
@@ -14867,6 +15311,8 @@
                   <a:srgbClr val="FFFFFF"/>
                 </a:solidFill>
                 <a:latin typeface="Tahoma"/>
+                <a:ea typeface="Tahoma"/>
+                <a:cs typeface="Tahoma"/>
               </a:rPr>
               <a:t>วิธีจัดการ</a:t>
             </a:r>
@@ -14882,7 +15328,7 @@
         <p:spPr>
           <a:xfrm>
             <a:off x="6693408" y="1627632"/>
-            <a:ext cx="1060704" cy="292608"/>
+            <a:ext cx="1060704" cy="475488"/>
           </a:xfrm>
           <a:prstGeom prst="rect">
             <a:avLst/>
@@ -14909,6 +15355,8 @@
                   <a:srgbClr val="FFFFFF"/>
                 </a:solidFill>
                 <a:latin typeface="Tahoma"/>
+                <a:ea typeface="Tahoma"/>
+                <a:cs typeface="Tahoma"/>
               </a:rPr>
               <a:t>แถวที่เสีย</a:t>
             </a:r>
@@ -14923,8 +15371,8 @@
         </p:nvSpPr>
         <p:spPr>
           <a:xfrm>
-            <a:off x="658368" y="2011680"/>
-            <a:ext cx="2889504" cy="292608"/>
+            <a:off x="658368" y="2194560"/>
+            <a:ext cx="2889504" cy="475488"/>
           </a:xfrm>
           <a:prstGeom prst="rect">
             <a:avLst/>
@@ -14951,6 +15399,8 @@
                   <a:srgbClr val="1F2C3D"/>
                 </a:solidFill>
                 <a:latin typeface="Tahoma"/>
+                <a:ea typeface="Tahoma"/>
+                <a:cs typeface="Tahoma"/>
               </a:rPr>
               <a:t>children ว่าง 4 ค่า</a:t>
             </a:r>
@@ -14965,8 +15415,8 @@
         </p:nvSpPr>
         <p:spPr>
           <a:xfrm>
-            <a:off x="3767328" y="2011680"/>
-            <a:ext cx="2706624" cy="292608"/>
+            <a:off x="3767328" y="2194560"/>
+            <a:ext cx="2706624" cy="475488"/>
           </a:xfrm>
           <a:prstGeom prst="rect">
             <a:avLst/>
@@ -14993,6 +15443,8 @@
                   <a:srgbClr val="1F2C3D"/>
                 </a:solidFill>
                 <a:latin typeface="Tahoma"/>
+                <a:ea typeface="Tahoma"/>
+                <a:cs typeface="Tahoma"/>
               </a:rPr>
               <a:t>เติมด้วย 0</a:t>
             </a:r>
@@ -15007,8 +15459,8 @@
         </p:nvSpPr>
         <p:spPr>
           <a:xfrm>
-            <a:off x="6693408" y="2011680"/>
-            <a:ext cx="1060704" cy="292608"/>
+            <a:off x="6693408" y="2194560"/>
+            <a:ext cx="1060704" cy="475488"/>
           </a:xfrm>
           <a:prstGeom prst="rect">
             <a:avLst/>
@@ -15035,6 +15487,8 @@
                   <a:srgbClr val="1F2C3D"/>
                 </a:solidFill>
                 <a:latin typeface="Tahoma"/>
+                <a:ea typeface="Tahoma"/>
+                <a:cs typeface="Tahoma"/>
               </a:rPr>
               <a:t>0</a:t>
             </a:r>
@@ -15049,8 +15503,8 @@
         </p:nvSpPr>
         <p:spPr>
           <a:xfrm>
-            <a:off x="548640" y="2322576"/>
-            <a:ext cx="7315200" cy="384048"/>
+            <a:off x="548640" y="2688336"/>
+            <a:ext cx="7315200" cy="566928"/>
           </a:xfrm>
           <a:prstGeom prst="rect">
             <a:avLst/>
@@ -15093,8 +15547,8 @@
         </p:nvSpPr>
         <p:spPr>
           <a:xfrm>
-            <a:off x="658368" y="2395728"/>
-            <a:ext cx="2889504" cy="292608"/>
+            <a:off x="658368" y="2761488"/>
+            <a:ext cx="2889504" cy="475488"/>
           </a:xfrm>
           <a:prstGeom prst="rect">
             <a:avLst/>
@@ -15121,6 +15575,8 @@
                   <a:srgbClr val="1F2C3D"/>
                 </a:solidFill>
                 <a:latin typeface="Tahoma"/>
+                <a:ea typeface="Tahoma"/>
+                <a:cs typeface="Tahoma"/>
               </a:rPr>
               <a:t>country ว่าง 488 ค่า</a:t>
             </a:r>
@@ -15135,8 +15591,8 @@
         </p:nvSpPr>
         <p:spPr>
           <a:xfrm>
-            <a:off x="3767328" y="2395728"/>
-            <a:ext cx="2706624" cy="292608"/>
+            <a:off x="3767328" y="2761488"/>
+            <a:ext cx="2706624" cy="475488"/>
           </a:xfrm>
           <a:prstGeom prst="rect">
             <a:avLst/>
@@ -15163,6 +15619,8 @@
                   <a:srgbClr val="1F2C3D"/>
                 </a:solidFill>
                 <a:latin typeface="Tahoma"/>
+                <a:ea typeface="Tahoma"/>
+                <a:cs typeface="Tahoma"/>
               </a:rPr>
               <a:t>แทนด้วย Unknown</a:t>
             </a:r>
@@ -15177,8 +15635,8 @@
         </p:nvSpPr>
         <p:spPr>
           <a:xfrm>
-            <a:off x="6693408" y="2395728"/>
-            <a:ext cx="1060704" cy="292608"/>
+            <a:off x="6693408" y="2761488"/>
+            <a:ext cx="1060704" cy="475488"/>
           </a:xfrm>
           <a:prstGeom prst="rect">
             <a:avLst/>
@@ -15205,6 +15663,8 @@
                   <a:srgbClr val="1F2C3D"/>
                 </a:solidFill>
                 <a:latin typeface="Tahoma"/>
+                <a:ea typeface="Tahoma"/>
+                <a:cs typeface="Tahoma"/>
               </a:rPr>
               <a:t>0</a:t>
             </a:r>
@@ -15219,8 +15679,8 @@
         </p:nvSpPr>
         <p:spPr>
           <a:xfrm>
-            <a:off x="658368" y="2779776"/>
-            <a:ext cx="2889504" cy="292608"/>
+            <a:off x="658368" y="3328416"/>
+            <a:ext cx="2889504" cy="475488"/>
           </a:xfrm>
           <a:prstGeom prst="rect">
             <a:avLst/>
@@ -15247,6 +15707,8 @@
                   <a:srgbClr val="1F2C3D"/>
                 </a:solidFill>
                 <a:latin typeface="Tahoma"/>
+                <a:ea typeface="Tahoma"/>
+                <a:cs typeface="Tahoma"/>
               </a:rPr>
               <a:t>agent / company ว่าง</a:t>
             </a:r>
@@ -15261,8 +15723,8 @@
         </p:nvSpPr>
         <p:spPr>
           <a:xfrm>
-            <a:off x="3767328" y="2779776"/>
-            <a:ext cx="2706624" cy="292608"/>
+            <a:off x="3767328" y="3328416"/>
+            <a:ext cx="2706624" cy="475488"/>
           </a:xfrm>
           <a:prstGeom prst="rect">
             <a:avLst/>
@@ -15289,6 +15751,8 @@
                   <a:srgbClr val="1F2C3D"/>
                 </a:solidFill>
                 <a:latin typeface="Tahoma"/>
+                <a:ea typeface="Tahoma"/>
+                <a:cs typeface="Tahoma"/>
               </a:rPr>
               <a:t>แปลงเป็น flag มี/ไม่มี</a:t>
             </a:r>
@@ -15303,8 +15767,8 @@
         </p:nvSpPr>
         <p:spPr>
           <a:xfrm>
-            <a:off x="6693408" y="2779776"/>
-            <a:ext cx="1060704" cy="292608"/>
+            <a:off x="6693408" y="3328416"/>
+            <a:ext cx="1060704" cy="475488"/>
           </a:xfrm>
           <a:prstGeom prst="rect">
             <a:avLst/>
@@ -15331,6 +15795,8 @@
                   <a:srgbClr val="1F2C3D"/>
                 </a:solidFill>
                 <a:latin typeface="Tahoma"/>
+                <a:ea typeface="Tahoma"/>
+                <a:cs typeface="Tahoma"/>
               </a:rPr>
               <a:t>0</a:t>
             </a:r>
@@ -15345,8 +15811,8 @@
         </p:nvSpPr>
         <p:spPr>
           <a:xfrm>
-            <a:off x="548640" y="3090672"/>
-            <a:ext cx="7315200" cy="384048"/>
+            <a:off x="548640" y="3822192"/>
+            <a:ext cx="7315200" cy="566928"/>
           </a:xfrm>
           <a:prstGeom prst="rect">
             <a:avLst/>
@@ -15389,8 +15855,8 @@
         </p:nvSpPr>
         <p:spPr>
           <a:xfrm>
-            <a:off x="658368" y="3163824"/>
-            <a:ext cx="2889504" cy="292608"/>
+            <a:off x="658368" y="3895344"/>
+            <a:ext cx="2889504" cy="475488"/>
           </a:xfrm>
           <a:prstGeom prst="rect">
             <a:avLst/>
@@ -15417,6 +15883,8 @@
                   <a:srgbClr val="1F2C3D"/>
                 </a:solidFill>
                 <a:latin typeface="Tahoma"/>
+                <a:ea typeface="Tahoma"/>
+                <a:cs typeface="Tahoma"/>
               </a:rPr>
               <a:t>ไม่มีผู้เข้าพัก</a:t>
             </a:r>
@@ -15431,8 +15899,8 @@
         </p:nvSpPr>
         <p:spPr>
           <a:xfrm>
-            <a:off x="3767328" y="3163824"/>
-            <a:ext cx="2706624" cy="292608"/>
+            <a:off x="3767328" y="3895344"/>
+            <a:ext cx="2706624" cy="475488"/>
           </a:xfrm>
           <a:prstGeom prst="rect">
             <a:avLst/>
@@ -15459,6 +15927,8 @@
                   <a:srgbClr val="1F2C3D"/>
                 </a:solidFill>
                 <a:latin typeface="Tahoma"/>
+                <a:ea typeface="Tahoma"/>
+                <a:cs typeface="Tahoma"/>
               </a:rPr>
               <a:t>ลบแถวทิ้ง</a:t>
             </a:r>
@@ -15473,8 +15943,8 @@
         </p:nvSpPr>
         <p:spPr>
           <a:xfrm>
-            <a:off x="6693408" y="3163824"/>
-            <a:ext cx="1060704" cy="292608"/>
+            <a:off x="6693408" y="3895344"/>
+            <a:ext cx="1060704" cy="475488"/>
           </a:xfrm>
           <a:prstGeom prst="rect">
             <a:avLst/>
@@ -15501,6 +15971,8 @@
                   <a:srgbClr val="0F2038"/>
                 </a:solidFill>
                 <a:latin typeface="Tahoma"/>
+                <a:ea typeface="Tahoma"/>
+                <a:cs typeface="Tahoma"/>
               </a:rPr>
               <a:t>180</a:t>
             </a:r>
@@ -15515,8 +15987,8 @@
         </p:nvSpPr>
         <p:spPr>
           <a:xfrm>
-            <a:off x="658368" y="3547872"/>
-            <a:ext cx="2889504" cy="292608"/>
+            <a:off x="658368" y="4462272"/>
+            <a:ext cx="2889504" cy="475488"/>
           </a:xfrm>
           <a:prstGeom prst="rect">
             <a:avLst/>
@@ -15543,6 +16015,8 @@
                   <a:srgbClr val="1F2C3D"/>
                 </a:solidFill>
                 <a:latin typeface="Tahoma"/>
+                <a:ea typeface="Tahoma"/>
+                <a:cs typeface="Tahoma"/>
               </a:rPr>
               <a:t>adr ติดลบ / เกิน 1,000</a:t>
             </a:r>
@@ -15557,8 +16031,8 @@
         </p:nvSpPr>
         <p:spPr>
           <a:xfrm>
-            <a:off x="3767328" y="3547872"/>
-            <a:ext cx="2706624" cy="292608"/>
+            <a:off x="3767328" y="4462272"/>
+            <a:ext cx="2706624" cy="475488"/>
           </a:xfrm>
           <a:prstGeom prst="rect">
             <a:avLst/>
@@ -15585,6 +16059,8 @@
                   <a:srgbClr val="1F2C3D"/>
                 </a:solidFill>
                 <a:latin typeface="Tahoma"/>
+                <a:ea typeface="Tahoma"/>
+                <a:cs typeface="Tahoma"/>
               </a:rPr>
               <a:t>ลบแถวทิ้ง</a:t>
             </a:r>
@@ -15599,8 +16075,8 @@
         </p:nvSpPr>
         <p:spPr>
           <a:xfrm>
-            <a:off x="6693408" y="3547872"/>
-            <a:ext cx="1060704" cy="292608"/>
+            <a:off x="6693408" y="4462272"/>
+            <a:ext cx="1060704" cy="475488"/>
           </a:xfrm>
           <a:prstGeom prst="rect">
             <a:avLst/>
@@ -15627,6 +16103,8 @@
                   <a:srgbClr val="0F2038"/>
                 </a:solidFill>
                 <a:latin typeface="Tahoma"/>
+                <a:ea typeface="Tahoma"/>
+                <a:cs typeface="Tahoma"/>
               </a:rPr>
               <a:t>2</a:t>
             </a:r>
@@ -15641,8 +16119,8 @@
         </p:nvSpPr>
         <p:spPr>
           <a:xfrm>
-            <a:off x="8229600" y="1554480"/>
-            <a:ext cx="3383280" cy="1188720"/>
+            <a:off x="8229600" y="1572768"/>
+            <a:ext cx="3383280" cy="1463040"/>
           </a:xfrm>
           <a:prstGeom prst="roundRect">
             <a:avLst>
@@ -15687,8 +16165,8 @@
         </p:nvSpPr>
         <p:spPr>
           <a:xfrm>
-            <a:off x="8339328" y="1664208"/>
-            <a:ext cx="3163824" cy="621792"/>
+            <a:off x="8339328" y="1682496"/>
+            <a:ext cx="3163824" cy="896112"/>
           </a:xfrm>
           <a:prstGeom prst="rect">
             <a:avLst/>
@@ -15715,6 +16193,8 @@
                   <a:srgbClr val="0F2038"/>
                 </a:solidFill>
                 <a:latin typeface="Tahoma"/>
+                <a:ea typeface="Tahoma"/>
+                <a:cs typeface="Tahoma"/>
               </a:rPr>
               <a:t>119,390 → 119,208</a:t>
             </a:r>
@@ -15729,7 +16209,7 @@
         </p:nvSpPr>
         <p:spPr>
           <a:xfrm>
-            <a:off x="8339328" y="2395728"/>
+            <a:off x="8339328" y="2688336"/>
             <a:ext cx="3163824" cy="274320"/>
           </a:xfrm>
           <a:prstGeom prst="rect">
@@ -15757,6 +16237,8 @@
                   <a:srgbClr val="6B7A8C"/>
                 </a:solidFill>
                 <a:latin typeface="Tahoma"/>
+                <a:ea typeface="Tahoma"/>
+                <a:cs typeface="Tahoma"/>
               </a:rPr>
               <a:t>จำนวนแถวก่อน → หลังคลีน</a:t>
             </a:r>
@@ -15771,8 +16253,8 @@
         </p:nvSpPr>
         <p:spPr>
           <a:xfrm>
-            <a:off x="8229600" y="2926080"/>
-            <a:ext cx="3383280" cy="1188720"/>
+            <a:off x="8229600" y="3200400"/>
+            <a:ext cx="3383280" cy="1463040"/>
           </a:xfrm>
           <a:prstGeom prst="roundRect">
             <a:avLst>
@@ -15817,8 +16299,8 @@
         </p:nvSpPr>
         <p:spPr>
           <a:xfrm>
-            <a:off x="8339328" y="3035808"/>
-            <a:ext cx="3163824" cy="621792"/>
+            <a:off x="8339328" y="3310128"/>
+            <a:ext cx="3163824" cy="896112"/>
           </a:xfrm>
           <a:prstGeom prst="rect">
             <a:avLst/>
@@ -15845,6 +16327,8 @@
                   <a:srgbClr val="E0A458"/>
                 </a:solidFill>
                 <a:latin typeface="Tahoma"/>
+                <a:ea typeface="Tahoma"/>
+                <a:cs typeface="Tahoma"/>
               </a:rPr>
               <a:t>182 แถว</a:t>
             </a:r>
@@ -15859,7 +16343,7 @@
         </p:nvSpPr>
         <p:spPr>
           <a:xfrm>
-            <a:off x="8339328" y="3767328"/>
+            <a:off x="8339328" y="4315968"/>
             <a:ext cx="3163824" cy="274320"/>
           </a:xfrm>
           <a:prstGeom prst="rect">
@@ -15887,6 +16371,8 @@
                   <a:srgbClr val="6B7A8C"/>
                 </a:solidFill>
                 <a:latin typeface="Tahoma"/>
+                <a:ea typeface="Tahoma"/>
+                <a:cs typeface="Tahoma"/>
               </a:rPr>
               <a:t>ลบทิ้งทั้งหมด คิดเป็น 0.15%</a:t>
             </a:r>
@@ -15901,7 +16387,7 @@
         </p:nvSpPr>
         <p:spPr>
           <a:xfrm>
-            <a:off x="8229600" y="4343400"/>
+            <a:off x="8229600" y="4892040"/>
             <a:ext cx="3383280" cy="1097280"/>
           </a:xfrm>
           <a:prstGeom prst="rect">
@@ -15929,6 +16415,8 @@
                   <a:srgbClr val="6B7A8C"/>
                 </a:solidFill>
                 <a:latin typeface="Tahoma"/>
+                <a:ea typeface="Tahoma"/>
+                <a:cs typeface="Tahoma"/>
               </a:rPr>
               <a:t>อัตรายกเลิกหลังคลีน 37.08%
 แทบไม่ต่างจาก 37.04% ก่อนคลีน
@@ -15945,7 +16433,7 @@
         </p:nvSpPr>
         <p:spPr>
           <a:xfrm>
-            <a:off x="548640" y="4133088"/>
+            <a:off x="548640" y="5230368"/>
             <a:ext cx="7315200" cy="548640"/>
           </a:xfrm>
           <a:prstGeom prst="rect">
@@ -15973,6 +16461,8 @@
                   <a:srgbClr val="6B7A8C"/>
                 </a:solidFill>
                 <a:latin typeface="Tahoma"/>
+                <a:ea typeface="Tahoma"/>
+                <a:cs typeface="Tahoma"/>
               </a:rPr>
               <a:t>ค่าว่างใน agent / company ตามเปเปอร์ต้นฉบับแปลว่า “ไม่เกี่ยวข้อง” ไม่ใช่ข้อมูลหาย จึงทำเป็น flag แทนการเติมค่า</a:t>
             </a:r>
@@ -16088,6 +16578,8 @@
                   <a:srgbClr val="0F2038"/>
                 </a:solidFill>
                 <a:latin typeface="Tahoma"/>
+                <a:ea typeface="Tahoma"/>
+                <a:cs typeface="Tahoma"/>
               </a:rPr>
               <a:t>6</a:t>
             </a:r>
@@ -16130,6 +16622,8 @@
                   <a:srgbClr val="E0A458"/>
                 </a:solidFill>
                 <a:latin typeface="Tahoma"/>
+                <a:ea typeface="Tahoma"/>
+                <a:cs typeface="Tahoma"/>
               </a:rPr>
               <a:t>DATA LEAKAGE</a:t>
             </a:r>
@@ -16172,6 +16666,8 @@
                   <a:srgbClr val="0F2038"/>
                 </a:solidFill>
                 <a:latin typeface="Tahoma"/>
+                <a:ea typeface="Tahoma"/>
+                <a:cs typeface="Tahoma"/>
               </a:rPr>
               <a:t>ตัด 3 คอลัมน์ที่แอบรู้คำตอบ ก่อนแบ่งข้อมูล</a:t>
             </a:r>
@@ -16260,6 +16756,8 @@
                   <a:srgbClr val="B33A3A"/>
                 </a:solidFill>
                 <a:latin typeface="Tahoma"/>
+                <a:ea typeface="Tahoma"/>
+                <a:cs typeface="Tahoma"/>
               </a:rPr>
               <a:t>คอลัมน์ที่ตัดออก</a:t>
             </a:r>
@@ -16288,7 +16786,7 @@
           </a:bodyPr>
           <a:lstStyle/>
           <a:p>
-            <a:pPr algn="l">
+            <a:pPr algn="l" marL="201168" indent="-201168">
               <a:lnSpc>
                 <a:spcPct val="125000"/>
               </a:lnSpc>
@@ -16302,6 +16800,8 @@
                   <a:srgbClr val="E0A458"/>
                 </a:solidFill>
                 <a:latin typeface="Tahoma"/>
+                <a:ea typeface="Tahoma"/>
+                <a:cs typeface="Tahoma"/>
               </a:rPr>
               <a:t>•  </a:t>
             </a:r>
@@ -16311,12 +16811,14 @@
                   <a:srgbClr val="1F2C3D"/>
                 </a:solidFill>
                 <a:latin typeface="Tahoma"/>
+                <a:ea typeface="Tahoma"/>
+                <a:cs typeface="Tahoma"/>
               </a:rPr>
               <a:t>reservation_status — บอกผลลัพธ์ตรงๆ</a:t>
             </a:r>
           </a:p>
           <a:p>
-            <a:pPr algn="l">
+            <a:pPr algn="l" marL="201168" indent="-201168">
               <a:lnSpc>
                 <a:spcPct val="125000"/>
               </a:lnSpc>
@@ -16330,6 +16832,8 @@
                   <a:srgbClr val="E0A458"/>
                 </a:solidFill>
                 <a:latin typeface="Tahoma"/>
+                <a:ea typeface="Tahoma"/>
+                <a:cs typeface="Tahoma"/>
               </a:rPr>
               <a:t>•  </a:t>
             </a:r>
@@ -16339,12 +16843,14 @@
                   <a:srgbClr val="1F2C3D"/>
                 </a:solidFill>
                 <a:latin typeface="Tahoma"/>
+                <a:ea typeface="Tahoma"/>
+                <a:cs typeface="Tahoma"/>
               </a:rPr>
               <a:t>reservation_status_date — วันที่ผลลัพธ์เกิดขึ้น</a:t>
             </a:r>
           </a:p>
           <a:p>
-            <a:pPr algn="l">
+            <a:pPr algn="l" marL="201168" indent="-201168">
               <a:lnSpc>
                 <a:spcPct val="125000"/>
               </a:lnSpc>
@@ -16358,6 +16864,8 @@
                   <a:srgbClr val="E0A458"/>
                 </a:solidFill>
                 <a:latin typeface="Tahoma"/>
+                <a:ea typeface="Tahoma"/>
+                <a:cs typeface="Tahoma"/>
               </a:rPr>
               <a:t>•  </a:t>
             </a:r>
@@ -16367,6 +16875,8 @@
                   <a:srgbClr val="1F2C3D"/>
                 </a:solidFill>
                 <a:latin typeface="Tahoma"/>
+                <a:ea typeface="Tahoma"/>
+                <a:cs typeface="Tahoma"/>
               </a:rPr>
               <a:t>assigned_room_type — ห้องถูกกำหนดตอนเช็คอิน</a:t>
             </a:r>
@@ -16409,6 +16919,8 @@
                   <a:srgbClr val="B33A3A"/>
                 </a:solidFill>
                 <a:latin typeface="Tahoma"/>
+                <a:ea typeface="Tahoma"/>
+                <a:cs typeface="Tahoma"/>
               </a:rPr>
               <a:t>หลักฐาน: </a:t>
             </a:r>
@@ -16418,6 +16930,8 @@
                   <a:srgbClr val="0F2038"/>
                 </a:solidFill>
                 <a:latin typeface="Tahoma"/>
+                <a:ea typeface="Tahoma"/>
+                <a:cs typeface="Tahoma"/>
               </a:rPr>
               <a:t>การจองที่ถูกเปลี่ยนห้องมีอัตรายกเลิก 0% → รู้ผลหลังเช็คอินแล้ว</a:t>
             </a:r>
@@ -16460,6 +16974,8 @@
                   <a:srgbClr val="0F2038"/>
                 </a:solidFill>
                 <a:latin typeface="Tahoma"/>
+                <a:ea typeface="Tahoma"/>
+                <a:cs typeface="Tahoma"/>
               </a:rPr>
               <a:t>แบ่งข้อมูล 2 แบบ</a:t>
             </a:r>
@@ -16546,6 +17062,8 @@
                   <a:srgbClr val="FFFFFF"/>
                 </a:solidFill>
                 <a:latin typeface="Tahoma"/>
+                <a:ea typeface="Tahoma"/>
+                <a:cs typeface="Tahoma"/>
               </a:rPr>
               <a:t>วิธีแบ่ง</a:t>
             </a:r>
@@ -16588,6 +17106,8 @@
                   <a:srgbClr val="FFFFFF"/>
                 </a:solidFill>
                 <a:latin typeface="Tahoma"/>
+                <a:ea typeface="Tahoma"/>
+                <a:cs typeface="Tahoma"/>
               </a:rPr>
               <a:t>Train</a:t>
             </a:r>
@@ -16630,6 +17150,8 @@
                   <a:srgbClr val="FFFFFF"/>
                 </a:solidFill>
                 <a:latin typeface="Tahoma"/>
+                <a:ea typeface="Tahoma"/>
+                <a:cs typeface="Tahoma"/>
               </a:rPr>
               <a:t>Test</a:t>
             </a:r>
@@ -16672,6 +17194,8 @@
                   <a:srgbClr val="1F2C3D"/>
                 </a:solidFill>
                 <a:latin typeface="Tahoma"/>
+                <a:ea typeface="Tahoma"/>
+                <a:cs typeface="Tahoma"/>
               </a:rPr>
               <a:t>Stratified Random 80/20</a:t>
             </a:r>
@@ -16714,6 +17238,8 @@
                   <a:srgbClr val="1F2C3D"/>
                 </a:solidFill>
                 <a:latin typeface="Tahoma"/>
+                <a:ea typeface="Tahoma"/>
+                <a:cs typeface="Tahoma"/>
               </a:rPr>
               <a:t>95,366</a:t>
             </a:r>
@@ -16756,6 +17282,8 @@
                   <a:srgbClr val="1F2C3D"/>
                 </a:solidFill>
                 <a:latin typeface="Tahoma"/>
+                <a:ea typeface="Tahoma"/>
+                <a:cs typeface="Tahoma"/>
               </a:rPr>
               <a:t>23,842</a:t>
             </a:r>
@@ -16842,6 +17370,8 @@
                   <a:srgbClr val="1F2C3D"/>
                 </a:solidFill>
                 <a:latin typeface="Tahoma"/>
+                <a:ea typeface="Tahoma"/>
+                <a:cs typeface="Tahoma"/>
               </a:rPr>
               <a:t>Time-based (ตามเวลา)</a:t>
             </a:r>
@@ -16884,6 +17414,8 @@
                   <a:srgbClr val="1F2C3D"/>
                 </a:solidFill>
                 <a:latin typeface="Tahoma"/>
+                <a:ea typeface="Tahoma"/>
+                <a:cs typeface="Tahoma"/>
               </a:rPr>
               <a:t>95,190</a:t>
             </a:r>
@@ -16926,6 +17458,8 @@
                   <a:srgbClr val="1F2C3D"/>
                 </a:solidFill>
                 <a:latin typeface="Tahoma"/>
+                <a:ea typeface="Tahoma"/>
+                <a:cs typeface="Tahoma"/>
               </a:rPr>
               <a:t>24,018</a:t>
             </a:r>
@@ -16968,6 +17502,8 @@
                   <a:srgbClr val="6B7A8C"/>
                 </a:solidFill>
                 <a:latin typeface="Tahoma"/>
+                <a:ea typeface="Tahoma"/>
+                <a:cs typeface="Tahoma"/>
               </a:rPr>
               <a:t>Time split: train มีอัตรายกเลิก 36.09% แต่ test มี 40.99%
 → พฤติกรรมเปลี่ยนตามเวลาจริง (ดูหน้า 14)</a:t>
@@ -17011,6 +17547,8 @@
                   <a:srgbClr val="6B7A8C"/>
                 </a:solidFill>
                 <a:latin typeface="Tahoma"/>
+                <a:ea typeface="Tahoma"/>
+                <a:cs typeface="Tahoma"/>
               </a:rPr>
               <a:t>encoding · scaling · feature selection ทั้งหมดอยู่ใน Pipeline จึงเรียนรู้จาก train ของแต่ละ fold เท่านั้น — Test set ถูกเปิดใช้ครั้งเดียวตอนท้าย</a:t>
             </a:r>
@@ -17126,6 +17664,8 @@
                   <a:srgbClr val="0F2038"/>
                 </a:solidFill>
                 <a:latin typeface="Tahoma"/>
+                <a:ea typeface="Tahoma"/>
+                <a:cs typeface="Tahoma"/>
               </a:rPr>
               <a:t>7</a:t>
             </a:r>
@@ -17168,6 +17708,8 @@
                   <a:srgbClr val="E0A458"/>
                 </a:solidFill>
                 <a:latin typeface="Tahoma"/>
+                <a:ea typeface="Tahoma"/>
+                <a:cs typeface="Tahoma"/>
               </a:rPr>
               <a:t>FEATURE ENGINEERING</a:t>
             </a:r>
@@ -17210,6 +17752,8 @@
                   <a:srgbClr val="0F2038"/>
                 </a:solidFill>
                 <a:latin typeface="Tahoma"/>
+                <a:ea typeface="Tahoma"/>
+                <a:cs typeface="Tahoma"/>
               </a:rPr>
               <a:t>สร้าง 9 features ใหม่ — ทุกตัวมีสมมติฐานรองรับ</a:t>
             </a:r>
@@ -17276,6 +17820,8 @@
                   <a:srgbClr val="0F2038"/>
                 </a:solidFill>
                 <a:latin typeface="Tahoma"/>
+                <a:ea typeface="Tahoma"/>
+                <a:cs typeface="Tahoma"/>
               </a:rPr>
               <a:t>ช่วงห่างของอัตรายกเลิกระหว่างกลุ่ม</a:t>
             </a:r>
@@ -17362,6 +17908,8 @@
                   <a:srgbClr val="FFFFFF"/>
                 </a:solidFill>
                 <a:latin typeface="Tahoma"/>
+                <a:ea typeface="Tahoma"/>
+                <a:cs typeface="Tahoma"/>
               </a:rPr>
               <a:t>Feature ใหม่</a:t>
             </a:r>
@@ -17404,6 +17952,8 @@
                   <a:srgbClr val="FFFFFF"/>
                 </a:solidFill>
                 <a:latin typeface="Tahoma"/>
+                <a:ea typeface="Tahoma"/>
+                <a:cs typeface="Tahoma"/>
               </a:rPr>
               <a:t>ช่วงห่าง</a:t>
             </a:r>
@@ -17490,6 +18040,8 @@
                   <a:srgbClr val="1F2C3D"/>
                 </a:solidFill>
                 <a:latin typeface="Tahoma"/>
+                <a:ea typeface="Tahoma"/>
+                <a:cs typeface="Tahoma"/>
               </a:rPr>
               <a:t>cancel_history_ratio</a:t>
             </a:r>
@@ -17532,6 +18084,8 @@
                   <a:srgbClr val="0F2038"/>
                 </a:solidFill>
                 <a:latin typeface="Tahoma"/>
+                <a:ea typeface="Tahoma"/>
+                <a:cs typeface="Tahoma"/>
               </a:rPr>
               <a:t>81.6%</a:t>
             </a:r>
@@ -17618,6 +18172,8 @@
                   <a:srgbClr val="1F2C3D"/>
                 </a:solidFill>
                 <a:latin typeface="Tahoma"/>
+                <a:ea typeface="Tahoma"/>
+                <a:cs typeface="Tahoma"/>
               </a:rPr>
               <a:t>lead_time_group</a:t>
             </a:r>
@@ -17660,6 +18216,8 @@
                   <a:srgbClr val="0F2038"/>
                 </a:solidFill>
                 <a:latin typeface="Tahoma"/>
+                <a:ea typeface="Tahoma"/>
+                <a:cs typeface="Tahoma"/>
               </a:rPr>
               <a:t>58.1%</a:t>
             </a:r>
@@ -17702,6 +18260,8 @@
                   <a:srgbClr val="1F2C3D"/>
                 </a:solidFill>
                 <a:latin typeface="Tahoma"/>
+                <a:ea typeface="Tahoma"/>
+                <a:cs typeface="Tahoma"/>
               </a:rPr>
               <a:t>total_nights</a:t>
             </a:r>
@@ -17744,6 +18304,8 @@
                   <a:srgbClr val="1F2C3D"/>
                 </a:solidFill>
                 <a:latin typeface="Tahoma"/>
+                <a:ea typeface="Tahoma"/>
+                <a:cs typeface="Tahoma"/>
               </a:rPr>
               <a:t>52.8%</a:t>
             </a:r>
@@ -17830,6 +18392,8 @@
                   <a:srgbClr val="1F2C3D"/>
                 </a:solidFill>
                 <a:latin typeface="Tahoma"/>
+                <a:ea typeface="Tahoma"/>
+                <a:cs typeface="Tahoma"/>
               </a:rPr>
               <a:t>is_domestic</a:t>
             </a:r>
@@ -17872,6 +18436,8 @@
                   <a:srgbClr val="1F2C3D"/>
                 </a:solidFill>
                 <a:latin typeface="Tahoma"/>
+                <a:ea typeface="Tahoma"/>
+                <a:cs typeface="Tahoma"/>
               </a:rPr>
               <a:t>33.1%</a:t>
             </a:r>
@@ -17914,6 +18480,8 @@
                   <a:srgbClr val="6B7A8C"/>
                 </a:solidFill>
                 <a:latin typeface="Tahoma"/>
+                <a:ea typeface="Tahoma"/>
+                <a:cs typeface="Tahoma"/>
               </a:rPr>
               <a:t>ยิ่งช่วงห่างกว้าง feature ยิ่งแยกกลุ่มคนที่จะยกเลิกออกจากคนที่ไม่ยกเลิกได้ดี
 ตั้งสมมติฐานก่อน แล้วค่อยพิสูจน์ด้วยกราฟ ไม่ได้สร้างมั่วแล้วลองดู</a:t>
@@ -18030,6 +18598,8 @@
                   <a:srgbClr val="0F2038"/>
                 </a:solidFill>
                 <a:latin typeface="Tahoma"/>
+                <a:ea typeface="Tahoma"/>
+                <a:cs typeface="Tahoma"/>
               </a:rPr>
               <a:t>8</a:t>
             </a:r>
@@ -18072,6 +18642,8 @@
                   <a:srgbClr val="E0A458"/>
                 </a:solidFill>
                 <a:latin typeface="Tahoma"/>
+                <a:ea typeface="Tahoma"/>
+                <a:cs typeface="Tahoma"/>
               </a:rPr>
               <a:t>FEATURE SELECTION</a:t>
             </a:r>
@@ -18114,6 +18686,8 @@
                   <a:srgbClr val="0F2038"/>
                 </a:solidFill>
                 <a:latin typeface="Tahoma"/>
+                <a:ea typeface="Tahoma"/>
+                <a:cs typeface="Tahoma"/>
               </a:rPr>
               <a:t>37 features → 18 features ด้วยการโหวต 2 ใน 3</a:t>
             </a:r>
@@ -18156,6 +18730,8 @@
                   <a:srgbClr val="0F2038"/>
                 </a:solidFill>
                 <a:latin typeface="Tahoma"/>
+                <a:ea typeface="Tahoma"/>
+                <a:cs typeface="Tahoma"/>
               </a:rPr>
               <a:t>Mutual Information</a:t>
             </a:r>
@@ -18198,6 +18774,8 @@
                   <a:srgbClr val="6B7A8C"/>
                 </a:solidFill>
                 <a:latin typeface="Tahoma"/>
+                <a:ea typeface="Tahoma"/>
+                <a:cs typeface="Tahoma"/>
               </a:rPr>
               <a:t>Filter — สถิติล้วน</a:t>
             </a:r>
@@ -18206,7 +18784,7 @@
       </p:sp>
       <p:pic>
         <p:nvPicPr>
-          <p:cNvPr id="8" name="Picture 7" descr="5_mutual_information.png"/>
+          <p:cNvPr id="8" name="Picture 7" descr="5_mutual_information_top.png"/>
           <p:cNvPicPr>
             <a:picLocks noChangeAspect="1"/>
           </p:cNvPicPr>
@@ -18220,8 +18798,8 @@
         </p:blipFill>
         <p:spPr>
           <a:xfrm>
-            <a:off x="1108152" y="1920240"/>
-            <a:ext cx="2447135" cy="3017520"/>
+            <a:off x="548640" y="2220915"/>
+            <a:ext cx="3566160" cy="2416170"/>
           </a:xfrm>
           <a:prstGeom prst="rect">
             <a:avLst/>
@@ -18264,6 +18842,8 @@
                   <a:srgbClr val="0F2038"/>
                 </a:solidFill>
                 <a:latin typeface="Tahoma"/>
+                <a:ea typeface="Tahoma"/>
+                <a:cs typeface="Tahoma"/>
               </a:rPr>
               <a:t>RF Importance</a:t>
             </a:r>
@@ -18306,6 +18886,8 @@
                   <a:srgbClr val="6B7A8C"/>
                 </a:solidFill>
                 <a:latin typeface="Tahoma"/>
+                <a:ea typeface="Tahoma"/>
+                <a:cs typeface="Tahoma"/>
               </a:rPr>
               <a:t>Embedded — จากตัวโมเดล</a:t>
             </a:r>
@@ -18314,7 +18896,7 @@
       </p:sp>
       <p:pic>
         <p:nvPicPr>
-          <p:cNvPr id="11" name="Picture 10" descr="5_random_forest_importance.png"/>
+          <p:cNvPr id="11" name="Picture 10" descr="5_random_forest_importance_top.png"/>
           <p:cNvPicPr>
             <a:picLocks noChangeAspect="1"/>
           </p:cNvPicPr>
@@ -18328,8 +18910,8 @@
         </p:blipFill>
         <p:spPr>
           <a:xfrm>
-            <a:off x="4966920" y="1920240"/>
-            <a:ext cx="2447135" cy="3017520"/>
+            <a:off x="4407408" y="2220915"/>
+            <a:ext cx="3566160" cy="2416170"/>
           </a:xfrm>
           <a:prstGeom prst="rect">
             <a:avLst/>
@@ -18372,6 +18954,8 @@
                   <a:srgbClr val="0F2038"/>
                 </a:solidFill>
                 <a:latin typeface="Tahoma"/>
+                <a:ea typeface="Tahoma"/>
+                <a:cs typeface="Tahoma"/>
               </a:rPr>
               <a:t>Permutation Importance</a:t>
             </a:r>
@@ -18414,6 +18998,8 @@
                   <a:srgbClr val="6B7A8C"/>
                 </a:solidFill>
                 <a:latin typeface="Tahoma"/>
+                <a:ea typeface="Tahoma"/>
+                <a:cs typeface="Tahoma"/>
               </a:rPr>
               <a:t>Model-agnostic — วัดบน validation</a:t>
             </a:r>
@@ -18422,7 +19008,7 @@
       </p:sp>
       <p:pic>
         <p:nvPicPr>
-          <p:cNvPr id="14" name="Picture 13" descr="5_permutation_importance.png"/>
+          <p:cNvPr id="14" name="Picture 13" descr="5_permutation_importance_top.png"/>
           <p:cNvPicPr>
             <a:picLocks noChangeAspect="1"/>
           </p:cNvPicPr>
@@ -18436,8 +19022,8 @@
         </p:blipFill>
         <p:spPr>
           <a:xfrm>
-            <a:off x="8825688" y="1920240"/>
-            <a:ext cx="2447135" cy="3017520"/>
+            <a:off x="8266176" y="2220915"/>
+            <a:ext cx="3566160" cy="2416170"/>
           </a:xfrm>
           <a:prstGeom prst="rect">
             <a:avLst/>
@@ -18526,6 +19112,8 @@
                   <a:srgbClr val="0F2038"/>
                 </a:solidFill>
                 <a:latin typeface="Tahoma"/>
+                <a:ea typeface="Tahoma"/>
+                <a:cs typeface="Tahoma"/>
               </a:rPr>
               <a:t>14 ตัว</a:t>
             </a:r>
@@ -18568,6 +19156,8 @@
                   <a:srgbClr val="6B7A8C"/>
                 </a:solidFill>
                 <a:latin typeface="Tahoma"/>
+                <a:ea typeface="Tahoma"/>
+                <a:cs typeface="Tahoma"/>
               </a:rPr>
               <a:t>ได้ครบ 3 โหวต</a:t>
             </a:r>
@@ -18656,6 +19246,8 @@
                   <a:srgbClr val="0F2038"/>
                 </a:solidFill>
                 <a:latin typeface="Tahoma"/>
+                <a:ea typeface="Tahoma"/>
+                <a:cs typeface="Tahoma"/>
               </a:rPr>
               <a:t>4 ตัว</a:t>
             </a:r>
@@ -18698,6 +19290,8 @@
                   <a:srgbClr val="6B7A8C"/>
                 </a:solidFill>
                 <a:latin typeface="Tahoma"/>
+                <a:ea typeface="Tahoma"/>
+                <a:cs typeface="Tahoma"/>
               </a:rPr>
               <a:t>ได้ 2 โหวต</a:t>
             </a:r>
@@ -18786,6 +19380,8 @@
                   <a:srgbClr val="E0A458"/>
                 </a:solidFill>
                 <a:latin typeface="Tahoma"/>
+                <a:ea typeface="Tahoma"/>
+                <a:cs typeface="Tahoma"/>
               </a:rPr>
               <a:t>18 ตัว</a:t>
             </a:r>
@@ -18828,6 +19424,8 @@
                   <a:srgbClr val="6B7A8C"/>
                 </a:solidFill>
                 <a:latin typeface="Tahoma"/>
+                <a:ea typeface="Tahoma"/>
+                <a:cs typeface="Tahoma"/>
               </a:rPr>
               <a:t>เก็บไว้ใช้เทรน</a:t>
             </a:r>
@@ -18870,6 +19468,8 @@
                   <a:srgbClr val="6B7A8C"/>
                 </a:solidFill>
                 <a:latin typeface="Tahoma"/>
+                <a:ea typeface="Tahoma"/>
+                <a:cs typeface="Tahoma"/>
               </a:rPr>
               <a:t>RF Importance มีอคติเข้าข้างตัวแปรที่มีค่าหลากหลาย จึงใช้ Permutation Importance ที่วัดบน validation set เป็นตัวถ่วง</a:t>
             </a:r>
@@ -18985,6 +19585,8 @@
                   <a:srgbClr val="0F2038"/>
                 </a:solidFill>
                 <a:latin typeface="Tahoma"/>
+                <a:ea typeface="Tahoma"/>
+                <a:cs typeface="Tahoma"/>
               </a:rPr>
               <a:t>9</a:t>
             </a:r>
@@ -19027,6 +19629,8 @@
                   <a:srgbClr val="E0A458"/>
                 </a:solidFill>
                 <a:latin typeface="Tahoma"/>
+                <a:ea typeface="Tahoma"/>
+                <a:cs typeface="Tahoma"/>
               </a:rPr>
               <a:t>ก่อน – หลังคัดเลือก</a:t>
             </a:r>
@@ -19069,6 +19673,8 @@
                   <a:srgbClr val="0F2038"/>
                 </a:solidFill>
                 <a:latin typeface="Tahoma"/>
+                <a:ea typeface="Tahoma"/>
+                <a:cs typeface="Tahoma"/>
               </a:rPr>
               <a:t>ใช้ feature น้อยลงครึ่งหนึ่ง แต่ผลเท่าเดิมและเทรนเร็วขึ้น</a:t>
             </a:r>
@@ -19155,6 +19761,8 @@
                   <a:srgbClr val="FFFFFF"/>
                 </a:solidFill>
                 <a:latin typeface="Tahoma"/>
+                <a:ea typeface="Tahoma"/>
+                <a:cs typeface="Tahoma"/>
               </a:rPr>
               <a:t>ชุด Feature</a:t>
             </a:r>
@@ -19197,6 +19805,8 @@
                   <a:srgbClr val="FFFFFF"/>
                 </a:solidFill>
                 <a:latin typeface="Tahoma"/>
+                <a:ea typeface="Tahoma"/>
+                <a:cs typeface="Tahoma"/>
               </a:rPr>
               <a:t>จำนวน</a:t>
             </a:r>
@@ -19239,6 +19849,8 @@
                   <a:srgbClr val="FFFFFF"/>
                 </a:solidFill>
                 <a:latin typeface="Tahoma"/>
+                <a:ea typeface="Tahoma"/>
+                <a:cs typeface="Tahoma"/>
               </a:rPr>
               <a:t>F1 (CV)</a:t>
             </a:r>
@@ -19281,6 +19893,8 @@
                   <a:srgbClr val="FFFFFF"/>
                 </a:solidFill>
                 <a:latin typeface="Tahoma"/>
+                <a:ea typeface="Tahoma"/>
+                <a:cs typeface="Tahoma"/>
               </a:rPr>
               <a:t>ROC-AUC</a:t>
             </a:r>
@@ -19323,6 +19937,8 @@
                   <a:srgbClr val="1F2C3D"/>
                 </a:solidFill>
                 <a:latin typeface="Tahoma"/>
+                <a:ea typeface="Tahoma"/>
+                <a:cs typeface="Tahoma"/>
               </a:rPr>
               <a:t>A: ตัวแปรเดิม</a:t>
             </a:r>
@@ -19365,6 +19981,8 @@
                   <a:srgbClr val="1F2C3D"/>
                 </a:solidFill>
                 <a:latin typeface="Tahoma"/>
+                <a:ea typeface="Tahoma"/>
+                <a:cs typeface="Tahoma"/>
               </a:rPr>
               <a:t>28</a:t>
             </a:r>
@@ -19407,6 +20025,8 @@
                   <a:srgbClr val="1F2C3D"/>
                 </a:solidFill>
                 <a:latin typeface="Tahoma"/>
+                <a:ea typeface="Tahoma"/>
+                <a:cs typeface="Tahoma"/>
               </a:rPr>
               <a:t>0.8103 ± 0.0049</a:t>
             </a:r>
@@ -19449,6 +20069,8 @@
                   <a:srgbClr val="1F2C3D"/>
                 </a:solidFill>
                 <a:latin typeface="Tahoma"/>
+                <a:ea typeface="Tahoma"/>
+                <a:cs typeface="Tahoma"/>
               </a:rPr>
               <a:t>0.9420</a:t>
             </a:r>
@@ -19535,6 +20157,8 @@
                   <a:srgbClr val="1F2C3D"/>
                 </a:solidFill>
                 <a:latin typeface="Tahoma"/>
+                <a:ea typeface="Tahoma"/>
+                <a:cs typeface="Tahoma"/>
               </a:rPr>
               <a:t>B: เดิม + ที่สร้างใหม่</a:t>
             </a:r>
@@ -19577,6 +20201,8 @@
                   <a:srgbClr val="1F2C3D"/>
                 </a:solidFill>
                 <a:latin typeface="Tahoma"/>
+                <a:ea typeface="Tahoma"/>
+                <a:cs typeface="Tahoma"/>
               </a:rPr>
               <a:t>37</a:t>
             </a:r>
@@ -19619,6 +20245,8 @@
                   <a:srgbClr val="1F2C3D"/>
                 </a:solidFill>
                 <a:latin typeface="Tahoma"/>
+                <a:ea typeface="Tahoma"/>
+                <a:cs typeface="Tahoma"/>
               </a:rPr>
               <a:t>0.8127 ± 0.0042</a:t>
             </a:r>
@@ -19661,6 +20289,8 @@
                   <a:srgbClr val="1F2C3D"/>
                 </a:solidFill>
                 <a:latin typeface="Tahoma"/>
+                <a:ea typeface="Tahoma"/>
+                <a:cs typeface="Tahoma"/>
               </a:rPr>
               <a:t>0.9428</a:t>
             </a:r>
@@ -19747,6 +20377,8 @@
                   <a:srgbClr val="0F2038"/>
                 </a:solidFill>
                 <a:latin typeface="Tahoma"/>
+                <a:ea typeface="Tahoma"/>
+                <a:cs typeface="Tahoma"/>
               </a:rPr>
               <a:t>C: คัดเลือกแล้ว</a:t>
             </a:r>
@@ -19789,6 +20421,8 @@
                   <a:srgbClr val="0F2038"/>
                 </a:solidFill>
                 <a:latin typeface="Tahoma"/>
+                <a:ea typeface="Tahoma"/>
+                <a:cs typeface="Tahoma"/>
               </a:rPr>
               <a:t>18</a:t>
             </a:r>
@@ -19831,6 +20465,8 @@
                   <a:srgbClr val="0F2038"/>
                 </a:solidFill>
                 <a:latin typeface="Tahoma"/>
+                <a:ea typeface="Tahoma"/>
+                <a:cs typeface="Tahoma"/>
               </a:rPr>
               <a:t>0.8112 ± 0.0027</a:t>
             </a:r>
@@ -19873,6 +20509,8 @@
                   <a:srgbClr val="0F2038"/>
                 </a:solidFill>
                 <a:latin typeface="Tahoma"/>
+                <a:ea typeface="Tahoma"/>
+                <a:cs typeface="Tahoma"/>
               </a:rPr>
               <a:t>0.9417</a:t>
             </a:r>
@@ -19961,6 +20599,8 @@
                   <a:srgbClr val="0F2038"/>
                 </a:solidFill>
                 <a:latin typeface="Tahoma"/>
+                <a:ea typeface="Tahoma"/>
+                <a:cs typeface="Tahoma"/>
               </a:rPr>
               <a:t>ผลต่างระหว่าง B กับ C = 0.0015 </a:t>
             </a:r>
@@ -19970,6 +20610,8 @@
                   <a:srgbClr val="1F2C3D"/>
                 </a:solidFill>
                 <a:latin typeface="Tahoma"/>
+                <a:ea typeface="Tahoma"/>
+                <a:cs typeface="Tahoma"/>
               </a:rPr>
               <a:t>ซึ่งน้อยกว่าค่า std (0.0042)</a:t>
             </a:r>
@@ -19989,6 +20631,8 @@
                   <a:srgbClr val="0F2038"/>
                 </a:solidFill>
                 <a:latin typeface="Tahoma"/>
+                <a:ea typeface="Tahoma"/>
+                <a:cs typeface="Tahoma"/>
               </a:rPr>
               <a:t>→ ถือว่าไม่ต่างกันอย่างมีนัยสำคัญ แต่ C มีความแปรปรวนต่ำที่สุดและเทรนเร็วที่สุด จึงเลือก C</a:t>
             </a:r>
@@ -20055,6 +20699,8 @@
                   <a:srgbClr val="6B7A8C"/>
                 </a:solidFill>
                 <a:latin typeface="Tahoma"/>
+                <a:ea typeface="Tahoma"/>
+                <a:cs typeface="Tahoma"/>
               </a:rPr>
               <a:t>กราฟตอบคำถาม “ทำไมเลือก K = 18” — เพิ่ม feature เกินจุดนี้แล้วคะแนนไม่ขึ้นอีก</a:t>
             </a:r>

</xml_diff>

<commit_message>
Drop Dummy and HistGradientBoosting from the whole project
The course only covered Logistic Regression, Decision Tree and Random Forest.

- Feature-set A/B/C comparison and the performance-vs-K curve are recomputed
  with Random Forest (A 0.8416, B 0.8427, C 0.8421; C trains twice as fast).
- The baseline is kept but stated as "predict not-cancelled for every booking"
  instead of naming DummyClassifier.
- The web app now serves a reduced Random Forest (150 trees, max_depth 25),
  28.8 MB, test F1 0.8376 at threshold 0.4754, replacing the HGB model.
- Report, slides, slide plan, README and the notebook updated to match.

Co-Authored-By: Claude Opus 5 <noreply@anthropic.com>
</commit_message>
<xml_diff>
--- a/slides/Hotel-Booking-Cancellation-Prediction.pptx
+++ b/slides/Hotel-Booking-Cancellation-Prediction.pptx
@@ -588,7 +588,7 @@
           <a:lstStyle/>
           <a:p>
             <a:r>
-              <a:t>ชี้ให้เห็นว่า Dummy ได้ F1 = 0 ทั้งที่ Accuracy สูง</a:t>
+              <a:t>ชี้ว่า Decision Tree overfit ชัดเจน ส่วน Random Forest แก้ด้วยการรวมหลายต้น</a:t>
             </a:r>
           </a:p>
         </p:txBody>
@@ -5461,8 +5461,8 @@
         </p:blipFill>
         <p:spPr>
           <a:xfrm>
-            <a:off x="6309360" y="1950812"/>
-            <a:ext cx="5303520" cy="2316296"/>
+            <a:off x="6309360" y="1783080"/>
+            <a:ext cx="5303520" cy="2651760"/>
           </a:xfrm>
           <a:prstGeom prst="rect">
             <a:avLst/>
@@ -5684,7 +5684,7 @@
                 <a:ea typeface="Tahoma"/>
                 <a:cs typeface="Tahoma"/>
               </a:rPr>
-              <a:t>Dummy (baseline)</a:t>
+              <a:t>Logistic Regression</a:t>
             </a:r>
           </a:p>
         </p:txBody>
@@ -5728,7 +5728,7 @@
                 <a:ea typeface="Tahoma"/>
                 <a:cs typeface="Tahoma"/>
               </a:rPr>
-              <a:t>0.000</a:t>
+              <a:t>0.763</a:t>
             </a:r>
           </a:p>
         </p:txBody>
@@ -5772,7 +5772,7 @@
                 <a:ea typeface="Tahoma"/>
                 <a:cs typeface="Tahoma"/>
               </a:rPr>
-              <a:t>0.000</a:t>
+              <a:t>0.001</a:t>
             </a:r>
           </a:p>
         </p:txBody>
@@ -5860,7 +5860,7 @@
                 <a:ea typeface="Tahoma"/>
                 <a:cs typeface="Tahoma"/>
               </a:rPr>
-              <a:t>Logistic Regression</a:t>
+              <a:t>Decision Tree</a:t>
             </a:r>
           </a:p>
         </p:txBody>
@@ -5904,7 +5904,7 @@
                 <a:ea typeface="Tahoma"/>
                 <a:cs typeface="Tahoma"/>
               </a:rPr>
-              <a:t>0.763</a:t>
+              <a:t>0.791</a:t>
             </a:r>
           </a:p>
         </p:txBody>
@@ -5940,138 +5940,6 @@
               </a:spcAft>
             </a:pPr>
             <a:r>
-              <a:rPr sz="1300" b="0">
-                <a:solidFill>
-                  <a:srgbClr val="1F2C3D"/>
-                </a:solidFill>
-                <a:latin typeface="Tahoma"/>
-                <a:ea typeface="Tahoma"/>
-                <a:cs typeface="Tahoma"/>
-              </a:rPr>
-              <a:t>0.001</a:t>
-            </a:r>
-          </a:p>
-        </p:txBody>
-      </p:sp>
-      <p:sp>
-        <p:nvSpPr>
-          <p:cNvPr id="18" name="TextBox 17"/>
-          <p:cNvSpPr txBox="1"/>
-          <p:nvPr/>
-        </p:nvSpPr>
-        <p:spPr>
-          <a:xfrm>
-            <a:off x="658368" y="2779776"/>
-            <a:ext cx="2298891" cy="292608"/>
-          </a:xfrm>
-          <a:prstGeom prst="rect">
-            <a:avLst/>
-          </a:prstGeom>
-          <a:noFill/>
-        </p:spPr>
-        <p:txBody>
-          <a:bodyPr wrap="square" lIns="0" rIns="0" tIns="0" bIns="0" anchor="t">
-            <a:spAutoFit/>
-          </a:bodyPr>
-          <a:lstStyle/>
-          <a:p>
-            <a:pPr algn="l">
-              <a:lnSpc>
-                <a:spcPct val="100000"/>
-              </a:lnSpc>
-              <a:spcAft>
-                <a:spcPts val="0"/>
-              </a:spcAft>
-            </a:pPr>
-            <a:r>
-              <a:rPr sz="1300" b="0">
-                <a:solidFill>
-                  <a:srgbClr val="1F2C3D"/>
-                </a:solidFill>
-                <a:latin typeface="Tahoma"/>
-                <a:ea typeface="Tahoma"/>
-                <a:cs typeface="Tahoma"/>
-              </a:rPr>
-              <a:t>Decision Tree</a:t>
-            </a:r>
-          </a:p>
-        </p:txBody>
-      </p:sp>
-      <p:sp>
-        <p:nvSpPr>
-          <p:cNvPr id="19" name="TextBox 18"/>
-          <p:cNvSpPr txBox="1"/>
-          <p:nvPr/>
-        </p:nvSpPr>
-        <p:spPr>
-          <a:xfrm>
-            <a:off x="3176715" y="2779776"/>
-            <a:ext cx="1039717" cy="292608"/>
-          </a:xfrm>
-          <a:prstGeom prst="rect">
-            <a:avLst/>
-          </a:prstGeom>
-          <a:noFill/>
-        </p:spPr>
-        <p:txBody>
-          <a:bodyPr wrap="square" lIns="0" rIns="0" tIns="0" bIns="0" anchor="t">
-            <a:spAutoFit/>
-          </a:bodyPr>
-          <a:lstStyle/>
-          <a:p>
-            <a:pPr algn="ctr">
-              <a:lnSpc>
-                <a:spcPct val="100000"/>
-              </a:lnSpc>
-              <a:spcAft>
-                <a:spcPts val="0"/>
-              </a:spcAft>
-            </a:pPr>
-            <a:r>
-              <a:rPr sz="1300" b="0">
-                <a:solidFill>
-                  <a:srgbClr val="1F2C3D"/>
-                </a:solidFill>
-                <a:latin typeface="Tahoma"/>
-                <a:ea typeface="Tahoma"/>
-                <a:cs typeface="Tahoma"/>
-              </a:rPr>
-              <a:t>0.791</a:t>
-            </a:r>
-          </a:p>
-        </p:txBody>
-      </p:sp>
-      <p:sp>
-        <p:nvSpPr>
-          <p:cNvPr id="20" name="TextBox 19"/>
-          <p:cNvSpPr txBox="1"/>
-          <p:nvPr/>
-        </p:nvSpPr>
-        <p:spPr>
-          <a:xfrm>
-            <a:off x="4435888" y="2779776"/>
-            <a:ext cx="1489422" cy="292608"/>
-          </a:xfrm>
-          <a:prstGeom prst="rect">
-            <a:avLst/>
-          </a:prstGeom>
-          <a:noFill/>
-        </p:spPr>
-        <p:txBody>
-          <a:bodyPr wrap="square" lIns="0" rIns="0" tIns="0" bIns="0" anchor="t">
-            <a:spAutoFit/>
-          </a:bodyPr>
-          <a:lstStyle/>
-          <a:p>
-            <a:pPr algn="ctr">
-              <a:lnSpc>
-                <a:spcPct val="100000"/>
-              </a:lnSpc>
-              <a:spcAft>
-                <a:spcPts val="0"/>
-              </a:spcAft>
-            </a:pPr>
-            <a:r>
               <a:rPr sz="1300" b="1">
                 <a:solidFill>
                   <a:srgbClr val="0F2038"/>
@@ -6087,13 +5955,13 @@
       </p:sp>
       <p:sp>
         <p:nvSpPr>
-          <p:cNvPr id="21" name="Rectangle 20"/>
+          <p:cNvPr id="18" name="Rectangle 17"/>
           <p:cNvSpPr/>
           <p:nvPr/>
         </p:nvSpPr>
         <p:spPr>
           <a:xfrm>
-            <a:off x="548640" y="3090672"/>
+            <a:off x="548640" y="2706624"/>
             <a:ext cx="5486400" cy="384048"/>
           </a:xfrm>
           <a:prstGeom prst="rect">
@@ -6131,13 +5999,13 @@
       </p:sp>
       <p:sp>
         <p:nvSpPr>
-          <p:cNvPr id="22" name="TextBox 21"/>
-          <p:cNvSpPr txBox="1"/>
-          <p:nvPr/>
-        </p:nvSpPr>
-        <p:spPr>
-          <a:xfrm>
-            <a:off x="658368" y="3163824"/>
+          <p:cNvPr id="19" name="TextBox 18"/>
+          <p:cNvSpPr txBox="1"/>
+          <p:nvPr/>
+        </p:nvSpPr>
+        <p:spPr>
+          <a:xfrm>
+            <a:off x="658368" y="2779776"/>
             <a:ext cx="2298891" cy="292608"/>
           </a:xfrm>
           <a:prstGeom prst="rect">
@@ -6175,13 +6043,13 @@
       </p:sp>
       <p:sp>
         <p:nvSpPr>
-          <p:cNvPr id="23" name="TextBox 22"/>
-          <p:cNvSpPr txBox="1"/>
-          <p:nvPr/>
-        </p:nvSpPr>
-        <p:spPr>
-          <a:xfrm>
-            <a:off x="3176715" y="3163824"/>
+          <p:cNvPr id="20" name="TextBox 19"/>
+          <p:cNvSpPr txBox="1"/>
+          <p:nvPr/>
+        </p:nvSpPr>
+        <p:spPr>
+          <a:xfrm>
+            <a:off x="3176715" y="2779776"/>
             <a:ext cx="1039717" cy="292608"/>
           </a:xfrm>
           <a:prstGeom prst="rect">
@@ -6219,13 +6087,13 @@
       </p:sp>
       <p:sp>
         <p:nvSpPr>
-          <p:cNvPr id="24" name="TextBox 23"/>
-          <p:cNvSpPr txBox="1"/>
-          <p:nvPr/>
-        </p:nvSpPr>
-        <p:spPr>
-          <a:xfrm>
-            <a:off x="4435888" y="3163824"/>
+          <p:cNvPr id="21" name="TextBox 20"/>
+          <p:cNvSpPr txBox="1"/>
+          <p:nvPr/>
+        </p:nvSpPr>
+        <p:spPr>
+          <a:xfrm>
+            <a:off x="4435888" y="2779776"/>
             <a:ext cx="1489422" cy="292608"/>
           </a:xfrm>
           <a:prstGeom prst="rect">
@@ -6263,139 +6131,7 @@
       </p:sp>
       <p:sp>
         <p:nvSpPr>
-          <p:cNvPr id="25" name="TextBox 24"/>
-          <p:cNvSpPr txBox="1"/>
-          <p:nvPr/>
-        </p:nvSpPr>
-        <p:spPr>
-          <a:xfrm>
-            <a:off x="658368" y="3547872"/>
-            <a:ext cx="2298891" cy="292608"/>
-          </a:xfrm>
-          <a:prstGeom prst="rect">
-            <a:avLst/>
-          </a:prstGeom>
-          <a:noFill/>
-        </p:spPr>
-        <p:txBody>
-          <a:bodyPr wrap="square" lIns="0" rIns="0" tIns="0" bIns="0" anchor="t">
-            <a:spAutoFit/>
-          </a:bodyPr>
-          <a:lstStyle/>
-          <a:p>
-            <a:pPr algn="l">
-              <a:lnSpc>
-                <a:spcPct val="100000"/>
-              </a:lnSpc>
-              <a:spcAft>
-                <a:spcPts val="0"/>
-              </a:spcAft>
-            </a:pPr>
-            <a:r>
-              <a:rPr sz="1300" b="0">
-                <a:solidFill>
-                  <a:srgbClr val="1F2C3D"/>
-                </a:solidFill>
-                <a:latin typeface="Tahoma"/>
-                <a:ea typeface="Tahoma"/>
-                <a:cs typeface="Tahoma"/>
-              </a:rPr>
-              <a:t>HistGradientBoosting</a:t>
-            </a:r>
-          </a:p>
-        </p:txBody>
-      </p:sp>
-      <p:sp>
-        <p:nvSpPr>
-          <p:cNvPr id="26" name="TextBox 25"/>
-          <p:cNvSpPr txBox="1"/>
-          <p:nvPr/>
-        </p:nvSpPr>
-        <p:spPr>
-          <a:xfrm>
-            <a:off x="3176715" y="3547872"/>
-            <a:ext cx="1039717" cy="292608"/>
-          </a:xfrm>
-          <a:prstGeom prst="rect">
-            <a:avLst/>
-          </a:prstGeom>
-          <a:noFill/>
-        </p:spPr>
-        <p:txBody>
-          <a:bodyPr wrap="square" lIns="0" rIns="0" tIns="0" bIns="0" anchor="t">
-            <a:spAutoFit/>
-          </a:bodyPr>
-          <a:lstStyle/>
-          <a:p>
-            <a:pPr algn="ctr">
-              <a:lnSpc>
-                <a:spcPct val="100000"/>
-              </a:lnSpc>
-              <a:spcAft>
-                <a:spcPts val="0"/>
-              </a:spcAft>
-            </a:pPr>
-            <a:r>
-              <a:rPr sz="1300" b="0">
-                <a:solidFill>
-                  <a:srgbClr val="1F2C3D"/>
-                </a:solidFill>
-                <a:latin typeface="Tahoma"/>
-                <a:ea typeface="Tahoma"/>
-                <a:cs typeface="Tahoma"/>
-              </a:rPr>
-              <a:t>0.811</a:t>
-            </a:r>
-          </a:p>
-        </p:txBody>
-      </p:sp>
-      <p:sp>
-        <p:nvSpPr>
-          <p:cNvPr id="27" name="TextBox 26"/>
-          <p:cNvSpPr txBox="1"/>
-          <p:nvPr/>
-        </p:nvSpPr>
-        <p:spPr>
-          <a:xfrm>
-            <a:off x="4435888" y="3547872"/>
-            <a:ext cx="1489422" cy="292608"/>
-          </a:xfrm>
-          <a:prstGeom prst="rect">
-            <a:avLst/>
-          </a:prstGeom>
-          <a:noFill/>
-        </p:spPr>
-        <p:txBody>
-          <a:bodyPr wrap="square" lIns="0" rIns="0" tIns="0" bIns="0" anchor="t">
-            <a:spAutoFit/>
-          </a:bodyPr>
-          <a:lstStyle/>
-          <a:p>
-            <a:pPr algn="ctr">
-              <a:lnSpc>
-                <a:spcPct val="100000"/>
-              </a:lnSpc>
-              <a:spcAft>
-                <a:spcPts val="0"/>
-              </a:spcAft>
-            </a:pPr>
-            <a:r>
-              <a:rPr sz="1300" b="0">
-                <a:solidFill>
-                  <a:srgbClr val="1F2C3D"/>
-                </a:solidFill>
-                <a:latin typeface="Tahoma"/>
-                <a:ea typeface="Tahoma"/>
-                <a:cs typeface="Tahoma"/>
-              </a:rPr>
-              <a:t>0.011</a:t>
-            </a:r>
-          </a:p>
-        </p:txBody>
-      </p:sp>
-      <p:sp>
-        <p:nvSpPr>
-          <p:cNvPr id="28" name="Rounded Rectangle 27"/>
+          <p:cNvPr id="22" name="Rounded Rectangle 21"/>
           <p:cNvSpPr/>
           <p:nvPr/>
         </p:nvSpPr>
@@ -6441,7 +6177,7 @@
       </p:sp>
       <p:sp>
         <p:nvSpPr>
-          <p:cNvPr id="29" name="TextBox 28"/>
+          <p:cNvPr id="23" name="TextBox 22"/>
           <p:cNvSpPr txBox="1"/>
           <p:nvPr/>
         </p:nvSpPr>
@@ -6517,7 +6253,7 @@
       </p:sp>
       <p:sp>
         <p:nvSpPr>
-          <p:cNvPr id="30" name="TextBox 29"/>
+          <p:cNvPr id="24" name="TextBox 23"/>
           <p:cNvSpPr txBox="1"/>
           <p:nvPr/>
         </p:nvSpPr>
@@ -6759,7 +6495,7 @@
                 <a:ea typeface="Tahoma"/>
                 <a:cs typeface="Tahoma"/>
               </a:rPr>
-              <a:t>Accuracy หลอกตา — Dummy ได้ 62.9% แต่ F1 = 0</a:t>
+              <a:t>Accuracy หลอกตา — ทายว่า "ไม่ยกเลิก" ทุกรายการก็ได้ 62.9%</a:t>
             </a:r>
           </a:p>
         </p:txBody>
@@ -7648,7 +7384,7 @@
                 <a:ea typeface="Tahoma"/>
                 <a:cs typeface="Tahoma"/>
               </a:rPr>
-              <a:t>Baseline: Dummy Classifier ทายคลาสที่พบบ่อยที่สุดเสมอ ได้ Accuracy 62.9% แต่ F1 = 0 คือจับคนที่จะยกเลิกไม่ได้เลยแม้แต่รายเดียว</a:t>
+              <a:t>เกณฑ์ขั้นต่ำ: การทายว่า "ไม่ยกเลิก" ทุกรายการได้ Accuracy 62.9% แต่ F1 = 0 คือจับคนที่จะยกเลิกไม่ได้เลยแม้แต่รายเดียว โมเดลจึงต้องชนะเกณฑ์นี้ให้ได้</a:t>
             </a:r>
           </a:p>
         </p:txBody>
@@ -8476,183 +8212,7 @@
       </p:sp>
       <p:sp>
         <p:nvSpPr>
-          <p:cNvPr id="20" name="TextBox 19"/>
-          <p:cNvSpPr txBox="1"/>
-          <p:nvPr/>
-        </p:nvSpPr>
-        <p:spPr>
-          <a:xfrm>
-            <a:off x="658368" y="2889504"/>
-            <a:ext cx="2093728" cy="329184"/>
-          </a:xfrm>
-          <a:prstGeom prst="rect">
-            <a:avLst/>
-          </a:prstGeom>
-          <a:noFill/>
-        </p:spPr>
-        <p:txBody>
-          <a:bodyPr wrap="square" lIns="0" rIns="0" tIns="0" bIns="0" anchor="t">
-            <a:spAutoFit/>
-          </a:bodyPr>
-          <a:lstStyle/>
-          <a:p>
-            <a:pPr algn="l">
-              <a:lnSpc>
-                <a:spcPct val="100000"/>
-              </a:lnSpc>
-              <a:spcAft>
-                <a:spcPts val="0"/>
-              </a:spcAft>
-            </a:pPr>
-            <a:r>
-              <a:rPr sz="1300" b="0">
-                <a:solidFill>
-                  <a:srgbClr val="1F2C3D"/>
-                </a:solidFill>
-                <a:latin typeface="Tahoma"/>
-                <a:ea typeface="Tahoma"/>
-                <a:cs typeface="Tahoma"/>
-              </a:rPr>
-              <a:t>HistGradientBoosting</a:t>
-            </a:r>
-          </a:p>
-        </p:txBody>
-      </p:sp>
-      <p:sp>
-        <p:nvSpPr>
-          <p:cNvPr id="21" name="TextBox 20"/>
-          <p:cNvSpPr txBox="1"/>
-          <p:nvPr/>
-        </p:nvSpPr>
-        <p:spPr>
-          <a:xfrm>
-            <a:off x="2971552" y="2889504"/>
-            <a:ext cx="937136" cy="329184"/>
-          </a:xfrm>
-          <a:prstGeom prst="rect">
-            <a:avLst/>
-          </a:prstGeom>
-          <a:noFill/>
-        </p:spPr>
-        <p:txBody>
-          <a:bodyPr wrap="square" lIns="0" rIns="0" tIns="0" bIns="0" anchor="t">
-            <a:spAutoFit/>
-          </a:bodyPr>
-          <a:lstStyle/>
-          <a:p>
-            <a:pPr algn="ctr">
-              <a:lnSpc>
-                <a:spcPct val="100000"/>
-              </a:lnSpc>
-              <a:spcAft>
-                <a:spcPts val="0"/>
-              </a:spcAft>
-            </a:pPr>
-            <a:r>
-              <a:rPr sz="1300" b="0">
-                <a:solidFill>
-                  <a:srgbClr val="1F2C3D"/>
-                </a:solidFill>
-                <a:latin typeface="Tahoma"/>
-                <a:ea typeface="Tahoma"/>
-                <a:cs typeface="Tahoma"/>
-              </a:rPr>
-              <a:t>0.8112</a:t>
-            </a:r>
-          </a:p>
-        </p:txBody>
-      </p:sp>
-      <p:sp>
-        <p:nvSpPr>
-          <p:cNvPr id="22" name="TextBox 21"/>
-          <p:cNvSpPr txBox="1"/>
-          <p:nvPr/>
-        </p:nvSpPr>
-        <p:spPr>
-          <a:xfrm>
-            <a:off x="4128144" y="2889504"/>
-            <a:ext cx="937136" cy="329184"/>
-          </a:xfrm>
-          <a:prstGeom prst="rect">
-            <a:avLst/>
-          </a:prstGeom>
-          <a:noFill/>
-        </p:spPr>
-        <p:txBody>
-          <a:bodyPr wrap="square" lIns="0" rIns="0" tIns="0" bIns="0" anchor="t">
-            <a:spAutoFit/>
-          </a:bodyPr>
-          <a:lstStyle/>
-          <a:p>
-            <a:pPr algn="ctr">
-              <a:lnSpc>
-                <a:spcPct val="100000"/>
-              </a:lnSpc>
-              <a:spcAft>
-                <a:spcPts val="0"/>
-              </a:spcAft>
-            </a:pPr>
-            <a:r>
-              <a:rPr sz="1300" b="1">
-                <a:solidFill>
-                  <a:srgbClr val="0F2038"/>
-                </a:solidFill>
-                <a:latin typeface="Tahoma"/>
-                <a:ea typeface="Tahoma"/>
-                <a:cs typeface="Tahoma"/>
-              </a:rPr>
-              <a:t>0.8344</a:t>
-            </a:r>
-          </a:p>
-        </p:txBody>
-      </p:sp>
-      <p:sp>
-        <p:nvSpPr>
-          <p:cNvPr id="23" name="TextBox 22"/>
-          <p:cNvSpPr txBox="1"/>
-          <p:nvPr/>
-        </p:nvSpPr>
-        <p:spPr>
-          <a:xfrm>
-            <a:off x="5284736" y="2889504"/>
-            <a:ext cx="1737854" cy="329184"/>
-          </a:xfrm>
-          <a:prstGeom prst="rect">
-            <a:avLst/>
-          </a:prstGeom>
-          <a:noFill/>
-        </p:spPr>
-        <p:txBody>
-          <a:bodyPr wrap="square" lIns="0" rIns="0" tIns="0" bIns="0" anchor="t">
-            <a:spAutoFit/>
-          </a:bodyPr>
-          <a:lstStyle/>
-          <a:p>
-            <a:pPr algn="ctr">
-              <a:lnSpc>
-                <a:spcPct val="100000"/>
-              </a:lnSpc>
-              <a:spcAft>
-                <a:spcPts val="0"/>
-              </a:spcAft>
-            </a:pPr>
-            <a:r>
-              <a:rPr sz="1300" b="0">
-                <a:solidFill>
-                  <a:srgbClr val="1F2C3D"/>
-                </a:solidFill>
-                <a:latin typeface="Tahoma"/>
-                <a:ea typeface="Tahoma"/>
-                <a:cs typeface="Tahoma"/>
-              </a:rPr>
-              <a:t>0.011 → 0.062</a:t>
-            </a:r>
-          </a:p>
-        </p:txBody>
-      </p:sp>
-      <p:sp>
-        <p:nvSpPr>
-          <p:cNvPr id="24" name="Rounded Rectangle 23"/>
+          <p:cNvPr id="20" name="Rounded Rectangle 19"/>
           <p:cNvSpPr/>
           <p:nvPr/>
         </p:nvSpPr>
@@ -8698,7 +8258,7 @@
       </p:sp>
       <p:sp>
         <p:nvSpPr>
-          <p:cNvPr id="25" name="TextBox 24"/>
+          <p:cNvPr id="21" name="TextBox 20"/>
           <p:cNvSpPr txBox="1"/>
           <p:nvPr/>
         </p:nvSpPr>
@@ -8774,7 +8334,7 @@
       </p:sp>
       <p:sp>
         <p:nvSpPr>
-          <p:cNvPr id="26" name="TextBox 25"/>
+          <p:cNvPr id="22" name="TextBox 21"/>
           <p:cNvSpPr txBox="1"/>
           <p:nvPr/>
         </p:nvSpPr>
@@ -8839,7 +8399,7 @@
       </p:sp>
       <p:pic>
         <p:nvPicPr>
-          <p:cNvPr id="27" name="Picture 26" descr="7_validation_curve_rf_max_depth.png"/>
+          <p:cNvPr id="23" name="Picture 22" descr="7_validation_curve_rf_max_depth.png"/>
           <p:cNvPicPr>
             <a:picLocks noChangeAspect="1"/>
           </p:cNvPicPr>
@@ -8863,7 +8423,7 @@
       </p:pic>
       <p:sp>
         <p:nvSpPr>
-          <p:cNvPr id="28" name="TextBox 27"/>
+          <p:cNvPr id="24" name="TextBox 23"/>
           <p:cNvSpPr txBox="1"/>
           <p:nvPr/>
         </p:nvSpPr>
@@ -11525,7 +11085,7 @@
                 <a:ea typeface="Tahoma"/>
                 <a:cs typeface="Tahoma"/>
               </a:rPr>
-              <a:t>99.8%</a:t>
+              <a:t>100%</a:t>
             </a:r>
           </a:p>
         </p:txBody>
@@ -11704,7 +11264,7 @@
                 <a:ea typeface="Tahoma"/>
                 <a:cs typeface="Tahoma"/>
               </a:rPr>
-              <a:t>25.9%</a:t>
+              <a:t>33.3%</a:t>
             </a:r>
           </a:p>
         </p:txBody>
@@ -11883,7 +11443,7 @@
                 <a:ea typeface="Tahoma"/>
                 <a:cs typeface="Tahoma"/>
               </a:rPr>
-              <a:t>1.0%</a:t>
+              <a:t>0.6%</a:t>
             </a:r>
           </a:p>
         </p:txBody>
@@ -12083,7 +11643,7 @@
                 <a:ea typeface="Tahoma"/>
                 <a:cs typeface="Tahoma"/>
               </a:rPr>
-              <a:t>โมเดลบนเว็บใช้ HistGradientBoosting ขนาด 0.8 MB (F1 0.8334) แทน Random Forest 356.8 MB เพราะข้อจำกัดด้านหน่วยความจำของบริการฟรี · ผลทำนายอิงข้อมูลโปรตุเกสปี 2015–2017</a:t>
+              <a:t>โมเดลบนเว็บเป็น Random Forest ฉบับย่อ 28.8 MB (F1 0.8376) แทนตัวเต็ม 356.8 MB เพราะข้อจำกัดด้านหน่วยความจำของบริการฟรี · ผลทำนายอิงข้อมูลโปรตุเกสปี 2015–2017</a:t>
             </a:r>
           </a:p>
         </p:txBody>
@@ -20028,7 +19588,7 @@
                 <a:ea typeface="Tahoma"/>
                 <a:cs typeface="Tahoma"/>
               </a:rPr>
-              <a:t>0.8103 ± 0.0049</a:t>
+              <a:t>0.8416 ± 0.0037</a:t>
             </a:r>
           </a:p>
         </p:txBody>
@@ -20072,7 +19632,7 @@
                 <a:ea typeface="Tahoma"/>
                 <a:cs typeface="Tahoma"/>
               </a:rPr>
-              <a:t>0.9420</a:t>
+              <a:t>0.9551</a:t>
             </a:r>
           </a:p>
         </p:txBody>
@@ -20248,7 +19808,7 @@
                 <a:ea typeface="Tahoma"/>
                 <a:cs typeface="Tahoma"/>
               </a:rPr>
-              <a:t>0.8127 ± 0.0042</a:t>
+              <a:t>0.8427 ± 0.0028</a:t>
             </a:r>
           </a:p>
         </p:txBody>
@@ -20292,7 +19852,7 @@
                 <a:ea typeface="Tahoma"/>
                 <a:cs typeface="Tahoma"/>
               </a:rPr>
-              <a:t>0.9428</a:t>
+              <a:t>0.9554</a:t>
             </a:r>
           </a:p>
         </p:txBody>
@@ -20468,7 +20028,7 @@
                 <a:ea typeface="Tahoma"/>
                 <a:cs typeface="Tahoma"/>
               </a:rPr>
-              <a:t>0.8112 ± 0.0027</a:t>
+              <a:t>0.8421 ± 0.0036</a:t>
             </a:r>
           </a:p>
         </p:txBody>
@@ -20512,7 +20072,7 @@
                 <a:ea typeface="Tahoma"/>
                 <a:cs typeface="Tahoma"/>
               </a:rPr>
-              <a:t>0.9417</a:t>
+              <a:t>0.9546</a:t>
             </a:r>
           </a:p>
         </p:txBody>
@@ -20602,7 +20162,7 @@
                 <a:ea typeface="Tahoma"/>
                 <a:cs typeface="Tahoma"/>
               </a:rPr>
-              <a:t>ผลต่างระหว่าง B กับ C = 0.0015 </a:t>
+              <a:t>ผลต่างระหว่าง B กับ C = 0.0006 </a:t>
             </a:r>
             <a:r>
               <a:rPr sz="1400" b="0">
@@ -20613,7 +20173,7 @@
                 <a:ea typeface="Tahoma"/>
                 <a:cs typeface="Tahoma"/>
               </a:rPr>
-              <a:t>ซึ่งน้อยกว่าค่า std (0.0042)</a:t>
+              <a:t>ซึ่งน้อยกว่าค่า std (0.0028)</a:t>
             </a:r>
           </a:p>
           <a:p>
@@ -20634,7 +20194,7 @@
                 <a:ea typeface="Tahoma"/>
                 <a:cs typeface="Tahoma"/>
               </a:rPr>
-              <a:t>→ ถือว่าไม่ต่างกันอย่างมีนัยสำคัญ แต่ C มีความแปรปรวนต่ำที่สุดและเทรนเร็วที่สุด จึงเลือก C</a:t>
+              <a:t>→ ไม่ต่างกันอย่างมีนัยสำคัญ แต่ C ใช้ feature ครึ่งเดียวและเทรนเร็วขึ้นเท่าตัว (8.7 vs 17.5 วินาที)</a:t>
             </a:r>
           </a:p>
         </p:txBody>
@@ -20655,8 +20215,8 @@
         </p:blipFill>
         <p:spPr>
           <a:xfrm>
-            <a:off x="7589520" y="2010029"/>
-            <a:ext cx="4023360" cy="2197862"/>
+            <a:off x="7589520" y="1991360"/>
+            <a:ext cx="4023360" cy="2235200"/>
           </a:xfrm>
           <a:prstGeom prst="rect">
             <a:avLst/>

</xml_diff>

<commit_message>
Revert "Drop Dummy and HistGradientBoosting from the whole project"
This reverts commit 3b1f2a86e98d934c4218596878dfd3434eddf85b.
</commit_message>
<xml_diff>
--- a/slides/Hotel-Booking-Cancellation-Prediction.pptx
+++ b/slides/Hotel-Booking-Cancellation-Prediction.pptx
@@ -588,7 +588,7 @@
           <a:lstStyle/>
           <a:p>
             <a:r>
-              <a:t>ชี้ว่า Decision Tree overfit ชัดเจน ส่วน Random Forest แก้ด้วยการรวมหลายต้น</a:t>
+              <a:t>ชี้ให้เห็นว่า Dummy ได้ F1 = 0 ทั้งที่ Accuracy สูง</a:t>
             </a:r>
           </a:p>
         </p:txBody>
@@ -5461,8 +5461,8 @@
         </p:blipFill>
         <p:spPr>
           <a:xfrm>
-            <a:off x="6309360" y="1783080"/>
-            <a:ext cx="5303520" cy="2651760"/>
+            <a:off x="6309360" y="1950812"/>
+            <a:ext cx="5303520" cy="2316296"/>
           </a:xfrm>
           <a:prstGeom prst="rect">
             <a:avLst/>
@@ -5684,7 +5684,7 @@
                 <a:ea typeface="Tahoma"/>
                 <a:cs typeface="Tahoma"/>
               </a:rPr>
-              <a:t>Logistic Regression</a:t>
+              <a:t>Dummy (baseline)</a:t>
             </a:r>
           </a:p>
         </p:txBody>
@@ -5728,7 +5728,7 @@
                 <a:ea typeface="Tahoma"/>
                 <a:cs typeface="Tahoma"/>
               </a:rPr>
-              <a:t>0.763</a:t>
+              <a:t>0.000</a:t>
             </a:r>
           </a:p>
         </p:txBody>
@@ -5772,7 +5772,7 @@
                 <a:ea typeface="Tahoma"/>
                 <a:cs typeface="Tahoma"/>
               </a:rPr>
-              <a:t>0.001</a:t>
+              <a:t>0.000</a:t>
             </a:r>
           </a:p>
         </p:txBody>
@@ -5860,7 +5860,7 @@
                 <a:ea typeface="Tahoma"/>
                 <a:cs typeface="Tahoma"/>
               </a:rPr>
-              <a:t>Decision Tree</a:t>
+              <a:t>Logistic Regression</a:t>
             </a:r>
           </a:p>
         </p:txBody>
@@ -5904,7 +5904,7 @@
                 <a:ea typeface="Tahoma"/>
                 <a:cs typeface="Tahoma"/>
               </a:rPr>
-              <a:t>0.791</a:t>
+              <a:t>0.763</a:t>
             </a:r>
           </a:p>
         </p:txBody>
@@ -5940,6 +5940,138 @@
               </a:spcAft>
             </a:pPr>
             <a:r>
+              <a:rPr sz="1300" b="0">
+                <a:solidFill>
+                  <a:srgbClr val="1F2C3D"/>
+                </a:solidFill>
+                <a:latin typeface="Tahoma"/>
+                <a:ea typeface="Tahoma"/>
+                <a:cs typeface="Tahoma"/>
+              </a:rPr>
+              <a:t>0.001</a:t>
+            </a:r>
+          </a:p>
+        </p:txBody>
+      </p:sp>
+      <p:sp>
+        <p:nvSpPr>
+          <p:cNvPr id="18" name="TextBox 17"/>
+          <p:cNvSpPr txBox="1"/>
+          <p:nvPr/>
+        </p:nvSpPr>
+        <p:spPr>
+          <a:xfrm>
+            <a:off x="658368" y="2779776"/>
+            <a:ext cx="2298891" cy="292608"/>
+          </a:xfrm>
+          <a:prstGeom prst="rect">
+            <a:avLst/>
+          </a:prstGeom>
+          <a:noFill/>
+        </p:spPr>
+        <p:txBody>
+          <a:bodyPr wrap="square" lIns="0" rIns="0" tIns="0" bIns="0" anchor="t">
+            <a:spAutoFit/>
+          </a:bodyPr>
+          <a:lstStyle/>
+          <a:p>
+            <a:pPr algn="l">
+              <a:lnSpc>
+                <a:spcPct val="100000"/>
+              </a:lnSpc>
+              <a:spcAft>
+                <a:spcPts val="0"/>
+              </a:spcAft>
+            </a:pPr>
+            <a:r>
+              <a:rPr sz="1300" b="0">
+                <a:solidFill>
+                  <a:srgbClr val="1F2C3D"/>
+                </a:solidFill>
+                <a:latin typeface="Tahoma"/>
+                <a:ea typeface="Tahoma"/>
+                <a:cs typeface="Tahoma"/>
+              </a:rPr>
+              <a:t>Decision Tree</a:t>
+            </a:r>
+          </a:p>
+        </p:txBody>
+      </p:sp>
+      <p:sp>
+        <p:nvSpPr>
+          <p:cNvPr id="19" name="TextBox 18"/>
+          <p:cNvSpPr txBox="1"/>
+          <p:nvPr/>
+        </p:nvSpPr>
+        <p:spPr>
+          <a:xfrm>
+            <a:off x="3176715" y="2779776"/>
+            <a:ext cx="1039717" cy="292608"/>
+          </a:xfrm>
+          <a:prstGeom prst="rect">
+            <a:avLst/>
+          </a:prstGeom>
+          <a:noFill/>
+        </p:spPr>
+        <p:txBody>
+          <a:bodyPr wrap="square" lIns="0" rIns="0" tIns="0" bIns="0" anchor="t">
+            <a:spAutoFit/>
+          </a:bodyPr>
+          <a:lstStyle/>
+          <a:p>
+            <a:pPr algn="ctr">
+              <a:lnSpc>
+                <a:spcPct val="100000"/>
+              </a:lnSpc>
+              <a:spcAft>
+                <a:spcPts val="0"/>
+              </a:spcAft>
+            </a:pPr>
+            <a:r>
+              <a:rPr sz="1300" b="0">
+                <a:solidFill>
+                  <a:srgbClr val="1F2C3D"/>
+                </a:solidFill>
+                <a:latin typeface="Tahoma"/>
+                <a:ea typeface="Tahoma"/>
+                <a:cs typeface="Tahoma"/>
+              </a:rPr>
+              <a:t>0.791</a:t>
+            </a:r>
+          </a:p>
+        </p:txBody>
+      </p:sp>
+      <p:sp>
+        <p:nvSpPr>
+          <p:cNvPr id="20" name="TextBox 19"/>
+          <p:cNvSpPr txBox="1"/>
+          <p:nvPr/>
+        </p:nvSpPr>
+        <p:spPr>
+          <a:xfrm>
+            <a:off x="4435888" y="2779776"/>
+            <a:ext cx="1489422" cy="292608"/>
+          </a:xfrm>
+          <a:prstGeom prst="rect">
+            <a:avLst/>
+          </a:prstGeom>
+          <a:noFill/>
+        </p:spPr>
+        <p:txBody>
+          <a:bodyPr wrap="square" lIns="0" rIns="0" tIns="0" bIns="0" anchor="t">
+            <a:spAutoFit/>
+          </a:bodyPr>
+          <a:lstStyle/>
+          <a:p>
+            <a:pPr algn="ctr">
+              <a:lnSpc>
+                <a:spcPct val="100000"/>
+              </a:lnSpc>
+              <a:spcAft>
+                <a:spcPts val="0"/>
+              </a:spcAft>
+            </a:pPr>
+            <a:r>
               <a:rPr sz="1300" b="1">
                 <a:solidFill>
                   <a:srgbClr val="0F2038"/>
@@ -5955,13 +6087,13 @@
       </p:sp>
       <p:sp>
         <p:nvSpPr>
-          <p:cNvPr id="18" name="Rectangle 17"/>
+          <p:cNvPr id="21" name="Rectangle 20"/>
           <p:cNvSpPr/>
           <p:nvPr/>
         </p:nvSpPr>
         <p:spPr>
           <a:xfrm>
-            <a:off x="548640" y="2706624"/>
+            <a:off x="548640" y="3090672"/>
             <a:ext cx="5486400" cy="384048"/>
           </a:xfrm>
           <a:prstGeom prst="rect">
@@ -5999,13 +6131,13 @@
       </p:sp>
       <p:sp>
         <p:nvSpPr>
-          <p:cNvPr id="19" name="TextBox 18"/>
-          <p:cNvSpPr txBox="1"/>
-          <p:nvPr/>
-        </p:nvSpPr>
-        <p:spPr>
-          <a:xfrm>
-            <a:off x="658368" y="2779776"/>
+          <p:cNvPr id="22" name="TextBox 21"/>
+          <p:cNvSpPr txBox="1"/>
+          <p:nvPr/>
+        </p:nvSpPr>
+        <p:spPr>
+          <a:xfrm>
+            <a:off x="658368" y="3163824"/>
             <a:ext cx="2298891" cy="292608"/>
           </a:xfrm>
           <a:prstGeom prst="rect">
@@ -6043,13 +6175,13 @@
       </p:sp>
       <p:sp>
         <p:nvSpPr>
-          <p:cNvPr id="20" name="TextBox 19"/>
-          <p:cNvSpPr txBox="1"/>
-          <p:nvPr/>
-        </p:nvSpPr>
-        <p:spPr>
-          <a:xfrm>
-            <a:off x="3176715" y="2779776"/>
+          <p:cNvPr id="23" name="TextBox 22"/>
+          <p:cNvSpPr txBox="1"/>
+          <p:nvPr/>
+        </p:nvSpPr>
+        <p:spPr>
+          <a:xfrm>
+            <a:off x="3176715" y="3163824"/>
             <a:ext cx="1039717" cy="292608"/>
           </a:xfrm>
           <a:prstGeom prst="rect">
@@ -6087,13 +6219,13 @@
       </p:sp>
       <p:sp>
         <p:nvSpPr>
-          <p:cNvPr id="21" name="TextBox 20"/>
-          <p:cNvSpPr txBox="1"/>
-          <p:nvPr/>
-        </p:nvSpPr>
-        <p:spPr>
-          <a:xfrm>
-            <a:off x="4435888" y="2779776"/>
+          <p:cNvPr id="24" name="TextBox 23"/>
+          <p:cNvSpPr txBox="1"/>
+          <p:nvPr/>
+        </p:nvSpPr>
+        <p:spPr>
+          <a:xfrm>
+            <a:off x="4435888" y="3163824"/>
             <a:ext cx="1489422" cy="292608"/>
           </a:xfrm>
           <a:prstGeom prst="rect">
@@ -6131,7 +6263,139 @@
       </p:sp>
       <p:sp>
         <p:nvSpPr>
-          <p:cNvPr id="22" name="Rounded Rectangle 21"/>
+          <p:cNvPr id="25" name="TextBox 24"/>
+          <p:cNvSpPr txBox="1"/>
+          <p:nvPr/>
+        </p:nvSpPr>
+        <p:spPr>
+          <a:xfrm>
+            <a:off x="658368" y="3547872"/>
+            <a:ext cx="2298891" cy="292608"/>
+          </a:xfrm>
+          <a:prstGeom prst="rect">
+            <a:avLst/>
+          </a:prstGeom>
+          <a:noFill/>
+        </p:spPr>
+        <p:txBody>
+          <a:bodyPr wrap="square" lIns="0" rIns="0" tIns="0" bIns="0" anchor="t">
+            <a:spAutoFit/>
+          </a:bodyPr>
+          <a:lstStyle/>
+          <a:p>
+            <a:pPr algn="l">
+              <a:lnSpc>
+                <a:spcPct val="100000"/>
+              </a:lnSpc>
+              <a:spcAft>
+                <a:spcPts val="0"/>
+              </a:spcAft>
+            </a:pPr>
+            <a:r>
+              <a:rPr sz="1300" b="0">
+                <a:solidFill>
+                  <a:srgbClr val="1F2C3D"/>
+                </a:solidFill>
+                <a:latin typeface="Tahoma"/>
+                <a:ea typeface="Tahoma"/>
+                <a:cs typeface="Tahoma"/>
+              </a:rPr>
+              <a:t>HistGradientBoosting</a:t>
+            </a:r>
+          </a:p>
+        </p:txBody>
+      </p:sp>
+      <p:sp>
+        <p:nvSpPr>
+          <p:cNvPr id="26" name="TextBox 25"/>
+          <p:cNvSpPr txBox="1"/>
+          <p:nvPr/>
+        </p:nvSpPr>
+        <p:spPr>
+          <a:xfrm>
+            <a:off x="3176715" y="3547872"/>
+            <a:ext cx="1039717" cy="292608"/>
+          </a:xfrm>
+          <a:prstGeom prst="rect">
+            <a:avLst/>
+          </a:prstGeom>
+          <a:noFill/>
+        </p:spPr>
+        <p:txBody>
+          <a:bodyPr wrap="square" lIns="0" rIns="0" tIns="0" bIns="0" anchor="t">
+            <a:spAutoFit/>
+          </a:bodyPr>
+          <a:lstStyle/>
+          <a:p>
+            <a:pPr algn="ctr">
+              <a:lnSpc>
+                <a:spcPct val="100000"/>
+              </a:lnSpc>
+              <a:spcAft>
+                <a:spcPts val="0"/>
+              </a:spcAft>
+            </a:pPr>
+            <a:r>
+              <a:rPr sz="1300" b="0">
+                <a:solidFill>
+                  <a:srgbClr val="1F2C3D"/>
+                </a:solidFill>
+                <a:latin typeface="Tahoma"/>
+                <a:ea typeface="Tahoma"/>
+                <a:cs typeface="Tahoma"/>
+              </a:rPr>
+              <a:t>0.811</a:t>
+            </a:r>
+          </a:p>
+        </p:txBody>
+      </p:sp>
+      <p:sp>
+        <p:nvSpPr>
+          <p:cNvPr id="27" name="TextBox 26"/>
+          <p:cNvSpPr txBox="1"/>
+          <p:nvPr/>
+        </p:nvSpPr>
+        <p:spPr>
+          <a:xfrm>
+            <a:off x="4435888" y="3547872"/>
+            <a:ext cx="1489422" cy="292608"/>
+          </a:xfrm>
+          <a:prstGeom prst="rect">
+            <a:avLst/>
+          </a:prstGeom>
+          <a:noFill/>
+        </p:spPr>
+        <p:txBody>
+          <a:bodyPr wrap="square" lIns="0" rIns="0" tIns="0" bIns="0" anchor="t">
+            <a:spAutoFit/>
+          </a:bodyPr>
+          <a:lstStyle/>
+          <a:p>
+            <a:pPr algn="ctr">
+              <a:lnSpc>
+                <a:spcPct val="100000"/>
+              </a:lnSpc>
+              <a:spcAft>
+                <a:spcPts val="0"/>
+              </a:spcAft>
+            </a:pPr>
+            <a:r>
+              <a:rPr sz="1300" b="0">
+                <a:solidFill>
+                  <a:srgbClr val="1F2C3D"/>
+                </a:solidFill>
+                <a:latin typeface="Tahoma"/>
+                <a:ea typeface="Tahoma"/>
+                <a:cs typeface="Tahoma"/>
+              </a:rPr>
+              <a:t>0.011</a:t>
+            </a:r>
+          </a:p>
+        </p:txBody>
+      </p:sp>
+      <p:sp>
+        <p:nvSpPr>
+          <p:cNvPr id="28" name="Rounded Rectangle 27"/>
           <p:cNvSpPr/>
           <p:nvPr/>
         </p:nvSpPr>
@@ -6177,7 +6441,7 @@
       </p:sp>
       <p:sp>
         <p:nvSpPr>
-          <p:cNvPr id="23" name="TextBox 22"/>
+          <p:cNvPr id="29" name="TextBox 28"/>
           <p:cNvSpPr txBox="1"/>
           <p:nvPr/>
         </p:nvSpPr>
@@ -6253,7 +6517,7 @@
       </p:sp>
       <p:sp>
         <p:nvSpPr>
-          <p:cNvPr id="24" name="TextBox 23"/>
+          <p:cNvPr id="30" name="TextBox 29"/>
           <p:cNvSpPr txBox="1"/>
           <p:nvPr/>
         </p:nvSpPr>
@@ -6495,7 +6759,7 @@
                 <a:ea typeface="Tahoma"/>
                 <a:cs typeface="Tahoma"/>
               </a:rPr>
-              <a:t>Accuracy หลอกตา — ทายว่า "ไม่ยกเลิก" ทุกรายการก็ได้ 62.9%</a:t>
+              <a:t>Accuracy หลอกตา — Dummy ได้ 62.9% แต่ F1 = 0</a:t>
             </a:r>
           </a:p>
         </p:txBody>
@@ -7384,7 +7648,7 @@
                 <a:ea typeface="Tahoma"/>
                 <a:cs typeface="Tahoma"/>
               </a:rPr>
-              <a:t>เกณฑ์ขั้นต่ำ: การทายว่า "ไม่ยกเลิก" ทุกรายการได้ Accuracy 62.9% แต่ F1 = 0 คือจับคนที่จะยกเลิกไม่ได้เลยแม้แต่รายเดียว โมเดลจึงต้องชนะเกณฑ์นี้ให้ได้</a:t>
+              <a:t>Baseline: Dummy Classifier ทายคลาสที่พบบ่อยที่สุดเสมอ ได้ Accuracy 62.9% แต่ F1 = 0 คือจับคนที่จะยกเลิกไม่ได้เลยแม้แต่รายเดียว</a:t>
             </a:r>
           </a:p>
         </p:txBody>
@@ -8212,7 +8476,183 @@
       </p:sp>
       <p:sp>
         <p:nvSpPr>
-          <p:cNvPr id="20" name="Rounded Rectangle 19"/>
+          <p:cNvPr id="20" name="TextBox 19"/>
+          <p:cNvSpPr txBox="1"/>
+          <p:nvPr/>
+        </p:nvSpPr>
+        <p:spPr>
+          <a:xfrm>
+            <a:off x="658368" y="2889504"/>
+            <a:ext cx="2093728" cy="329184"/>
+          </a:xfrm>
+          <a:prstGeom prst="rect">
+            <a:avLst/>
+          </a:prstGeom>
+          <a:noFill/>
+        </p:spPr>
+        <p:txBody>
+          <a:bodyPr wrap="square" lIns="0" rIns="0" tIns="0" bIns="0" anchor="t">
+            <a:spAutoFit/>
+          </a:bodyPr>
+          <a:lstStyle/>
+          <a:p>
+            <a:pPr algn="l">
+              <a:lnSpc>
+                <a:spcPct val="100000"/>
+              </a:lnSpc>
+              <a:spcAft>
+                <a:spcPts val="0"/>
+              </a:spcAft>
+            </a:pPr>
+            <a:r>
+              <a:rPr sz="1300" b="0">
+                <a:solidFill>
+                  <a:srgbClr val="1F2C3D"/>
+                </a:solidFill>
+                <a:latin typeface="Tahoma"/>
+                <a:ea typeface="Tahoma"/>
+                <a:cs typeface="Tahoma"/>
+              </a:rPr>
+              <a:t>HistGradientBoosting</a:t>
+            </a:r>
+          </a:p>
+        </p:txBody>
+      </p:sp>
+      <p:sp>
+        <p:nvSpPr>
+          <p:cNvPr id="21" name="TextBox 20"/>
+          <p:cNvSpPr txBox="1"/>
+          <p:nvPr/>
+        </p:nvSpPr>
+        <p:spPr>
+          <a:xfrm>
+            <a:off x="2971552" y="2889504"/>
+            <a:ext cx="937136" cy="329184"/>
+          </a:xfrm>
+          <a:prstGeom prst="rect">
+            <a:avLst/>
+          </a:prstGeom>
+          <a:noFill/>
+        </p:spPr>
+        <p:txBody>
+          <a:bodyPr wrap="square" lIns="0" rIns="0" tIns="0" bIns="0" anchor="t">
+            <a:spAutoFit/>
+          </a:bodyPr>
+          <a:lstStyle/>
+          <a:p>
+            <a:pPr algn="ctr">
+              <a:lnSpc>
+                <a:spcPct val="100000"/>
+              </a:lnSpc>
+              <a:spcAft>
+                <a:spcPts val="0"/>
+              </a:spcAft>
+            </a:pPr>
+            <a:r>
+              <a:rPr sz="1300" b="0">
+                <a:solidFill>
+                  <a:srgbClr val="1F2C3D"/>
+                </a:solidFill>
+                <a:latin typeface="Tahoma"/>
+                <a:ea typeface="Tahoma"/>
+                <a:cs typeface="Tahoma"/>
+              </a:rPr>
+              <a:t>0.8112</a:t>
+            </a:r>
+          </a:p>
+        </p:txBody>
+      </p:sp>
+      <p:sp>
+        <p:nvSpPr>
+          <p:cNvPr id="22" name="TextBox 21"/>
+          <p:cNvSpPr txBox="1"/>
+          <p:nvPr/>
+        </p:nvSpPr>
+        <p:spPr>
+          <a:xfrm>
+            <a:off x="4128144" y="2889504"/>
+            <a:ext cx="937136" cy="329184"/>
+          </a:xfrm>
+          <a:prstGeom prst="rect">
+            <a:avLst/>
+          </a:prstGeom>
+          <a:noFill/>
+        </p:spPr>
+        <p:txBody>
+          <a:bodyPr wrap="square" lIns="0" rIns="0" tIns="0" bIns="0" anchor="t">
+            <a:spAutoFit/>
+          </a:bodyPr>
+          <a:lstStyle/>
+          <a:p>
+            <a:pPr algn="ctr">
+              <a:lnSpc>
+                <a:spcPct val="100000"/>
+              </a:lnSpc>
+              <a:spcAft>
+                <a:spcPts val="0"/>
+              </a:spcAft>
+            </a:pPr>
+            <a:r>
+              <a:rPr sz="1300" b="1">
+                <a:solidFill>
+                  <a:srgbClr val="0F2038"/>
+                </a:solidFill>
+                <a:latin typeface="Tahoma"/>
+                <a:ea typeface="Tahoma"/>
+                <a:cs typeface="Tahoma"/>
+              </a:rPr>
+              <a:t>0.8344</a:t>
+            </a:r>
+          </a:p>
+        </p:txBody>
+      </p:sp>
+      <p:sp>
+        <p:nvSpPr>
+          <p:cNvPr id="23" name="TextBox 22"/>
+          <p:cNvSpPr txBox="1"/>
+          <p:nvPr/>
+        </p:nvSpPr>
+        <p:spPr>
+          <a:xfrm>
+            <a:off x="5284736" y="2889504"/>
+            <a:ext cx="1737854" cy="329184"/>
+          </a:xfrm>
+          <a:prstGeom prst="rect">
+            <a:avLst/>
+          </a:prstGeom>
+          <a:noFill/>
+        </p:spPr>
+        <p:txBody>
+          <a:bodyPr wrap="square" lIns="0" rIns="0" tIns="0" bIns="0" anchor="t">
+            <a:spAutoFit/>
+          </a:bodyPr>
+          <a:lstStyle/>
+          <a:p>
+            <a:pPr algn="ctr">
+              <a:lnSpc>
+                <a:spcPct val="100000"/>
+              </a:lnSpc>
+              <a:spcAft>
+                <a:spcPts val="0"/>
+              </a:spcAft>
+            </a:pPr>
+            <a:r>
+              <a:rPr sz="1300" b="0">
+                <a:solidFill>
+                  <a:srgbClr val="1F2C3D"/>
+                </a:solidFill>
+                <a:latin typeface="Tahoma"/>
+                <a:ea typeface="Tahoma"/>
+                <a:cs typeface="Tahoma"/>
+              </a:rPr>
+              <a:t>0.011 → 0.062</a:t>
+            </a:r>
+          </a:p>
+        </p:txBody>
+      </p:sp>
+      <p:sp>
+        <p:nvSpPr>
+          <p:cNvPr id="24" name="Rounded Rectangle 23"/>
           <p:cNvSpPr/>
           <p:nvPr/>
         </p:nvSpPr>
@@ -8258,7 +8698,7 @@
       </p:sp>
       <p:sp>
         <p:nvSpPr>
-          <p:cNvPr id="21" name="TextBox 20"/>
+          <p:cNvPr id="25" name="TextBox 24"/>
           <p:cNvSpPr txBox="1"/>
           <p:nvPr/>
         </p:nvSpPr>
@@ -8334,7 +8774,7 @@
       </p:sp>
       <p:sp>
         <p:nvSpPr>
-          <p:cNvPr id="22" name="TextBox 21"/>
+          <p:cNvPr id="26" name="TextBox 25"/>
           <p:cNvSpPr txBox="1"/>
           <p:nvPr/>
         </p:nvSpPr>
@@ -8399,7 +8839,7 @@
       </p:sp>
       <p:pic>
         <p:nvPicPr>
-          <p:cNvPr id="23" name="Picture 22" descr="7_validation_curve_rf_max_depth.png"/>
+          <p:cNvPr id="27" name="Picture 26" descr="7_validation_curve_rf_max_depth.png"/>
           <p:cNvPicPr>
             <a:picLocks noChangeAspect="1"/>
           </p:cNvPicPr>
@@ -8423,7 +8863,7 @@
       </p:pic>
       <p:sp>
         <p:nvSpPr>
-          <p:cNvPr id="24" name="TextBox 23"/>
+          <p:cNvPr id="28" name="TextBox 27"/>
           <p:cNvSpPr txBox="1"/>
           <p:nvPr/>
         </p:nvSpPr>
@@ -11085,7 +11525,7 @@
                 <a:ea typeface="Tahoma"/>
                 <a:cs typeface="Tahoma"/>
               </a:rPr>
-              <a:t>100%</a:t>
+              <a:t>99.8%</a:t>
             </a:r>
           </a:p>
         </p:txBody>
@@ -11264,7 +11704,7 @@
                 <a:ea typeface="Tahoma"/>
                 <a:cs typeface="Tahoma"/>
               </a:rPr>
-              <a:t>33.3%</a:t>
+              <a:t>25.9%</a:t>
             </a:r>
           </a:p>
         </p:txBody>
@@ -11443,7 +11883,7 @@
                 <a:ea typeface="Tahoma"/>
                 <a:cs typeface="Tahoma"/>
               </a:rPr>
-              <a:t>0.6%</a:t>
+              <a:t>1.0%</a:t>
             </a:r>
           </a:p>
         </p:txBody>
@@ -11643,7 +12083,7 @@
                 <a:ea typeface="Tahoma"/>
                 <a:cs typeface="Tahoma"/>
               </a:rPr>
-              <a:t>โมเดลบนเว็บเป็น Random Forest ฉบับย่อ 28.8 MB (F1 0.8376) แทนตัวเต็ม 356.8 MB เพราะข้อจำกัดด้านหน่วยความจำของบริการฟรี · ผลทำนายอิงข้อมูลโปรตุเกสปี 2015–2017</a:t>
+              <a:t>โมเดลบนเว็บใช้ HistGradientBoosting ขนาด 0.8 MB (F1 0.8334) แทน Random Forest 356.8 MB เพราะข้อจำกัดด้านหน่วยความจำของบริการฟรี · ผลทำนายอิงข้อมูลโปรตุเกสปี 2015–2017</a:t>
             </a:r>
           </a:p>
         </p:txBody>
@@ -19588,7 +20028,7 @@
                 <a:ea typeface="Tahoma"/>
                 <a:cs typeface="Tahoma"/>
               </a:rPr>
-              <a:t>0.8416 ± 0.0037</a:t>
+              <a:t>0.8103 ± 0.0049</a:t>
             </a:r>
           </a:p>
         </p:txBody>
@@ -19632,7 +20072,7 @@
                 <a:ea typeface="Tahoma"/>
                 <a:cs typeface="Tahoma"/>
               </a:rPr>
-              <a:t>0.9551</a:t>
+              <a:t>0.9420</a:t>
             </a:r>
           </a:p>
         </p:txBody>
@@ -19808,7 +20248,7 @@
                 <a:ea typeface="Tahoma"/>
                 <a:cs typeface="Tahoma"/>
               </a:rPr>
-              <a:t>0.8427 ± 0.0028</a:t>
+              <a:t>0.8127 ± 0.0042</a:t>
             </a:r>
           </a:p>
         </p:txBody>
@@ -19852,7 +20292,7 @@
                 <a:ea typeface="Tahoma"/>
                 <a:cs typeface="Tahoma"/>
               </a:rPr>
-              <a:t>0.9554</a:t>
+              <a:t>0.9428</a:t>
             </a:r>
           </a:p>
         </p:txBody>
@@ -20028,7 +20468,7 @@
                 <a:ea typeface="Tahoma"/>
                 <a:cs typeface="Tahoma"/>
               </a:rPr>
-              <a:t>0.8421 ± 0.0036</a:t>
+              <a:t>0.8112 ± 0.0027</a:t>
             </a:r>
           </a:p>
         </p:txBody>
@@ -20072,7 +20512,7 @@
                 <a:ea typeface="Tahoma"/>
                 <a:cs typeface="Tahoma"/>
               </a:rPr>
-              <a:t>0.9546</a:t>
+              <a:t>0.9417</a:t>
             </a:r>
           </a:p>
         </p:txBody>
@@ -20162,7 +20602,7 @@
                 <a:ea typeface="Tahoma"/>
                 <a:cs typeface="Tahoma"/>
               </a:rPr>
-              <a:t>ผลต่างระหว่าง B กับ C = 0.0006 </a:t>
+              <a:t>ผลต่างระหว่าง B กับ C = 0.0015 </a:t>
             </a:r>
             <a:r>
               <a:rPr sz="1400" b="0">
@@ -20173,7 +20613,7 @@
                 <a:ea typeface="Tahoma"/>
                 <a:cs typeface="Tahoma"/>
               </a:rPr>
-              <a:t>ซึ่งน้อยกว่าค่า std (0.0028)</a:t>
+              <a:t>ซึ่งน้อยกว่าค่า std (0.0042)</a:t>
             </a:r>
           </a:p>
           <a:p>
@@ -20194,7 +20634,7 @@
                 <a:ea typeface="Tahoma"/>
                 <a:cs typeface="Tahoma"/>
               </a:rPr>
-              <a:t>→ ไม่ต่างกันอย่างมีนัยสำคัญ แต่ C ใช้ feature ครึ่งเดียวและเทรนเร็วขึ้นเท่าตัว (8.7 vs 17.5 วินาที)</a:t>
+              <a:t>→ ถือว่าไม่ต่างกันอย่างมีนัยสำคัญ แต่ C มีความแปรปรวนต่ำที่สุดและเทรนเร็วที่สุด จึงเลือก C</a:t>
             </a:r>
           </a:p>
         </p:txBody>
@@ -20215,8 +20655,8 @@
         </p:blipFill>
         <p:spPr>
           <a:xfrm>
-            <a:off x="7589520" y="1991360"/>
-            <a:ext cx="4023360" cy="2235200"/>
+            <a:off x="7589520" y="2010029"/>
+            <a:ext cx="4023360" cy="2197862"/>
           </a:xfrm>
           <a:prstGeom prst="rect">
             <a:avLst/>

</xml_diff>

<commit_message>
Serve a reduced Random Forest on the web app
The report's best model is Random Forest, so the demo now runs the same
model type instead of HistGradientBoosting: 150 trees, max_depth 25,
min_samples_leaf 5 -> 28.8 MB, test F1 0.8376 at threshold 0.4754
(0.0093 below the full 356.8 MB forest).

HistGradientBoosting stays in the report and slides as one of the five
models compared. Deployment sections and demo examples updated.

Co-Authored-By: Claude Opus 5 <noreply@anthropic.com>
</commit_message>
<xml_diff>
--- a/slides/Hotel-Booking-Cancellation-Prediction.pptx
+++ b/slides/Hotel-Booking-Cancellation-Prediction.pptx
@@ -11525,7 +11525,7 @@
                 <a:ea typeface="Tahoma"/>
                 <a:cs typeface="Tahoma"/>
               </a:rPr>
-              <a:t>99.8%</a:t>
+              <a:t>100%</a:t>
             </a:r>
           </a:p>
         </p:txBody>
@@ -11704,7 +11704,7 @@
                 <a:ea typeface="Tahoma"/>
                 <a:cs typeface="Tahoma"/>
               </a:rPr>
-              <a:t>25.9%</a:t>
+              <a:t>33.3%</a:t>
             </a:r>
           </a:p>
         </p:txBody>
@@ -11883,7 +11883,7 @@
                 <a:ea typeface="Tahoma"/>
                 <a:cs typeface="Tahoma"/>
               </a:rPr>
-              <a:t>1.0%</a:t>
+              <a:t>0.6%</a:t>
             </a:r>
           </a:p>
         </p:txBody>
@@ -12083,7 +12083,7 @@
                 <a:ea typeface="Tahoma"/>
                 <a:cs typeface="Tahoma"/>
               </a:rPr>
-              <a:t>โมเดลบนเว็บใช้ HistGradientBoosting ขนาด 0.8 MB (F1 0.8334) แทน Random Forest 356.8 MB เพราะข้อจำกัดด้านหน่วยความจำของบริการฟรี · ผลทำนายอิงข้อมูลโปรตุเกสปี 2015–2017</a:t>
+              <a:t>โมเดลบนเว็บเป็น Random Forest ฉบับย่อ 28.8 MB (F1 0.8376) แทนตัวเต็ม 356.8 MB เพราะข้อจำกัดด้านหน่วยความจำของบริการฟรี · ผลทำนายอิงข้อมูลโปรตุเกสปี 2015–2017</a:t>
             </a:r>
           </a:p>
         </p:txBody>

</xml_diff>